<commit_message>
Added additional slides to the Powerpoint presentation
</commit_message>
<xml_diff>
--- a/presentations/GitHub_Introduction_I-AIR SEO.pptx
+++ b/presentations/GitHub_Introduction_I-AIR SEO.pptx
@@ -5,17 +5,18 @@
     <p:sldMasterId id="2147483648" r:id="rId1"/>
   </p:sldMasterIdLst>
   <p:notesMasterIdLst>
-    <p:notesMasterId r:id="rId10"/>
+    <p:notesMasterId r:id="rId11"/>
   </p:notesMasterIdLst>
   <p:sldIdLst>
     <p:sldId id="256" r:id="rId2"/>
     <p:sldId id="257" r:id="rId3"/>
     <p:sldId id="258" r:id="rId4"/>
-    <p:sldId id="259" r:id="rId5"/>
-    <p:sldId id="260" r:id="rId6"/>
-    <p:sldId id="261" r:id="rId7"/>
-    <p:sldId id="262" r:id="rId8"/>
-    <p:sldId id="263" r:id="rId9"/>
+    <p:sldId id="264" r:id="rId5"/>
+    <p:sldId id="259" r:id="rId6"/>
+    <p:sldId id="260" r:id="rId7"/>
+    <p:sldId id="261" r:id="rId8"/>
+    <p:sldId id="262" r:id="rId9"/>
+    <p:sldId id="263" r:id="rId10"/>
   </p:sldIdLst>
   <p:sldSz cx="9144000" cy="5143500" type="screen16x9"/>
   <p:notesSz cx="5143500" cy="9144000"/>
@@ -501,7 +502,13 @@
   <p:cSld>
     <p:spTree>
       <p:nvGrpSpPr>
-        <p:cNvPr id="1" name=""/>
+        <p:cNvPr id="1" name="">
+          <a:extLst>
+            <a:ext uri="{FF2B5EF4-FFF2-40B4-BE49-F238E27FC236}">
+              <a16:creationId xmlns:a16="http://schemas.microsoft.com/office/drawing/2014/main" id="{11A1D0D8-461D-7762-2E49-61A93FC06B4D}"/>
+            </a:ext>
+          </a:extLst>
+        </p:cNvPr>
         <p:cNvGrpSpPr/>
         <p:nvPr/>
       </p:nvGrpSpPr>
@@ -515,7 +522,13 @@
       </p:grpSpPr>
       <p:sp>
         <p:nvSpPr>
-          <p:cNvPr id="2" name="Slide Image Placeholder 1"/>
+          <p:cNvPr id="2" name="Slide Image Placeholder 1">
+            <a:extLst>
+              <a:ext uri="{FF2B5EF4-FFF2-40B4-BE49-F238E27FC236}">
+                <a16:creationId xmlns:a16="http://schemas.microsoft.com/office/drawing/2014/main" id="{916209D6-D018-6C7E-0B1F-CA77456C0043}"/>
+              </a:ext>
+            </a:extLst>
+          </p:cNvPr>
           <p:cNvSpPr>
             <a:spLocks noGrp="1" noRot="1" noChangeAspect="1"/>
           </p:cNvSpPr>
@@ -527,7 +540,13 @@
       </p:sp>
       <p:sp>
         <p:nvSpPr>
-          <p:cNvPr id="3" name="Notes Placeholder 2"/>
+          <p:cNvPr id="3" name="Notes Placeholder 2">
+            <a:extLst>
+              <a:ext uri="{FF2B5EF4-FFF2-40B4-BE49-F238E27FC236}">
+                <a16:creationId xmlns:a16="http://schemas.microsoft.com/office/drawing/2014/main" id="{C2F108C9-BCF3-38E6-8331-461695C61773}"/>
+              </a:ext>
+            </a:extLst>
+          </p:cNvPr>
           <p:cNvSpPr>
             <a:spLocks noGrp="1"/>
           </p:cNvSpPr>
@@ -546,7 +565,13 @@
       </p:sp>
       <p:sp>
         <p:nvSpPr>
-          <p:cNvPr id="4" name="Slide Number Placeholder 3"/>
+          <p:cNvPr id="4" name="Slide Number Placeholder 3">
+            <a:extLst>
+              <a:ext uri="{FF2B5EF4-FFF2-40B4-BE49-F238E27FC236}">
+                <a16:creationId xmlns:a16="http://schemas.microsoft.com/office/drawing/2014/main" id="{F027D655-CC61-3AA2-7714-E3BCFE67A199}"/>
+              </a:ext>
+            </a:extLst>
+          </p:cNvPr>
           <p:cNvSpPr>
             <a:spLocks noGrp="1"/>
           </p:cNvSpPr>
@@ -570,7 +595,7 @@
     </p:spTree>
     <p:extLst>
       <p:ext uri="{BB962C8B-B14F-4D97-AF65-F5344CB8AC3E}">
-        <p14:creationId xmlns:p14="http://schemas.microsoft.com/office/powerpoint/2010/main" val="1024086991"/>
+        <p14:creationId xmlns:p14="http://schemas.microsoft.com/office/powerpoint/2010/main" val="3969942519"/>
       </p:ext>
     </p:extLst>
   </p:cSld>
@@ -898,6 +923,90 @@
             <a:fld id="{F7021451-1387-4CA6-816F-3879F97B5CBC}" type="slidenum">
               <a:rPr lang="en-US"/>
               <a:t>8</a:t>
+            </a:fld>
+            <a:endParaRPr lang="en-US"/>
+          </a:p>
+        </p:txBody>
+      </p:sp>
+    </p:spTree>
+    <p:extLst>
+      <p:ext uri="{BB962C8B-B14F-4D97-AF65-F5344CB8AC3E}">
+        <p14:creationId xmlns:p14="http://schemas.microsoft.com/office/powerpoint/2010/main" val="1024086991"/>
+      </p:ext>
+    </p:extLst>
+  </p:cSld>
+  <p:clrMapOvr>
+    <a:masterClrMapping/>
+  </p:clrMapOvr>
+</p:notes>
+</file>
+
+<file path=ppt/notesSlides/notesSlide9.xml><?xml version="1.0" encoding="utf-8"?>
+<p:notes xmlns:a="http://schemas.openxmlformats.org/drawingml/2006/main" xmlns:r="http://schemas.openxmlformats.org/officeDocument/2006/relationships" xmlns:p="http://schemas.openxmlformats.org/presentationml/2006/main">
+  <p:cSld>
+    <p:spTree>
+      <p:nvGrpSpPr>
+        <p:cNvPr id="1" name=""/>
+        <p:cNvGrpSpPr/>
+        <p:nvPr/>
+      </p:nvGrpSpPr>
+      <p:grpSpPr>
+        <a:xfrm>
+          <a:off x="0" y="0"/>
+          <a:ext cx="0" cy="0"/>
+          <a:chOff x="0" y="0"/>
+          <a:chExt cx="0" cy="0"/>
+        </a:xfrm>
+      </p:grpSpPr>
+      <p:sp>
+        <p:nvSpPr>
+          <p:cNvPr id="2" name="Slide Image Placeholder 1"/>
+          <p:cNvSpPr>
+            <a:spLocks noGrp="1" noRot="1" noChangeAspect="1"/>
+          </p:cNvSpPr>
+          <p:nvPr>
+            <p:ph type="sldImg"/>
+          </p:nvPr>
+        </p:nvSpPr>
+        <p:spPr/>
+      </p:sp>
+      <p:sp>
+        <p:nvSpPr>
+          <p:cNvPr id="3" name="Notes Placeholder 2"/>
+          <p:cNvSpPr>
+            <a:spLocks noGrp="1"/>
+          </p:cNvSpPr>
+          <p:nvPr>
+            <p:ph type="body" idx="1"/>
+          </p:nvPr>
+        </p:nvSpPr>
+        <p:spPr/>
+        <p:txBody>
+          <a:bodyPr/>
+          <a:lstStyle/>
+          <a:p>
+            <a:endParaRPr lang="en-US" dirty="0"/>
+          </a:p>
+        </p:txBody>
+      </p:sp>
+      <p:sp>
+        <p:nvSpPr>
+          <p:cNvPr id="4" name="Slide Number Placeholder 3"/>
+          <p:cNvSpPr>
+            <a:spLocks noGrp="1"/>
+          </p:cNvSpPr>
+          <p:nvPr>
+            <p:ph type="sldNum" sz="quarter" idx="10"/>
+          </p:nvPr>
+        </p:nvSpPr>
+        <p:spPr/>
+        <p:txBody>
+          <a:bodyPr/>
+          <a:lstStyle/>
+          <a:p>
+            <a:fld id="{F7021451-1387-4CA6-816F-3879F97B5CBC}" type="slidenum">
+              <a:rPr lang="en-US"/>
+              <a:t>9</a:t>
             </a:fld>
             <a:endParaRPr lang="en-US"/>
           </a:p>
@@ -2450,7 +2559,7 @@
                   <a:srgbClr val="FFFFFF"/>
                 </a:solidFill>
               </a:rPr>
-              <a:t>WHAT IS IT?</a:t>
+              <a:t>COMMON USE CASES</a:t>
             </a:r>
             <a:endParaRPr lang="en-US" sz="800" dirty="0"/>
           </a:p>
@@ -2489,27 +2598,10 @@
                 <a:ea typeface="Trebuchet MS" pitchFamily="34" charset="-122"/>
                 <a:cs typeface="Trebuchet MS" pitchFamily="34" charset="-120"/>
               </a:rPr>
-              <a:t>Version control is a time machine</a:t>
+              <a:t>Data professionals can use software development practices.</a:t>
             </a:r>
             <a:endParaRPr lang="en-US" sz="3000" dirty="0"/>
           </a:p>
-          <a:p>
-            <a:pPr marL="0" indent="0">
-              <a:buNone/>
-            </a:pPr>
-            <a:r>
-              <a:rPr lang="en-US" sz="3000" b="1" dirty="0">
-                <a:solidFill>
-                  <a:srgbClr val="1E293B"/>
-                </a:solidFill>
-                <a:latin typeface="Trebuchet MS" pitchFamily="34" charset="0"/>
-                <a:ea typeface="Trebuchet MS" pitchFamily="34" charset="-122"/>
-                <a:cs typeface="Trebuchet MS" pitchFamily="34" charset="-120"/>
-              </a:rPr>
-              <a:t>for your work.</a:t>
-            </a:r>
-            <a:endParaRPr lang="en-US" sz="3000" dirty="0"/>
-          </a:p>
         </p:txBody>
       </p:sp>
       <p:sp>
@@ -2520,7 +2612,7 @@
         </p:nvSpPr>
         <p:spPr>
           <a:xfrm>
-            <a:off x="457200" y="1783080"/>
+            <a:off x="457200" y="2337480"/>
             <a:ext cx="3977640" cy="1325880"/>
           </a:xfrm>
           <a:prstGeom prst="rect">
@@ -2559,18 +2651,18 @@
         </p:nvSpPr>
         <p:spPr>
           <a:xfrm>
-            <a:off x="457200" y="1783080"/>
+            <a:off x="457200" y="2337480"/>
             <a:ext cx="73152" cy="1325880"/>
           </a:xfrm>
           <a:prstGeom prst="rect">
             <a:avLst/>
           </a:prstGeom>
           <a:solidFill>
-            <a:srgbClr val="0D9488"/>
+            <a:srgbClr val="002060"/>
           </a:solidFill>
           <a:ln w="12700">
             <a:solidFill>
-              <a:srgbClr val="0D9488"/>
+              <a:srgbClr val="002060"/>
             </a:solidFill>
             <a:prstDash val="solid"/>
           </a:ln>
@@ -2583,30 +2675,6 @@
           </a:p>
         </p:txBody>
       </p:sp>
-      <p:pic>
-        <p:nvPicPr>
-          <p:cNvPr id="7" name="Image 0" descr="preencoded.png"/>
-          <p:cNvPicPr>
-            <a:picLocks noChangeAspect="1"/>
-          </p:cNvPicPr>
-          <p:nvPr/>
-        </p:nvPicPr>
-        <p:blipFill>
-          <a:blip r:embed="rId3"/>
-          <a:stretch>
-            <a:fillRect/>
-          </a:stretch>
-        </p:blipFill>
-        <p:spPr>
-          <a:xfrm>
-            <a:off x="621792" y="2194560"/>
-            <a:ext cx="411480" cy="411480"/>
-          </a:xfrm>
-          <a:prstGeom prst="rect">
-            <a:avLst/>
-          </a:prstGeom>
-        </p:spPr>
-      </p:pic>
       <p:sp>
         <p:nvSpPr>
           <p:cNvPr id="8" name="Text 5"/>
@@ -2615,7 +2683,7 @@
         </p:nvSpPr>
         <p:spPr>
           <a:xfrm>
-            <a:off x="1143000" y="1920240"/>
+            <a:off x="797400" y="2474640"/>
             <a:ext cx="3200400" cy="365760"/>
           </a:xfrm>
           <a:prstGeom prst="rect">
@@ -2637,10 +2705,8 @@
                   <a:srgbClr val="1E293B"/>
                 </a:solidFill>
                 <a:latin typeface="Trebuchet MS" pitchFamily="34" charset="0"/>
-                <a:ea typeface="Trebuchet MS" pitchFamily="34" charset="-122"/>
-                <a:cs typeface="Trebuchet MS" pitchFamily="34" charset="-120"/>
-              </a:rPr>
-              <a:t>Full History</a:t>
+              </a:rPr>
+              <a:t>Dashboard Development</a:t>
             </a:r>
             <a:endParaRPr lang="en-US" sz="1500" dirty="0"/>
           </a:p>
@@ -2654,7 +2720,7 @@
         </p:nvSpPr>
         <p:spPr>
           <a:xfrm>
-            <a:off x="1143000" y="2286000"/>
+            <a:off x="819000" y="2840400"/>
             <a:ext cx="3200400" cy="685800"/>
           </a:xfrm>
           <a:prstGeom prst="rect">
@@ -2679,7 +2745,7 @@
                 <a:ea typeface="Calibri" pitchFamily="34" charset="-122"/>
                 <a:cs typeface="Calibri" pitchFamily="34" charset="-120"/>
               </a:rPr>
-              <a:t>Every change ever made is saved with who made it and why.</a:t>
+              <a:t>Developing dashboards IS software development even when it is low-code (Tableau/Power BI).</a:t>
             </a:r>
             <a:endParaRPr lang="en-US" sz="1200" dirty="0"/>
           </a:p>
@@ -2693,7 +2759,7 @@
         </p:nvSpPr>
         <p:spPr>
           <a:xfrm>
-            <a:off x="4754880" y="1783080"/>
+            <a:off x="4754880" y="2337480"/>
             <a:ext cx="3977640" cy="1325880"/>
           </a:xfrm>
           <a:prstGeom prst="rect">
@@ -2732,8 +2798,183 @@
         </p:nvSpPr>
         <p:spPr>
           <a:xfrm>
-            <a:off x="4754880" y="1783080"/>
+            <a:off x="4754880" y="2337480"/>
             <a:ext cx="73152" cy="1325880"/>
+          </a:xfrm>
+          <a:prstGeom prst="rect">
+            <a:avLst/>
+          </a:prstGeom>
+          <a:solidFill>
+            <a:srgbClr val="002060"/>
+          </a:solidFill>
+          <a:ln w="12700">
+            <a:solidFill>
+              <a:srgbClr val="002060"/>
+            </a:solidFill>
+            <a:prstDash val="solid"/>
+          </a:ln>
+        </p:spPr>
+        <p:txBody>
+          <a:bodyPr/>
+          <a:lstStyle/>
+          <a:p>
+            <a:endParaRPr lang="en-US"/>
+          </a:p>
+        </p:txBody>
+      </p:sp>
+      <p:sp>
+        <p:nvSpPr>
+          <p:cNvPr id="13" name="Text 9"/>
+          <p:cNvSpPr/>
+          <p:nvPr/>
+        </p:nvSpPr>
+        <p:spPr>
+          <a:xfrm>
+            <a:off x="5124600" y="2474640"/>
+            <a:ext cx="3200400" cy="365760"/>
+          </a:xfrm>
+          <a:prstGeom prst="rect">
+            <a:avLst/>
+          </a:prstGeom>
+          <a:noFill/>
+          <a:ln/>
+        </p:spPr>
+        <p:txBody>
+          <a:bodyPr wrap="square" lIns="0" tIns="0" rIns="0" bIns="0" rtlCol="0" anchor="ctr"/>
+          <a:lstStyle/>
+          <a:p>
+            <a:pPr marL="0" indent="0">
+              <a:buNone/>
+            </a:pPr>
+            <a:r>
+              <a:rPr lang="en-US" sz="1500" b="1" dirty="0">
+                <a:solidFill>
+                  <a:srgbClr val="1E293B"/>
+                </a:solidFill>
+                <a:latin typeface="Trebuchet MS" pitchFamily="34" charset="0"/>
+              </a:rPr>
+              <a:t>Pipelines</a:t>
+            </a:r>
+            <a:endParaRPr lang="en-US" sz="1500" dirty="0"/>
+          </a:p>
+        </p:txBody>
+      </p:sp>
+      <p:sp>
+        <p:nvSpPr>
+          <p:cNvPr id="14" name="Text 10"/>
+          <p:cNvSpPr/>
+          <p:nvPr/>
+        </p:nvSpPr>
+        <p:spPr>
+          <a:xfrm>
+            <a:off x="5124600" y="2817540"/>
+            <a:ext cx="3200400" cy="685800"/>
+          </a:xfrm>
+          <a:prstGeom prst="rect">
+            <a:avLst/>
+          </a:prstGeom>
+          <a:noFill/>
+          <a:ln/>
+        </p:spPr>
+        <p:txBody>
+          <a:bodyPr wrap="square" lIns="0" tIns="0" rIns="0" bIns="0" rtlCol="0" anchor="ctr"/>
+          <a:lstStyle/>
+          <a:p>
+            <a:pPr marL="0" indent="0">
+              <a:buNone/>
+            </a:pPr>
+            <a:r>
+              <a:rPr lang="en-US" sz="1200" dirty="0">
+                <a:solidFill>
+                  <a:srgbClr val="475569"/>
+                </a:solidFill>
+                <a:latin typeface="Calibri" pitchFamily="34" charset="0"/>
+                <a:ea typeface="Calibri" pitchFamily="34" charset="-122"/>
+                <a:cs typeface="Calibri" pitchFamily="34" charset="-120"/>
+              </a:rPr>
+              <a:t>All parts of a process can be grouped together in one repository (SQL, Python, SSIS, SAS, </a:t>
+            </a:r>
+            <a:r>
+              <a:rPr lang="en-US" sz="1200" dirty="0" err="1">
+                <a:solidFill>
+                  <a:srgbClr val="475569"/>
+                </a:solidFill>
+                <a:latin typeface="Calibri" pitchFamily="34" charset="0"/>
+                <a:ea typeface="Calibri" pitchFamily="34" charset="-122"/>
+                <a:cs typeface="Calibri" pitchFamily="34" charset="-120"/>
+              </a:rPr>
+              <a:t>etc</a:t>
+            </a:r>
+            <a:r>
+              <a:rPr lang="en-US" sz="1200" dirty="0">
+                <a:solidFill>
+                  <a:srgbClr val="475569"/>
+                </a:solidFill>
+                <a:latin typeface="Calibri" pitchFamily="34" charset="0"/>
+                <a:ea typeface="Calibri" pitchFamily="34" charset="-122"/>
+                <a:cs typeface="Calibri" pitchFamily="34" charset="-120"/>
+              </a:rPr>
+              <a:t>).</a:t>
+            </a:r>
+            <a:endParaRPr lang="en-US" sz="1200" dirty="0"/>
+          </a:p>
+        </p:txBody>
+      </p:sp>
+    </p:spTree>
+  </p:cSld>
+  <p:clrMapOvr>
+    <a:masterClrMapping/>
+  </p:clrMapOvr>
+</p:sld>
+</file>
+
+<file path=ppt/slides/slide4.xml><?xml version="1.0" encoding="utf-8"?>
+<p:sld xmlns:a="http://schemas.openxmlformats.org/drawingml/2006/main" xmlns:r="http://schemas.openxmlformats.org/officeDocument/2006/relationships" xmlns:p="http://schemas.openxmlformats.org/presentationml/2006/main">
+  <p:cSld>
+    <p:bg>
+      <p:bgPr>
+        <a:solidFill>
+          <a:srgbClr val="F8FAFC"/>
+        </a:solidFill>
+        <a:effectLst/>
+      </p:bgPr>
+    </p:bg>
+    <p:spTree>
+      <p:nvGrpSpPr>
+        <p:cNvPr id="1" name="">
+          <a:extLst>
+            <a:ext uri="{FF2B5EF4-FFF2-40B4-BE49-F238E27FC236}">
+              <a16:creationId xmlns:a16="http://schemas.microsoft.com/office/drawing/2014/main" id="{1C55B3A8-BE19-98E6-E39A-D8238B9BF7F4}"/>
+            </a:ext>
+          </a:extLst>
+        </p:cNvPr>
+        <p:cNvGrpSpPr/>
+        <p:nvPr/>
+      </p:nvGrpSpPr>
+      <p:grpSpPr>
+        <a:xfrm>
+          <a:off x="0" y="0"/>
+          <a:ext cx="0" cy="0"/>
+          <a:chOff x="0" y="0"/>
+          <a:chExt cx="0" cy="0"/>
+        </a:xfrm>
+      </p:grpSpPr>
+      <p:sp>
+        <p:nvSpPr>
+          <p:cNvPr id="2" name="Shape 0">
+            <a:extLst>
+              <a:ext uri="{FF2B5EF4-FFF2-40B4-BE49-F238E27FC236}">
+                <a16:creationId xmlns:a16="http://schemas.microsoft.com/office/drawing/2014/main" id="{FE12E256-99B6-8A7B-8D98-8A313B3ED66B}"/>
+              </a:ext>
+            </a:extLst>
+          </p:cNvPr>
+          <p:cNvSpPr/>
+          <p:nvPr/>
+        </p:nvSpPr>
+        <p:spPr>
+          <a:xfrm>
+            <a:off x="457200" y="256032"/>
+            <a:ext cx="1645920" cy="256032"/>
           </a:xfrm>
           <a:prstGeom prst="rect">
             <a:avLst/>
@@ -2756,40 +2997,22 @@
           </a:p>
         </p:txBody>
       </p:sp>
-      <p:pic>
-        <p:nvPicPr>
-          <p:cNvPr id="12" name="Image 1" descr="preencoded.png"/>
-          <p:cNvPicPr>
-            <a:picLocks noChangeAspect="1"/>
-          </p:cNvPicPr>
-          <p:nvPr/>
-        </p:nvPicPr>
-        <p:blipFill>
-          <a:blip r:embed="rId4"/>
-          <a:stretch>
-            <a:fillRect/>
-          </a:stretch>
-        </p:blipFill>
-        <p:spPr>
-          <a:xfrm>
-            <a:off x="4919472" y="2194560"/>
-            <a:ext cx="411480" cy="411480"/>
-          </a:xfrm>
-          <a:prstGeom prst="rect">
-            <a:avLst/>
-          </a:prstGeom>
-        </p:spPr>
-      </p:pic>
-      <p:sp>
-        <p:nvSpPr>
-          <p:cNvPr id="13" name="Text 9"/>
-          <p:cNvSpPr/>
-          <p:nvPr/>
-        </p:nvSpPr>
-        <p:spPr>
-          <a:xfrm>
-            <a:off x="5440680" y="1920240"/>
-            <a:ext cx="3200400" cy="365760"/>
+      <p:sp>
+        <p:nvSpPr>
+          <p:cNvPr id="3" name="Text 1">
+            <a:extLst>
+              <a:ext uri="{FF2B5EF4-FFF2-40B4-BE49-F238E27FC236}">
+                <a16:creationId xmlns:a16="http://schemas.microsoft.com/office/drawing/2014/main" id="{A541EC5E-65A3-64E4-7830-3F028FA5EDDC}"/>
+              </a:ext>
+            </a:extLst>
+          </p:cNvPr>
+          <p:cNvSpPr/>
+          <p:nvPr/>
+        </p:nvSpPr>
+        <p:spPr>
+          <a:xfrm>
+            <a:off x="457200" y="256032"/>
+            <a:ext cx="1645920" cy="256032"/>
           </a:xfrm>
           <a:prstGeom prst="rect">
             <a:avLst/>
@@ -2801,11 +3024,53 @@
           <a:bodyPr wrap="square" lIns="0" tIns="0" rIns="0" bIns="0" rtlCol="0" anchor="ctr"/>
           <a:lstStyle/>
           <a:p>
+            <a:pPr marL="0" indent="0" algn="ctr">
+              <a:buNone/>
+            </a:pPr>
+            <a:r>
+              <a:rPr lang="en-US" sz="800" b="1" dirty="0">
+                <a:solidFill>
+                  <a:srgbClr val="FFFFFF"/>
+                </a:solidFill>
+              </a:rPr>
+              <a:t>WHAT IS IT?</a:t>
+            </a:r>
+            <a:endParaRPr lang="en-US" sz="800" dirty="0"/>
+          </a:p>
+        </p:txBody>
+      </p:sp>
+      <p:sp>
+        <p:nvSpPr>
+          <p:cNvPr id="4" name="Text 2">
+            <a:extLst>
+              <a:ext uri="{FF2B5EF4-FFF2-40B4-BE49-F238E27FC236}">
+                <a16:creationId xmlns:a16="http://schemas.microsoft.com/office/drawing/2014/main" id="{541C49B6-7E0A-0B00-1DBF-88D316D4BB90}"/>
+              </a:ext>
+            </a:extLst>
+          </p:cNvPr>
+          <p:cNvSpPr/>
+          <p:nvPr/>
+        </p:nvSpPr>
+        <p:spPr>
+          <a:xfrm>
+            <a:off x="457200" y="594360"/>
+            <a:ext cx="8229600" cy="1005840"/>
+          </a:xfrm>
+          <a:prstGeom prst="rect">
+            <a:avLst/>
+          </a:prstGeom>
+          <a:noFill/>
+          <a:ln/>
+        </p:spPr>
+        <p:txBody>
+          <a:bodyPr wrap="square" rtlCol="0" anchor="ctr"/>
+          <a:lstStyle/>
+          <a:p>
             <a:pPr marL="0" indent="0">
               <a:buNone/>
             </a:pPr>
             <a:r>
-              <a:rPr lang="en-US" sz="1500" b="1" dirty="0">
+              <a:rPr lang="en-US" sz="3000" b="1" dirty="0">
                 <a:solidFill>
                   <a:srgbClr val="1E293B"/>
                 </a:solidFill>
@@ -2813,60 +3078,44 @@
                 <a:ea typeface="Trebuchet MS" pitchFamily="34" charset="-122"/>
                 <a:cs typeface="Trebuchet MS" pitchFamily="34" charset="-120"/>
               </a:rPr>
-              <a:t>Time Travel</a:t>
-            </a:r>
-            <a:endParaRPr lang="en-US" sz="1500" dirty="0"/>
-          </a:p>
-        </p:txBody>
-      </p:sp>
-      <p:sp>
-        <p:nvSpPr>
-          <p:cNvPr id="14" name="Text 10"/>
-          <p:cNvSpPr/>
-          <p:nvPr/>
-        </p:nvSpPr>
-        <p:spPr>
-          <a:xfrm>
-            <a:off x="5440680" y="2286000"/>
-            <a:ext cx="3200400" cy="685800"/>
-          </a:xfrm>
-          <a:prstGeom prst="rect">
-            <a:avLst/>
-          </a:prstGeom>
-          <a:noFill/>
-          <a:ln/>
-        </p:spPr>
-        <p:txBody>
-          <a:bodyPr wrap="square" lIns="0" tIns="0" rIns="0" bIns="0" rtlCol="0" anchor="ctr"/>
-          <a:lstStyle/>
+              <a:t>Version control is a time machine</a:t>
+            </a:r>
+            <a:endParaRPr lang="en-US" sz="3000" dirty="0"/>
+          </a:p>
           <a:p>
             <a:pPr marL="0" indent="0">
               <a:buNone/>
             </a:pPr>
             <a:r>
-              <a:rPr lang="en-US" sz="1200" dirty="0">
-                <a:solidFill>
-                  <a:srgbClr val="475569"/>
-                </a:solidFill>
-                <a:latin typeface="Calibri" pitchFamily="34" charset="0"/>
-                <a:ea typeface="Calibri" pitchFamily="34" charset="-122"/>
-                <a:cs typeface="Calibri" pitchFamily="34" charset="-120"/>
-              </a:rPr>
-              <a:t>Revert any file — or the whole project — to any past state.</a:t>
-            </a:r>
-            <a:endParaRPr lang="en-US" sz="1200" dirty="0"/>
-          </a:p>
-        </p:txBody>
-      </p:sp>
-      <p:sp>
-        <p:nvSpPr>
-          <p:cNvPr id="15" name="Shape 11"/>
-          <p:cNvSpPr/>
-          <p:nvPr/>
-        </p:nvSpPr>
-        <p:spPr>
-          <a:xfrm>
-            <a:off x="457200" y="3291840"/>
+              <a:rPr lang="en-US" sz="3000" b="1" dirty="0">
+                <a:solidFill>
+                  <a:srgbClr val="1E293B"/>
+                </a:solidFill>
+                <a:latin typeface="Trebuchet MS" pitchFamily="34" charset="0"/>
+                <a:ea typeface="Trebuchet MS" pitchFamily="34" charset="-122"/>
+                <a:cs typeface="Trebuchet MS" pitchFamily="34" charset="-120"/>
+              </a:rPr>
+              <a:t>for your work.</a:t>
+            </a:r>
+            <a:endParaRPr lang="en-US" sz="3000" dirty="0"/>
+          </a:p>
+        </p:txBody>
+      </p:sp>
+      <p:sp>
+        <p:nvSpPr>
+          <p:cNvPr id="5" name="Shape 3">
+            <a:extLst>
+              <a:ext uri="{FF2B5EF4-FFF2-40B4-BE49-F238E27FC236}">
+                <a16:creationId xmlns:a16="http://schemas.microsoft.com/office/drawing/2014/main" id="{95F6549C-19FE-D15C-A4DB-0A22CC2E7FB8}"/>
+              </a:ext>
+            </a:extLst>
+          </p:cNvPr>
+          <p:cNvSpPr/>
+          <p:nvPr/>
+        </p:nvSpPr>
+        <p:spPr>
+          <a:xfrm>
+            <a:off x="457200" y="1783080"/>
             <a:ext cx="3977640" cy="1325880"/>
           </a:xfrm>
           <a:prstGeom prst="rect">
@@ -2899,13 +3148,19 @@
       </p:sp>
       <p:sp>
         <p:nvSpPr>
-          <p:cNvPr id="16" name="Shape 12"/>
-          <p:cNvSpPr/>
-          <p:nvPr/>
-        </p:nvSpPr>
-        <p:spPr>
-          <a:xfrm>
-            <a:off x="457200" y="3291840"/>
+          <p:cNvPr id="6" name="Shape 4">
+            <a:extLst>
+              <a:ext uri="{FF2B5EF4-FFF2-40B4-BE49-F238E27FC236}">
+                <a16:creationId xmlns:a16="http://schemas.microsoft.com/office/drawing/2014/main" id="{764B647A-A297-3CDE-015A-C70C41DFB9DE}"/>
+              </a:ext>
+            </a:extLst>
+          </p:cNvPr>
+          <p:cNvSpPr/>
+          <p:nvPr/>
+        </p:nvSpPr>
+        <p:spPr>
+          <a:xfrm>
+            <a:off x="457200" y="1783080"/>
             <a:ext cx="73152" cy="1325880"/>
           </a:xfrm>
           <a:prstGeom prst="rect">
@@ -2931,21 +3186,27 @@
       </p:sp>
       <p:pic>
         <p:nvPicPr>
-          <p:cNvPr id="17" name="Image 2" descr="preencoded.png"/>
+          <p:cNvPr id="7" name="Image 0" descr="preencoded.png">
+            <a:extLst>
+              <a:ext uri="{FF2B5EF4-FFF2-40B4-BE49-F238E27FC236}">
+                <a16:creationId xmlns:a16="http://schemas.microsoft.com/office/drawing/2014/main" id="{81920E2E-9286-FBC6-617A-E66FE9C744F5}"/>
+              </a:ext>
+            </a:extLst>
+          </p:cNvPr>
           <p:cNvPicPr>
             <a:picLocks noChangeAspect="1"/>
           </p:cNvPicPr>
           <p:nvPr/>
         </p:nvPicPr>
         <p:blipFill>
-          <a:blip r:embed="rId5"/>
+          <a:blip r:embed="rId3"/>
           <a:stretch>
             <a:fillRect/>
           </a:stretch>
         </p:blipFill>
         <p:spPr>
           <a:xfrm>
-            <a:off x="621792" y="3703320"/>
+            <a:off x="621792" y="2194560"/>
             <a:ext cx="411480" cy="411480"/>
           </a:xfrm>
           <a:prstGeom prst="rect">
@@ -2955,13 +3216,19 @@
       </p:pic>
       <p:sp>
         <p:nvSpPr>
-          <p:cNvPr id="18" name="Text 13"/>
-          <p:cNvSpPr/>
-          <p:nvPr/>
-        </p:nvSpPr>
-        <p:spPr>
-          <a:xfrm>
-            <a:off x="1143000" y="3429000"/>
+          <p:cNvPr id="8" name="Text 5">
+            <a:extLst>
+              <a:ext uri="{FF2B5EF4-FFF2-40B4-BE49-F238E27FC236}">
+                <a16:creationId xmlns:a16="http://schemas.microsoft.com/office/drawing/2014/main" id="{FFA6DA9D-8A6E-9025-716E-EB64A58C3AF9}"/>
+              </a:ext>
+            </a:extLst>
+          </p:cNvPr>
+          <p:cNvSpPr/>
+          <p:nvPr/>
+        </p:nvSpPr>
+        <p:spPr>
+          <a:xfrm>
+            <a:off x="1143000" y="1920240"/>
             <a:ext cx="3200400" cy="365760"/>
           </a:xfrm>
           <a:prstGeom prst="rect">
@@ -2986,7 +3253,7 @@
                 <a:ea typeface="Trebuchet MS" pitchFamily="34" charset="-122"/>
                 <a:cs typeface="Trebuchet MS" pitchFamily="34" charset="-120"/>
               </a:rPr>
-              <a:t>Compare</a:t>
+              <a:t>Full History</a:t>
             </a:r>
             <a:endParaRPr lang="en-US" sz="1500" dirty="0"/>
           </a:p>
@@ -2994,13 +3261,19 @@
       </p:sp>
       <p:sp>
         <p:nvSpPr>
-          <p:cNvPr id="19" name="Text 14"/>
-          <p:cNvSpPr/>
-          <p:nvPr/>
-        </p:nvSpPr>
-        <p:spPr>
-          <a:xfrm>
-            <a:off x="1143000" y="3794760"/>
+          <p:cNvPr id="9" name="Text 6">
+            <a:extLst>
+              <a:ext uri="{FF2B5EF4-FFF2-40B4-BE49-F238E27FC236}">
+                <a16:creationId xmlns:a16="http://schemas.microsoft.com/office/drawing/2014/main" id="{B10068CC-BFCA-2C2B-B402-EC6333C5453E}"/>
+              </a:ext>
+            </a:extLst>
+          </p:cNvPr>
+          <p:cNvSpPr/>
+          <p:nvPr/>
+        </p:nvSpPr>
+        <p:spPr>
+          <a:xfrm>
+            <a:off x="1143000" y="2286000"/>
             <a:ext cx="3200400" cy="685800"/>
           </a:xfrm>
           <a:prstGeom prst="rect">
@@ -3025,7 +3298,7 @@
                 <a:ea typeface="Calibri" pitchFamily="34" charset="-122"/>
                 <a:cs typeface="Calibri" pitchFamily="34" charset="-120"/>
               </a:rPr>
-              <a:t>See exactly what changed between any two versions, line by line.</a:t>
+              <a:t>Every change ever made is saved with who made it and why.</a:t>
             </a:r>
             <a:endParaRPr lang="en-US" sz="1200" dirty="0"/>
           </a:p>
@@ -3033,13 +3306,19 @@
       </p:sp>
       <p:sp>
         <p:nvSpPr>
-          <p:cNvPr id="20" name="Shape 15"/>
-          <p:cNvSpPr/>
-          <p:nvPr/>
-        </p:nvSpPr>
-        <p:spPr>
-          <a:xfrm>
-            <a:off x="4754880" y="3291840"/>
+          <p:cNvPr id="10" name="Shape 7">
+            <a:extLst>
+              <a:ext uri="{FF2B5EF4-FFF2-40B4-BE49-F238E27FC236}">
+                <a16:creationId xmlns:a16="http://schemas.microsoft.com/office/drawing/2014/main" id="{480BCAFE-981B-4372-3BB3-30B18BCF5509}"/>
+              </a:ext>
+            </a:extLst>
+          </p:cNvPr>
+          <p:cNvSpPr/>
+          <p:nvPr/>
+        </p:nvSpPr>
+        <p:spPr>
+          <a:xfrm>
+            <a:off x="4754880" y="1783080"/>
             <a:ext cx="3977640" cy="1325880"/>
           </a:xfrm>
           <a:prstGeom prst="rect">
@@ -3072,13 +3351,19 @@
       </p:sp>
       <p:sp>
         <p:nvSpPr>
-          <p:cNvPr id="21" name="Shape 16"/>
-          <p:cNvSpPr/>
-          <p:nvPr/>
-        </p:nvSpPr>
-        <p:spPr>
-          <a:xfrm>
-            <a:off x="4754880" y="3291840"/>
+          <p:cNvPr id="11" name="Shape 8">
+            <a:extLst>
+              <a:ext uri="{FF2B5EF4-FFF2-40B4-BE49-F238E27FC236}">
+                <a16:creationId xmlns:a16="http://schemas.microsoft.com/office/drawing/2014/main" id="{34C63141-EAEB-74CC-51A8-411C692E0ECE}"/>
+              </a:ext>
+            </a:extLst>
+          </p:cNvPr>
+          <p:cNvSpPr/>
+          <p:nvPr/>
+        </p:nvSpPr>
+        <p:spPr>
+          <a:xfrm>
+            <a:off x="4754880" y="1783080"/>
             <a:ext cx="73152" cy="1325880"/>
           </a:xfrm>
           <a:prstGeom prst="rect">
@@ -3104,7 +3389,419 @@
       </p:sp>
       <p:pic>
         <p:nvPicPr>
-          <p:cNvPr id="22" name="Image 3" descr="preencoded.png"/>
+          <p:cNvPr id="12" name="Image 1" descr="preencoded.png">
+            <a:extLst>
+              <a:ext uri="{FF2B5EF4-FFF2-40B4-BE49-F238E27FC236}">
+                <a16:creationId xmlns:a16="http://schemas.microsoft.com/office/drawing/2014/main" id="{CD19921E-2453-D73F-679E-6D2AA05241F2}"/>
+              </a:ext>
+            </a:extLst>
+          </p:cNvPr>
+          <p:cNvPicPr>
+            <a:picLocks noChangeAspect="1"/>
+          </p:cNvPicPr>
+          <p:nvPr/>
+        </p:nvPicPr>
+        <p:blipFill>
+          <a:blip r:embed="rId4"/>
+          <a:stretch>
+            <a:fillRect/>
+          </a:stretch>
+        </p:blipFill>
+        <p:spPr>
+          <a:xfrm>
+            <a:off x="4919472" y="2194560"/>
+            <a:ext cx="411480" cy="411480"/>
+          </a:xfrm>
+          <a:prstGeom prst="rect">
+            <a:avLst/>
+          </a:prstGeom>
+        </p:spPr>
+      </p:pic>
+      <p:sp>
+        <p:nvSpPr>
+          <p:cNvPr id="13" name="Text 9">
+            <a:extLst>
+              <a:ext uri="{FF2B5EF4-FFF2-40B4-BE49-F238E27FC236}">
+                <a16:creationId xmlns:a16="http://schemas.microsoft.com/office/drawing/2014/main" id="{93C9689F-30C3-6A12-2043-CEC5EFC08102}"/>
+              </a:ext>
+            </a:extLst>
+          </p:cNvPr>
+          <p:cNvSpPr/>
+          <p:nvPr/>
+        </p:nvSpPr>
+        <p:spPr>
+          <a:xfrm>
+            <a:off x="5440680" y="1920240"/>
+            <a:ext cx="3200400" cy="365760"/>
+          </a:xfrm>
+          <a:prstGeom prst="rect">
+            <a:avLst/>
+          </a:prstGeom>
+          <a:noFill/>
+          <a:ln/>
+        </p:spPr>
+        <p:txBody>
+          <a:bodyPr wrap="square" lIns="0" tIns="0" rIns="0" bIns="0" rtlCol="0" anchor="ctr"/>
+          <a:lstStyle/>
+          <a:p>
+            <a:pPr marL="0" indent="0">
+              <a:buNone/>
+            </a:pPr>
+            <a:r>
+              <a:rPr lang="en-US" sz="1500" b="1" dirty="0">
+                <a:solidFill>
+                  <a:srgbClr val="1E293B"/>
+                </a:solidFill>
+                <a:latin typeface="Trebuchet MS" pitchFamily="34" charset="0"/>
+                <a:ea typeface="Trebuchet MS" pitchFamily="34" charset="-122"/>
+                <a:cs typeface="Trebuchet MS" pitchFamily="34" charset="-120"/>
+              </a:rPr>
+              <a:t>Time Travel</a:t>
+            </a:r>
+            <a:endParaRPr lang="en-US" sz="1500" dirty="0"/>
+          </a:p>
+        </p:txBody>
+      </p:sp>
+      <p:sp>
+        <p:nvSpPr>
+          <p:cNvPr id="14" name="Text 10">
+            <a:extLst>
+              <a:ext uri="{FF2B5EF4-FFF2-40B4-BE49-F238E27FC236}">
+                <a16:creationId xmlns:a16="http://schemas.microsoft.com/office/drawing/2014/main" id="{C3F008AB-BB34-3ACD-00A4-7ADE5502D014}"/>
+              </a:ext>
+            </a:extLst>
+          </p:cNvPr>
+          <p:cNvSpPr/>
+          <p:nvPr/>
+        </p:nvSpPr>
+        <p:spPr>
+          <a:xfrm>
+            <a:off x="5440680" y="2286000"/>
+            <a:ext cx="3200400" cy="685800"/>
+          </a:xfrm>
+          <a:prstGeom prst="rect">
+            <a:avLst/>
+          </a:prstGeom>
+          <a:noFill/>
+          <a:ln/>
+        </p:spPr>
+        <p:txBody>
+          <a:bodyPr wrap="square" lIns="0" tIns="0" rIns="0" bIns="0" rtlCol="0" anchor="ctr"/>
+          <a:lstStyle/>
+          <a:p>
+            <a:pPr marL="0" indent="0">
+              <a:buNone/>
+            </a:pPr>
+            <a:r>
+              <a:rPr lang="en-US" sz="1200" dirty="0">
+                <a:solidFill>
+                  <a:srgbClr val="475569"/>
+                </a:solidFill>
+                <a:latin typeface="Calibri" pitchFamily="34" charset="0"/>
+                <a:ea typeface="Calibri" pitchFamily="34" charset="-122"/>
+                <a:cs typeface="Calibri" pitchFamily="34" charset="-120"/>
+              </a:rPr>
+              <a:t>Revert any file — or the whole project — to any past state.</a:t>
+            </a:r>
+            <a:endParaRPr lang="en-US" sz="1200" dirty="0"/>
+          </a:p>
+        </p:txBody>
+      </p:sp>
+      <p:sp>
+        <p:nvSpPr>
+          <p:cNvPr id="15" name="Shape 11">
+            <a:extLst>
+              <a:ext uri="{FF2B5EF4-FFF2-40B4-BE49-F238E27FC236}">
+                <a16:creationId xmlns:a16="http://schemas.microsoft.com/office/drawing/2014/main" id="{C4869FD7-CD11-263D-C64F-307AB95C006F}"/>
+              </a:ext>
+            </a:extLst>
+          </p:cNvPr>
+          <p:cNvSpPr/>
+          <p:nvPr/>
+        </p:nvSpPr>
+        <p:spPr>
+          <a:xfrm>
+            <a:off x="457200" y="3291840"/>
+            <a:ext cx="3977640" cy="1325880"/>
+          </a:xfrm>
+          <a:prstGeom prst="rect">
+            <a:avLst/>
+          </a:prstGeom>
+          <a:solidFill>
+            <a:srgbClr val="FFFFFF"/>
+          </a:solidFill>
+          <a:ln w="12700">
+            <a:solidFill>
+              <a:srgbClr val="CBD5E1"/>
+            </a:solidFill>
+            <a:prstDash val="solid"/>
+          </a:ln>
+          <a:effectLst>
+            <a:outerShdw blurRad="101600" dist="38100" dir="8100000" algn="bl" rotWithShape="0">
+              <a:srgbClr val="000000">
+                <a:alpha val="10000"/>
+              </a:srgbClr>
+            </a:outerShdw>
+          </a:effectLst>
+        </p:spPr>
+        <p:txBody>
+          <a:bodyPr/>
+          <a:lstStyle/>
+          <a:p>
+            <a:endParaRPr lang="en-US"/>
+          </a:p>
+        </p:txBody>
+      </p:sp>
+      <p:sp>
+        <p:nvSpPr>
+          <p:cNvPr id="16" name="Shape 12">
+            <a:extLst>
+              <a:ext uri="{FF2B5EF4-FFF2-40B4-BE49-F238E27FC236}">
+                <a16:creationId xmlns:a16="http://schemas.microsoft.com/office/drawing/2014/main" id="{CF1AA51C-4F9E-1DFD-BA70-6088C5F314DA}"/>
+              </a:ext>
+            </a:extLst>
+          </p:cNvPr>
+          <p:cNvSpPr/>
+          <p:nvPr/>
+        </p:nvSpPr>
+        <p:spPr>
+          <a:xfrm>
+            <a:off x="457200" y="3291840"/>
+            <a:ext cx="73152" cy="1325880"/>
+          </a:xfrm>
+          <a:prstGeom prst="rect">
+            <a:avLst/>
+          </a:prstGeom>
+          <a:solidFill>
+            <a:srgbClr val="0D9488"/>
+          </a:solidFill>
+          <a:ln w="12700">
+            <a:solidFill>
+              <a:srgbClr val="0D9488"/>
+            </a:solidFill>
+            <a:prstDash val="solid"/>
+          </a:ln>
+        </p:spPr>
+        <p:txBody>
+          <a:bodyPr/>
+          <a:lstStyle/>
+          <a:p>
+            <a:endParaRPr lang="en-US"/>
+          </a:p>
+        </p:txBody>
+      </p:sp>
+      <p:pic>
+        <p:nvPicPr>
+          <p:cNvPr id="17" name="Image 2" descr="preencoded.png">
+            <a:extLst>
+              <a:ext uri="{FF2B5EF4-FFF2-40B4-BE49-F238E27FC236}">
+                <a16:creationId xmlns:a16="http://schemas.microsoft.com/office/drawing/2014/main" id="{61BB539D-5B92-2B51-CA18-8B45CC022F1E}"/>
+              </a:ext>
+            </a:extLst>
+          </p:cNvPr>
+          <p:cNvPicPr>
+            <a:picLocks noChangeAspect="1"/>
+          </p:cNvPicPr>
+          <p:nvPr/>
+        </p:nvPicPr>
+        <p:blipFill>
+          <a:blip r:embed="rId5"/>
+          <a:stretch>
+            <a:fillRect/>
+          </a:stretch>
+        </p:blipFill>
+        <p:spPr>
+          <a:xfrm>
+            <a:off x="621792" y="3703320"/>
+            <a:ext cx="411480" cy="411480"/>
+          </a:xfrm>
+          <a:prstGeom prst="rect">
+            <a:avLst/>
+          </a:prstGeom>
+        </p:spPr>
+      </p:pic>
+      <p:sp>
+        <p:nvSpPr>
+          <p:cNvPr id="18" name="Text 13">
+            <a:extLst>
+              <a:ext uri="{FF2B5EF4-FFF2-40B4-BE49-F238E27FC236}">
+                <a16:creationId xmlns:a16="http://schemas.microsoft.com/office/drawing/2014/main" id="{D4EBB86B-9E92-DF6C-B539-3483D0CAE42D}"/>
+              </a:ext>
+            </a:extLst>
+          </p:cNvPr>
+          <p:cNvSpPr/>
+          <p:nvPr/>
+        </p:nvSpPr>
+        <p:spPr>
+          <a:xfrm>
+            <a:off x="1143000" y="3429000"/>
+            <a:ext cx="3200400" cy="365760"/>
+          </a:xfrm>
+          <a:prstGeom prst="rect">
+            <a:avLst/>
+          </a:prstGeom>
+          <a:noFill/>
+          <a:ln/>
+        </p:spPr>
+        <p:txBody>
+          <a:bodyPr wrap="square" lIns="0" tIns="0" rIns="0" bIns="0" rtlCol="0" anchor="ctr"/>
+          <a:lstStyle/>
+          <a:p>
+            <a:pPr marL="0" indent="0">
+              <a:buNone/>
+            </a:pPr>
+            <a:r>
+              <a:rPr lang="en-US" sz="1500" b="1" dirty="0">
+                <a:solidFill>
+                  <a:srgbClr val="1E293B"/>
+                </a:solidFill>
+                <a:latin typeface="Trebuchet MS" pitchFamily="34" charset="0"/>
+                <a:ea typeface="Trebuchet MS" pitchFamily="34" charset="-122"/>
+                <a:cs typeface="Trebuchet MS" pitchFamily="34" charset="-120"/>
+              </a:rPr>
+              <a:t>Compare</a:t>
+            </a:r>
+            <a:endParaRPr lang="en-US" sz="1500" dirty="0"/>
+          </a:p>
+        </p:txBody>
+      </p:sp>
+      <p:sp>
+        <p:nvSpPr>
+          <p:cNvPr id="19" name="Text 14">
+            <a:extLst>
+              <a:ext uri="{FF2B5EF4-FFF2-40B4-BE49-F238E27FC236}">
+                <a16:creationId xmlns:a16="http://schemas.microsoft.com/office/drawing/2014/main" id="{FE0E66FB-A71B-2F25-4C35-31822EF01F00}"/>
+              </a:ext>
+            </a:extLst>
+          </p:cNvPr>
+          <p:cNvSpPr/>
+          <p:nvPr/>
+        </p:nvSpPr>
+        <p:spPr>
+          <a:xfrm>
+            <a:off x="1143000" y="3794760"/>
+            <a:ext cx="3200400" cy="685800"/>
+          </a:xfrm>
+          <a:prstGeom prst="rect">
+            <a:avLst/>
+          </a:prstGeom>
+          <a:noFill/>
+          <a:ln/>
+        </p:spPr>
+        <p:txBody>
+          <a:bodyPr wrap="square" lIns="0" tIns="0" rIns="0" bIns="0" rtlCol="0" anchor="ctr"/>
+          <a:lstStyle/>
+          <a:p>
+            <a:pPr marL="0" indent="0">
+              <a:buNone/>
+            </a:pPr>
+            <a:r>
+              <a:rPr lang="en-US" sz="1200" dirty="0">
+                <a:solidFill>
+                  <a:srgbClr val="475569"/>
+                </a:solidFill>
+                <a:latin typeface="Calibri" pitchFamily="34" charset="0"/>
+                <a:ea typeface="Calibri" pitchFamily="34" charset="-122"/>
+                <a:cs typeface="Calibri" pitchFamily="34" charset="-120"/>
+              </a:rPr>
+              <a:t>See exactly what changed between any two versions, line by line.</a:t>
+            </a:r>
+            <a:endParaRPr lang="en-US" sz="1200" dirty="0"/>
+          </a:p>
+        </p:txBody>
+      </p:sp>
+      <p:sp>
+        <p:nvSpPr>
+          <p:cNvPr id="20" name="Shape 15">
+            <a:extLst>
+              <a:ext uri="{FF2B5EF4-FFF2-40B4-BE49-F238E27FC236}">
+                <a16:creationId xmlns:a16="http://schemas.microsoft.com/office/drawing/2014/main" id="{7DDFCA4B-AB6F-5D5D-3E26-21560356FE25}"/>
+              </a:ext>
+            </a:extLst>
+          </p:cNvPr>
+          <p:cNvSpPr/>
+          <p:nvPr/>
+        </p:nvSpPr>
+        <p:spPr>
+          <a:xfrm>
+            <a:off x="4754880" y="3291840"/>
+            <a:ext cx="3977640" cy="1325880"/>
+          </a:xfrm>
+          <a:prstGeom prst="rect">
+            <a:avLst/>
+          </a:prstGeom>
+          <a:solidFill>
+            <a:srgbClr val="FFFFFF"/>
+          </a:solidFill>
+          <a:ln w="12700">
+            <a:solidFill>
+              <a:srgbClr val="CBD5E1"/>
+            </a:solidFill>
+            <a:prstDash val="solid"/>
+          </a:ln>
+          <a:effectLst>
+            <a:outerShdw blurRad="101600" dist="38100" dir="8100000" algn="bl" rotWithShape="0">
+              <a:srgbClr val="000000">
+                <a:alpha val="10000"/>
+              </a:srgbClr>
+            </a:outerShdw>
+          </a:effectLst>
+        </p:spPr>
+        <p:txBody>
+          <a:bodyPr/>
+          <a:lstStyle/>
+          <a:p>
+            <a:endParaRPr lang="en-US"/>
+          </a:p>
+        </p:txBody>
+      </p:sp>
+      <p:sp>
+        <p:nvSpPr>
+          <p:cNvPr id="21" name="Shape 16">
+            <a:extLst>
+              <a:ext uri="{FF2B5EF4-FFF2-40B4-BE49-F238E27FC236}">
+                <a16:creationId xmlns:a16="http://schemas.microsoft.com/office/drawing/2014/main" id="{55682712-6319-73B8-A160-C788F73A3F61}"/>
+              </a:ext>
+            </a:extLst>
+          </p:cNvPr>
+          <p:cNvSpPr/>
+          <p:nvPr/>
+        </p:nvSpPr>
+        <p:spPr>
+          <a:xfrm>
+            <a:off x="4754880" y="3291840"/>
+            <a:ext cx="73152" cy="1325880"/>
+          </a:xfrm>
+          <a:prstGeom prst="rect">
+            <a:avLst/>
+          </a:prstGeom>
+          <a:solidFill>
+            <a:srgbClr val="0D9488"/>
+          </a:solidFill>
+          <a:ln w="12700">
+            <a:solidFill>
+              <a:srgbClr val="0D9488"/>
+            </a:solidFill>
+            <a:prstDash val="solid"/>
+          </a:ln>
+        </p:spPr>
+        <p:txBody>
+          <a:bodyPr/>
+          <a:lstStyle/>
+          <a:p>
+            <a:endParaRPr lang="en-US"/>
+          </a:p>
+        </p:txBody>
+      </p:sp>
+      <p:pic>
+        <p:nvPicPr>
+          <p:cNvPr id="22" name="Image 3" descr="preencoded.png">
+            <a:extLst>
+              <a:ext uri="{FF2B5EF4-FFF2-40B4-BE49-F238E27FC236}">
+                <a16:creationId xmlns:a16="http://schemas.microsoft.com/office/drawing/2014/main" id="{3F93D8FD-5529-F0DA-B168-47D1D4D381B7}"/>
+              </a:ext>
+            </a:extLst>
+          </p:cNvPr>
           <p:cNvPicPr>
             <a:picLocks noChangeAspect="1"/>
           </p:cNvPicPr>
@@ -3128,7 +3825,13 @@
       </p:pic>
       <p:sp>
         <p:nvSpPr>
-          <p:cNvPr id="23" name="Text 17"/>
+          <p:cNvPr id="23" name="Text 17">
+            <a:extLst>
+              <a:ext uri="{FF2B5EF4-FFF2-40B4-BE49-F238E27FC236}">
+                <a16:creationId xmlns:a16="http://schemas.microsoft.com/office/drawing/2014/main" id="{BA57F36D-B5EC-F47F-9A8C-E3FFABC7B9B4}"/>
+              </a:ext>
+            </a:extLst>
+          </p:cNvPr>
           <p:cNvSpPr/>
           <p:nvPr/>
         </p:nvSpPr>
@@ -3167,7 +3870,13 @@
       </p:sp>
       <p:sp>
         <p:nvSpPr>
-          <p:cNvPr id="24" name="Text 18"/>
+          <p:cNvPr id="24" name="Text 18">
+            <a:extLst>
+              <a:ext uri="{FF2B5EF4-FFF2-40B4-BE49-F238E27FC236}">
+                <a16:creationId xmlns:a16="http://schemas.microsoft.com/office/drawing/2014/main" id="{800F6FDC-FC99-82D6-038C-C85FC019BE37}"/>
+              </a:ext>
+            </a:extLst>
+          </p:cNvPr>
           <p:cNvSpPr/>
           <p:nvPr/>
         </p:nvSpPr>
@@ -3205,6 +3914,11 @@
         </p:txBody>
       </p:sp>
     </p:spTree>
+    <p:extLst>
+      <p:ext uri="{BB962C8B-B14F-4D97-AF65-F5344CB8AC3E}">
+        <p14:creationId xmlns:p14="http://schemas.microsoft.com/office/powerpoint/2010/main" val="1619363473"/>
+      </p:ext>
+    </p:extLst>
   </p:cSld>
   <p:clrMapOvr>
     <a:masterClrMapping/>
@@ -3212,7 +3926,7 @@
 </p:sld>
 </file>
 
-<file path=ppt/slides/slide4.xml><?xml version="1.0" encoding="utf-8"?>
+<file path=ppt/slides/slide5.xml><?xml version="1.0" encoding="utf-8"?>
 <p:sld xmlns:a="http://schemas.openxmlformats.org/drawingml/2006/main" xmlns:r="http://schemas.openxmlformats.org/officeDocument/2006/relationships" xmlns:p="http://schemas.openxmlformats.org/presentationml/2006/main">
   <p:cSld name="Slide 4">
     <p:bg>
@@ -4319,7 +5033,7 @@
 </p:sld>
 </file>
 
-<file path=ppt/slides/slide5.xml><?xml version="1.0" encoding="utf-8"?>
+<file path=ppt/slides/slide6.xml><?xml version="1.0" encoding="utf-8"?>
 <p:sld xmlns:a="http://schemas.openxmlformats.org/drawingml/2006/main" xmlns:r="http://schemas.openxmlformats.org/officeDocument/2006/relationships" xmlns:p="http://schemas.openxmlformats.org/presentationml/2006/main">
   <p:cSld name="Slide 5">
     <p:bg>
@@ -5098,7 +5812,7 @@
                 <a:ea typeface="Trebuchet MS" pitchFamily="34" charset="-122"/>
                 <a:cs typeface="Trebuchet MS" pitchFamily="34" charset="-120"/>
               </a:rPr>
-              <a:t>Reproducibility</a:t>
+              <a:t>Supports reproducibility</a:t>
             </a:r>
             <a:endParaRPr lang="en-US" sz="1400" dirty="0"/>
           </a:p>
@@ -5151,7 +5865,7 @@
 </p:sld>
 </file>
 
-<file path=ppt/slides/slide6.xml><?xml version="1.0" encoding="utf-8"?>
+<file path=ppt/slides/slide7.xml><?xml version="1.0" encoding="utf-8"?>
 <p:sld xmlns:a="http://schemas.openxmlformats.org/drawingml/2006/main" xmlns:r="http://schemas.openxmlformats.org/officeDocument/2006/relationships" xmlns:p="http://schemas.openxmlformats.org/presentationml/2006/main">
   <p:cSld name="Slide 6">
     <p:bg>
@@ -6645,7 +7359,7 @@
 </p:sld>
 </file>
 
-<file path=ppt/slides/slide7.xml><?xml version="1.0" encoding="utf-8"?>
+<file path=ppt/slides/slide8.xml><?xml version="1.0" encoding="utf-8"?>
 <p:sld xmlns:a="http://schemas.openxmlformats.org/drawingml/2006/main" xmlns:r="http://schemas.openxmlformats.org/officeDocument/2006/relationships" xmlns:p="http://schemas.openxmlformats.org/presentationml/2006/main">
   <p:cSld name="Slide 7">
     <p:bg>
@@ -8278,7 +8992,7 @@
 </p:sld>
 </file>
 
-<file path=ppt/slides/slide8.xml><?xml version="1.0" encoding="utf-8"?>
+<file path=ppt/slides/slide9.xml><?xml version="1.0" encoding="utf-8"?>
 <p:sld xmlns:a="http://schemas.openxmlformats.org/drawingml/2006/main" xmlns:r="http://schemas.openxmlformats.org/officeDocument/2006/relationships" xmlns:p="http://schemas.openxmlformats.org/presentationml/2006/main">
   <p:cSld name="Slide 8">
     <p:bg>

</xml_diff>

<commit_message>
Made additional updates to the PP presentation
</commit_message>
<xml_diff>
--- a/presentations/GitHub_Introduction_I-AIR SEO.pptx
+++ b/presentations/GitHub_Introduction_I-AIR SEO.pptx
@@ -5,7 +5,7 @@
     <p:sldMasterId id="2147483648" r:id="rId1"/>
   </p:sldMasterIdLst>
   <p:notesMasterIdLst>
-    <p:notesMasterId r:id="rId11"/>
+    <p:notesMasterId r:id="rId12"/>
   </p:notesMasterIdLst>
   <p:sldIdLst>
     <p:sldId id="256" r:id="rId2"/>
@@ -16,7 +16,8 @@
     <p:sldId id="260" r:id="rId7"/>
     <p:sldId id="261" r:id="rId8"/>
     <p:sldId id="262" r:id="rId9"/>
-    <p:sldId id="263" r:id="rId10"/>
+    <p:sldId id="265" r:id="rId10"/>
+    <p:sldId id="263" r:id="rId11"/>
   </p:sldIdLst>
   <p:sldSz cx="9144000" cy="5143500" type="screen16x9"/>
   <p:notesSz cx="5143500" cy="9144000"/>
@@ -329,6 +330,90 @@
 </p:notes>
 </file>
 
+<file path=ppt/notesSlides/notesSlide10.xml><?xml version="1.0" encoding="utf-8"?>
+<p:notes xmlns:a="http://schemas.openxmlformats.org/drawingml/2006/main" xmlns:r="http://schemas.openxmlformats.org/officeDocument/2006/relationships" xmlns:p="http://schemas.openxmlformats.org/presentationml/2006/main">
+  <p:cSld>
+    <p:spTree>
+      <p:nvGrpSpPr>
+        <p:cNvPr id="1" name=""/>
+        <p:cNvGrpSpPr/>
+        <p:nvPr/>
+      </p:nvGrpSpPr>
+      <p:grpSpPr>
+        <a:xfrm>
+          <a:off x="0" y="0"/>
+          <a:ext cx="0" cy="0"/>
+          <a:chOff x="0" y="0"/>
+          <a:chExt cx="0" cy="0"/>
+        </a:xfrm>
+      </p:grpSpPr>
+      <p:sp>
+        <p:nvSpPr>
+          <p:cNvPr id="2" name="Slide Image Placeholder 1"/>
+          <p:cNvSpPr>
+            <a:spLocks noGrp="1" noRot="1" noChangeAspect="1"/>
+          </p:cNvSpPr>
+          <p:nvPr>
+            <p:ph type="sldImg"/>
+          </p:nvPr>
+        </p:nvSpPr>
+        <p:spPr/>
+      </p:sp>
+      <p:sp>
+        <p:nvSpPr>
+          <p:cNvPr id="3" name="Notes Placeholder 2"/>
+          <p:cNvSpPr>
+            <a:spLocks noGrp="1"/>
+          </p:cNvSpPr>
+          <p:nvPr>
+            <p:ph type="body" idx="1"/>
+          </p:nvPr>
+        </p:nvSpPr>
+        <p:spPr/>
+        <p:txBody>
+          <a:bodyPr/>
+          <a:lstStyle/>
+          <a:p>
+            <a:endParaRPr lang="en-US" dirty="0"/>
+          </a:p>
+        </p:txBody>
+      </p:sp>
+      <p:sp>
+        <p:nvSpPr>
+          <p:cNvPr id="4" name="Slide Number Placeholder 3"/>
+          <p:cNvSpPr>
+            <a:spLocks noGrp="1"/>
+          </p:cNvSpPr>
+          <p:nvPr>
+            <p:ph type="sldNum" sz="quarter" idx="10"/>
+          </p:nvPr>
+        </p:nvSpPr>
+        <p:spPr/>
+        <p:txBody>
+          <a:bodyPr/>
+          <a:lstStyle/>
+          <a:p>
+            <a:fld id="{F7021451-1387-4CA6-816F-3879F97B5CBC}" type="slidenum">
+              <a:rPr lang="en-US"/>
+              <a:t>10</a:t>
+            </a:fld>
+            <a:endParaRPr lang="en-US"/>
+          </a:p>
+        </p:txBody>
+      </p:sp>
+    </p:spTree>
+    <p:extLst>
+      <p:ext uri="{BB962C8B-B14F-4D97-AF65-F5344CB8AC3E}">
+        <p14:creationId xmlns:p14="http://schemas.microsoft.com/office/powerpoint/2010/main" val="1024086991"/>
+      </p:ext>
+    </p:extLst>
+  </p:cSld>
+  <p:clrMapOvr>
+    <a:masterClrMapping/>
+  </p:clrMapOvr>
+</p:notes>
+</file>
+
 <file path=ppt/notesSlides/notesSlide2.xml><?xml version="1.0" encoding="utf-8"?>
 <p:notes xmlns:a="http://schemas.openxmlformats.org/drawingml/2006/main" xmlns:r="http://schemas.openxmlformats.org/officeDocument/2006/relationships" xmlns:p="http://schemas.openxmlformats.org/presentationml/2006/main">
   <p:cSld>
@@ -946,7 +1031,13 @@
   <p:cSld>
     <p:spTree>
       <p:nvGrpSpPr>
-        <p:cNvPr id="1" name=""/>
+        <p:cNvPr id="1" name="">
+          <a:extLst>
+            <a:ext uri="{FF2B5EF4-FFF2-40B4-BE49-F238E27FC236}">
+              <a16:creationId xmlns:a16="http://schemas.microsoft.com/office/drawing/2014/main" id="{37DA7EE9-EE33-2D58-74A6-73BE590AA139}"/>
+            </a:ext>
+          </a:extLst>
+        </p:cNvPr>
         <p:cNvGrpSpPr/>
         <p:nvPr/>
       </p:nvGrpSpPr>
@@ -960,7 +1051,13 @@
       </p:grpSpPr>
       <p:sp>
         <p:nvSpPr>
-          <p:cNvPr id="2" name="Slide Image Placeholder 1"/>
+          <p:cNvPr id="2" name="Slide Image Placeholder 1">
+            <a:extLst>
+              <a:ext uri="{FF2B5EF4-FFF2-40B4-BE49-F238E27FC236}">
+                <a16:creationId xmlns:a16="http://schemas.microsoft.com/office/drawing/2014/main" id="{F08E9422-6E15-9ECF-BE9A-3F39B55945DA}"/>
+              </a:ext>
+            </a:extLst>
+          </p:cNvPr>
           <p:cNvSpPr>
             <a:spLocks noGrp="1" noRot="1" noChangeAspect="1"/>
           </p:cNvSpPr>
@@ -972,7 +1069,13 @@
       </p:sp>
       <p:sp>
         <p:nvSpPr>
-          <p:cNvPr id="3" name="Notes Placeholder 2"/>
+          <p:cNvPr id="3" name="Notes Placeholder 2">
+            <a:extLst>
+              <a:ext uri="{FF2B5EF4-FFF2-40B4-BE49-F238E27FC236}">
+                <a16:creationId xmlns:a16="http://schemas.microsoft.com/office/drawing/2014/main" id="{53147C36-9807-763B-E599-BD54799120F8}"/>
+              </a:ext>
+            </a:extLst>
+          </p:cNvPr>
           <p:cNvSpPr>
             <a:spLocks noGrp="1"/>
           </p:cNvSpPr>
@@ -991,7 +1094,13 @@
       </p:sp>
       <p:sp>
         <p:nvSpPr>
-          <p:cNvPr id="4" name="Slide Number Placeholder 3"/>
+          <p:cNvPr id="4" name="Slide Number Placeholder 3">
+            <a:extLst>
+              <a:ext uri="{FF2B5EF4-FFF2-40B4-BE49-F238E27FC236}">
+                <a16:creationId xmlns:a16="http://schemas.microsoft.com/office/drawing/2014/main" id="{9EFD2847-C24B-C23A-5FA4-CF06C7499A76}"/>
+              </a:ext>
+            </a:extLst>
+          </p:cNvPr>
           <p:cNvSpPr>
             <a:spLocks noGrp="1"/>
           </p:cNvSpPr>
@@ -1015,7 +1124,7 @@
     </p:spTree>
     <p:extLst>
       <p:ext uri="{BB962C8B-B14F-4D97-AF65-F5344CB8AC3E}">
-        <p14:creationId xmlns:p14="http://schemas.microsoft.com/office/powerpoint/2010/main" val="1024086991"/>
+        <p14:creationId xmlns:p14="http://schemas.microsoft.com/office/powerpoint/2010/main" val="3858462183"/>
       </p:ext>
     </p:extLst>
   </p:cSld>
@@ -1663,6 +1772,752 @@
 </p:sld>
 </file>
 
+<file path=ppt/slides/slide10.xml><?xml version="1.0" encoding="utf-8"?>
+<p:sld xmlns:a="http://schemas.openxmlformats.org/drawingml/2006/main" xmlns:r="http://schemas.openxmlformats.org/officeDocument/2006/relationships" xmlns:p="http://schemas.openxmlformats.org/presentationml/2006/main">
+  <p:cSld name="Slide 8">
+    <p:bg>
+      <p:bgPr>
+        <a:solidFill>
+          <a:srgbClr val="1B2A4A"/>
+        </a:solidFill>
+        <a:effectLst/>
+      </p:bgPr>
+    </p:bg>
+    <p:spTree>
+      <p:nvGrpSpPr>
+        <p:cNvPr id="1" name=""/>
+        <p:cNvGrpSpPr/>
+        <p:nvPr/>
+      </p:nvGrpSpPr>
+      <p:grpSpPr>
+        <a:xfrm>
+          <a:off x="0" y="0"/>
+          <a:ext cx="0" cy="0"/>
+          <a:chOff x="0" y="0"/>
+          <a:chExt cx="0" cy="0"/>
+        </a:xfrm>
+      </p:grpSpPr>
+      <p:sp>
+        <p:nvSpPr>
+          <p:cNvPr id="2" name="Shape 0"/>
+          <p:cNvSpPr/>
+          <p:nvPr/>
+        </p:nvSpPr>
+        <p:spPr>
+          <a:xfrm>
+            <a:off x="0" y="4114800"/>
+            <a:ext cx="9144000" cy="1028700"/>
+          </a:xfrm>
+          <a:prstGeom prst="rect">
+            <a:avLst/>
+          </a:prstGeom>
+          <a:solidFill>
+            <a:srgbClr val="0D9488"/>
+          </a:solidFill>
+          <a:ln w="12700">
+            <a:solidFill>
+              <a:srgbClr val="0D9488"/>
+            </a:solidFill>
+            <a:prstDash val="solid"/>
+          </a:ln>
+        </p:spPr>
+        <p:txBody>
+          <a:bodyPr/>
+          <a:lstStyle/>
+          <a:p>
+            <a:endParaRPr lang="en-US"/>
+          </a:p>
+        </p:txBody>
+      </p:sp>
+      <p:sp>
+        <p:nvSpPr>
+          <p:cNvPr id="3" name="Text 1"/>
+          <p:cNvSpPr/>
+          <p:nvPr/>
+        </p:nvSpPr>
+        <p:spPr>
+          <a:xfrm>
+            <a:off x="457200" y="274320"/>
+            <a:ext cx="8229600" cy="685800"/>
+          </a:xfrm>
+          <a:prstGeom prst="rect">
+            <a:avLst/>
+          </a:prstGeom>
+          <a:noFill/>
+          <a:ln/>
+        </p:spPr>
+        <p:txBody>
+          <a:bodyPr wrap="square" rtlCol="0" anchor="ctr"/>
+          <a:lstStyle/>
+          <a:p>
+            <a:pPr marL="0" indent="0" algn="ctr">
+              <a:buNone/>
+            </a:pPr>
+            <a:r>
+              <a:rPr lang="en-US" sz="3400" b="1" dirty="0">
+                <a:solidFill>
+                  <a:srgbClr val="FFFFFF"/>
+                </a:solidFill>
+                <a:latin typeface="Trebuchet MS" pitchFamily="34" charset="0"/>
+                <a:ea typeface="Trebuchet MS" pitchFamily="34" charset="-122"/>
+                <a:cs typeface="Trebuchet MS" pitchFamily="34" charset="-120"/>
+              </a:rPr>
+              <a:t>Ready to go further?</a:t>
+            </a:r>
+            <a:endParaRPr lang="en-US" sz="3400" dirty="0"/>
+          </a:p>
+        </p:txBody>
+      </p:sp>
+      <p:sp>
+        <p:nvSpPr>
+          <p:cNvPr id="4" name="Text 2"/>
+          <p:cNvSpPr/>
+          <p:nvPr/>
+        </p:nvSpPr>
+        <p:spPr>
+          <a:xfrm>
+            <a:off x="457200" y="960120"/>
+            <a:ext cx="8229600" cy="411480"/>
+          </a:xfrm>
+          <a:prstGeom prst="rect">
+            <a:avLst/>
+          </a:prstGeom>
+          <a:noFill/>
+          <a:ln/>
+        </p:spPr>
+        <p:txBody>
+          <a:bodyPr wrap="square" rtlCol="0" anchor="ctr"/>
+          <a:lstStyle/>
+          <a:p>
+            <a:pPr marL="0" indent="0" algn="ctr">
+              <a:buNone/>
+            </a:pPr>
+            <a:r>
+              <a:rPr lang="en-US" sz="1600" i="1" dirty="0">
+                <a:solidFill>
+                  <a:srgbClr val="CCFBF1"/>
+                </a:solidFill>
+                <a:latin typeface="Calibri" pitchFamily="34" charset="0"/>
+                <a:ea typeface="Calibri" pitchFamily="34" charset="-122"/>
+                <a:cs typeface="Calibri" pitchFamily="34" charset="-120"/>
+              </a:rPr>
+              <a:t>Free resources to get started today</a:t>
+            </a:r>
+            <a:endParaRPr lang="en-US" sz="1600" dirty="0"/>
+          </a:p>
+        </p:txBody>
+      </p:sp>
+      <p:sp>
+        <p:nvSpPr>
+          <p:cNvPr id="5" name="Shape 3"/>
+          <p:cNvSpPr/>
+          <p:nvPr/>
+        </p:nvSpPr>
+        <p:spPr>
+          <a:xfrm>
+            <a:off x="457200" y="1508760"/>
+            <a:ext cx="3977640" cy="1005840"/>
+          </a:xfrm>
+          <a:prstGeom prst="rect">
+            <a:avLst/>
+          </a:prstGeom>
+          <a:solidFill>
+            <a:srgbClr val="1E3A5F"/>
+          </a:solidFill>
+          <a:ln w="12700">
+            <a:solidFill>
+              <a:srgbClr val="0D9488"/>
+            </a:solidFill>
+            <a:prstDash val="solid"/>
+          </a:ln>
+          <a:effectLst>
+            <a:outerShdw blurRad="101600" dist="38100" dir="8100000" algn="bl" rotWithShape="0">
+              <a:srgbClr val="000000">
+                <a:alpha val="10000"/>
+              </a:srgbClr>
+            </a:outerShdw>
+          </a:effectLst>
+        </p:spPr>
+        <p:txBody>
+          <a:bodyPr/>
+          <a:lstStyle/>
+          <a:p>
+            <a:endParaRPr lang="en-US"/>
+          </a:p>
+        </p:txBody>
+      </p:sp>
+      <p:pic>
+        <p:nvPicPr>
+          <p:cNvPr id="6" name="Image 0" descr="preencoded.png"/>
+          <p:cNvPicPr>
+            <a:picLocks noChangeAspect="1"/>
+          </p:cNvPicPr>
+          <p:nvPr/>
+        </p:nvPicPr>
+        <p:blipFill>
+          <a:blip r:embed="rId3"/>
+          <a:stretch>
+            <a:fillRect/>
+          </a:stretch>
+        </p:blipFill>
+        <p:spPr>
+          <a:xfrm>
+            <a:off x="594360" y="1847088"/>
+            <a:ext cx="274320" cy="274320"/>
+          </a:xfrm>
+          <a:prstGeom prst="rect">
+            <a:avLst/>
+          </a:prstGeom>
+        </p:spPr>
+      </p:pic>
+      <p:sp>
+        <p:nvSpPr>
+          <p:cNvPr id="7" name="Text 4"/>
+          <p:cNvSpPr/>
+          <p:nvPr/>
+        </p:nvSpPr>
+        <p:spPr>
+          <a:xfrm>
+            <a:off x="960120" y="1600200"/>
+            <a:ext cx="3383280" cy="365760"/>
+          </a:xfrm>
+          <a:prstGeom prst="rect">
+            <a:avLst/>
+          </a:prstGeom>
+          <a:noFill/>
+          <a:ln/>
+        </p:spPr>
+        <p:txBody>
+          <a:bodyPr wrap="square" lIns="0" tIns="0" rIns="0" bIns="0" rtlCol="0" anchor="ctr"/>
+          <a:lstStyle/>
+          <a:p>
+            <a:pPr marL="0" indent="0">
+              <a:buNone/>
+            </a:pPr>
+            <a:r>
+              <a:rPr lang="en-US" sz="1300" b="1" dirty="0">
+                <a:solidFill>
+                  <a:srgbClr val="FFFFFF"/>
+                </a:solidFill>
+                <a:latin typeface="Calibri" pitchFamily="34" charset="0"/>
+                <a:ea typeface="Calibri" pitchFamily="34" charset="-122"/>
+                <a:cs typeface="Calibri" pitchFamily="34" charset="-120"/>
+              </a:rPr>
+              <a:t>W3Schools Git Tutorial</a:t>
+            </a:r>
+            <a:endParaRPr lang="en-US" sz="1300" dirty="0"/>
+          </a:p>
+        </p:txBody>
+      </p:sp>
+      <p:sp>
+        <p:nvSpPr>
+          <p:cNvPr id="8" name="Text 5"/>
+          <p:cNvSpPr/>
+          <p:nvPr/>
+        </p:nvSpPr>
+        <p:spPr>
+          <a:xfrm>
+            <a:off x="960120" y="2011680"/>
+            <a:ext cx="3383280" cy="320040"/>
+          </a:xfrm>
+          <a:prstGeom prst="rect">
+            <a:avLst/>
+          </a:prstGeom>
+          <a:noFill/>
+          <a:ln/>
+        </p:spPr>
+        <p:txBody>
+          <a:bodyPr wrap="square" lIns="0" tIns="0" rIns="0" bIns="0" rtlCol="0" anchor="ctr"/>
+          <a:lstStyle/>
+          <a:p>
+            <a:pPr marL="0" indent="0">
+              <a:buNone/>
+            </a:pPr>
+            <a:r>
+              <a:rPr lang="en-US" sz="1100" dirty="0">
+                <a:solidFill>
+                  <a:srgbClr val="CCFBF1"/>
+                </a:solidFill>
+                <a:latin typeface="Consolas" pitchFamily="34" charset="0"/>
+                <a:ea typeface="Consolas" pitchFamily="34" charset="-122"/>
+                <a:cs typeface="Consolas" pitchFamily="34" charset="-120"/>
+              </a:rPr>
+              <a:t>w3schools.com/git</a:t>
+            </a:r>
+            <a:endParaRPr lang="en-US" sz="1100" dirty="0"/>
+          </a:p>
+        </p:txBody>
+      </p:sp>
+      <p:sp>
+        <p:nvSpPr>
+          <p:cNvPr id="9" name="Shape 6"/>
+          <p:cNvSpPr/>
+          <p:nvPr/>
+        </p:nvSpPr>
+        <p:spPr>
+          <a:xfrm>
+            <a:off x="4800600" y="1508760"/>
+            <a:ext cx="3977640" cy="1005840"/>
+          </a:xfrm>
+          <a:prstGeom prst="rect">
+            <a:avLst/>
+          </a:prstGeom>
+          <a:solidFill>
+            <a:srgbClr val="1E3A5F"/>
+          </a:solidFill>
+          <a:ln w="12700">
+            <a:solidFill>
+              <a:srgbClr val="0D9488"/>
+            </a:solidFill>
+            <a:prstDash val="solid"/>
+          </a:ln>
+          <a:effectLst>
+            <a:outerShdw blurRad="101600" dist="38100" dir="8100000" algn="bl" rotWithShape="0">
+              <a:srgbClr val="000000">
+                <a:alpha val="10000"/>
+              </a:srgbClr>
+            </a:outerShdw>
+          </a:effectLst>
+        </p:spPr>
+        <p:txBody>
+          <a:bodyPr/>
+          <a:lstStyle/>
+          <a:p>
+            <a:endParaRPr lang="en-US"/>
+          </a:p>
+        </p:txBody>
+      </p:sp>
+      <p:pic>
+        <p:nvPicPr>
+          <p:cNvPr id="10" name="Image 1" descr="preencoded.png"/>
+          <p:cNvPicPr>
+            <a:picLocks noChangeAspect="1"/>
+          </p:cNvPicPr>
+          <p:nvPr/>
+        </p:nvPicPr>
+        <p:blipFill>
+          <a:blip r:embed="rId3"/>
+          <a:stretch>
+            <a:fillRect/>
+          </a:stretch>
+        </p:blipFill>
+        <p:spPr>
+          <a:xfrm>
+            <a:off x="4937760" y="1847088"/>
+            <a:ext cx="274320" cy="274320"/>
+          </a:xfrm>
+          <a:prstGeom prst="rect">
+            <a:avLst/>
+          </a:prstGeom>
+        </p:spPr>
+      </p:pic>
+      <p:sp>
+        <p:nvSpPr>
+          <p:cNvPr id="11" name="Text 7"/>
+          <p:cNvSpPr/>
+          <p:nvPr/>
+        </p:nvSpPr>
+        <p:spPr>
+          <a:xfrm>
+            <a:off x="5303520" y="1600200"/>
+            <a:ext cx="3383280" cy="365760"/>
+          </a:xfrm>
+          <a:prstGeom prst="rect">
+            <a:avLst/>
+          </a:prstGeom>
+          <a:noFill/>
+          <a:ln/>
+        </p:spPr>
+        <p:txBody>
+          <a:bodyPr wrap="square" lIns="0" tIns="0" rIns="0" bIns="0" rtlCol="0" anchor="ctr"/>
+          <a:lstStyle/>
+          <a:p>
+            <a:pPr marL="0" indent="0">
+              <a:buNone/>
+            </a:pPr>
+            <a:r>
+              <a:rPr lang="en-US" sz="1300" b="1" dirty="0">
+                <a:solidFill>
+                  <a:srgbClr val="FFFFFF"/>
+                </a:solidFill>
+                <a:latin typeface="Calibri" pitchFamily="34" charset="0"/>
+                <a:ea typeface="Calibri" pitchFamily="34" charset="-122"/>
+                <a:cs typeface="Calibri" pitchFamily="34" charset="-120"/>
+              </a:rPr>
+              <a:t>GitHub Skills (interactive)</a:t>
+            </a:r>
+            <a:endParaRPr lang="en-US" sz="1300" dirty="0"/>
+          </a:p>
+        </p:txBody>
+      </p:sp>
+      <p:sp>
+        <p:nvSpPr>
+          <p:cNvPr id="12" name="Text 8"/>
+          <p:cNvSpPr/>
+          <p:nvPr/>
+        </p:nvSpPr>
+        <p:spPr>
+          <a:xfrm>
+            <a:off x="5303520" y="2011680"/>
+            <a:ext cx="3383280" cy="320040"/>
+          </a:xfrm>
+          <a:prstGeom prst="rect">
+            <a:avLst/>
+          </a:prstGeom>
+          <a:noFill/>
+          <a:ln/>
+        </p:spPr>
+        <p:txBody>
+          <a:bodyPr wrap="square" lIns="0" tIns="0" rIns="0" bIns="0" rtlCol="0" anchor="ctr"/>
+          <a:lstStyle/>
+          <a:p>
+            <a:pPr marL="0" indent="0">
+              <a:buNone/>
+            </a:pPr>
+            <a:r>
+              <a:rPr lang="en-US" sz="1100" dirty="0">
+                <a:solidFill>
+                  <a:srgbClr val="CCFBF1"/>
+                </a:solidFill>
+                <a:latin typeface="Consolas" pitchFamily="34" charset="0"/>
+                <a:ea typeface="Consolas" pitchFamily="34" charset="-122"/>
+                <a:cs typeface="Consolas" pitchFamily="34" charset="-120"/>
+              </a:rPr>
+              <a:t>skills.github.com</a:t>
+            </a:r>
+            <a:endParaRPr lang="en-US" sz="1100" dirty="0"/>
+          </a:p>
+        </p:txBody>
+      </p:sp>
+      <p:sp>
+        <p:nvSpPr>
+          <p:cNvPr id="13" name="Shape 9"/>
+          <p:cNvSpPr/>
+          <p:nvPr/>
+        </p:nvSpPr>
+        <p:spPr>
+          <a:xfrm>
+            <a:off x="457200" y="2697480"/>
+            <a:ext cx="3977640" cy="1005840"/>
+          </a:xfrm>
+          <a:prstGeom prst="rect">
+            <a:avLst/>
+          </a:prstGeom>
+          <a:solidFill>
+            <a:srgbClr val="1E3A5F"/>
+          </a:solidFill>
+          <a:ln w="12700">
+            <a:solidFill>
+              <a:srgbClr val="0D9488"/>
+            </a:solidFill>
+            <a:prstDash val="solid"/>
+          </a:ln>
+          <a:effectLst>
+            <a:outerShdw blurRad="101600" dist="38100" dir="8100000" algn="bl" rotWithShape="0">
+              <a:srgbClr val="000000">
+                <a:alpha val="10000"/>
+              </a:srgbClr>
+            </a:outerShdw>
+          </a:effectLst>
+        </p:spPr>
+        <p:txBody>
+          <a:bodyPr/>
+          <a:lstStyle/>
+          <a:p>
+            <a:endParaRPr lang="en-US"/>
+          </a:p>
+        </p:txBody>
+      </p:sp>
+      <p:pic>
+        <p:nvPicPr>
+          <p:cNvPr id="14" name="Image 2" descr="preencoded.png"/>
+          <p:cNvPicPr>
+            <a:picLocks noChangeAspect="1"/>
+          </p:cNvPicPr>
+          <p:nvPr/>
+        </p:nvPicPr>
+        <p:blipFill>
+          <a:blip r:embed="rId3"/>
+          <a:stretch>
+            <a:fillRect/>
+          </a:stretch>
+        </p:blipFill>
+        <p:spPr>
+          <a:xfrm>
+            <a:off x="594360" y="3035808"/>
+            <a:ext cx="274320" cy="274320"/>
+          </a:xfrm>
+          <a:prstGeom prst="rect">
+            <a:avLst/>
+          </a:prstGeom>
+        </p:spPr>
+      </p:pic>
+      <p:sp>
+        <p:nvSpPr>
+          <p:cNvPr id="15" name="Text 10"/>
+          <p:cNvSpPr/>
+          <p:nvPr/>
+        </p:nvSpPr>
+        <p:spPr>
+          <a:xfrm>
+            <a:off x="960120" y="2788920"/>
+            <a:ext cx="3383280" cy="365760"/>
+          </a:xfrm>
+          <a:prstGeom prst="rect">
+            <a:avLst/>
+          </a:prstGeom>
+          <a:noFill/>
+          <a:ln/>
+        </p:spPr>
+        <p:txBody>
+          <a:bodyPr wrap="square" lIns="0" tIns="0" rIns="0" bIns="0" rtlCol="0" anchor="ctr"/>
+          <a:lstStyle/>
+          <a:p>
+            <a:pPr marL="0" indent="0">
+              <a:buNone/>
+            </a:pPr>
+            <a:r>
+              <a:rPr lang="en-US" sz="1300" b="1" dirty="0">
+                <a:solidFill>
+                  <a:srgbClr val="FFFFFF"/>
+                </a:solidFill>
+                <a:latin typeface="Calibri" pitchFamily="34" charset="0"/>
+                <a:ea typeface="Calibri" pitchFamily="34" charset="-122"/>
+                <a:cs typeface="Calibri" pitchFamily="34" charset="-120"/>
+              </a:rPr>
+              <a:t>Atlassian Git Tutorials</a:t>
+            </a:r>
+            <a:endParaRPr lang="en-US" sz="1300" dirty="0"/>
+          </a:p>
+        </p:txBody>
+      </p:sp>
+      <p:sp>
+        <p:nvSpPr>
+          <p:cNvPr id="16" name="Text 11"/>
+          <p:cNvSpPr/>
+          <p:nvPr/>
+        </p:nvSpPr>
+        <p:spPr>
+          <a:xfrm>
+            <a:off x="960120" y="3200400"/>
+            <a:ext cx="3383280" cy="320040"/>
+          </a:xfrm>
+          <a:prstGeom prst="rect">
+            <a:avLst/>
+          </a:prstGeom>
+          <a:noFill/>
+          <a:ln/>
+        </p:spPr>
+        <p:txBody>
+          <a:bodyPr wrap="square" lIns="0" tIns="0" rIns="0" bIns="0" rtlCol="0" anchor="ctr"/>
+          <a:lstStyle/>
+          <a:p>
+            <a:pPr marL="0" indent="0">
+              <a:buNone/>
+            </a:pPr>
+            <a:r>
+              <a:rPr lang="en-US" sz="1100" dirty="0">
+                <a:solidFill>
+                  <a:srgbClr val="CCFBF1"/>
+                </a:solidFill>
+                <a:latin typeface="Consolas" pitchFamily="34" charset="0"/>
+                <a:ea typeface="Consolas" pitchFamily="34" charset="-122"/>
+                <a:cs typeface="Consolas" pitchFamily="34" charset="-120"/>
+              </a:rPr>
+              <a:t>atlassian.com/git/tutorials</a:t>
+            </a:r>
+            <a:endParaRPr lang="en-US" sz="1100" dirty="0"/>
+          </a:p>
+        </p:txBody>
+      </p:sp>
+      <p:sp>
+        <p:nvSpPr>
+          <p:cNvPr id="17" name="Shape 12"/>
+          <p:cNvSpPr/>
+          <p:nvPr/>
+        </p:nvSpPr>
+        <p:spPr>
+          <a:xfrm>
+            <a:off x="4800600" y="2697480"/>
+            <a:ext cx="3977640" cy="1005840"/>
+          </a:xfrm>
+          <a:prstGeom prst="rect">
+            <a:avLst/>
+          </a:prstGeom>
+          <a:solidFill>
+            <a:srgbClr val="1E3A5F"/>
+          </a:solidFill>
+          <a:ln w="12700">
+            <a:solidFill>
+              <a:srgbClr val="0D9488"/>
+            </a:solidFill>
+            <a:prstDash val="solid"/>
+          </a:ln>
+          <a:effectLst>
+            <a:outerShdw blurRad="101600" dist="38100" dir="8100000" algn="bl" rotWithShape="0">
+              <a:srgbClr val="000000">
+                <a:alpha val="10000"/>
+              </a:srgbClr>
+            </a:outerShdw>
+          </a:effectLst>
+        </p:spPr>
+        <p:txBody>
+          <a:bodyPr/>
+          <a:lstStyle/>
+          <a:p>
+            <a:endParaRPr lang="en-US"/>
+          </a:p>
+        </p:txBody>
+      </p:sp>
+      <p:pic>
+        <p:nvPicPr>
+          <p:cNvPr id="18" name="Image 3" descr="preencoded.png"/>
+          <p:cNvPicPr>
+            <a:picLocks noChangeAspect="1"/>
+          </p:cNvPicPr>
+          <p:nvPr/>
+        </p:nvPicPr>
+        <p:blipFill>
+          <a:blip r:embed="rId3"/>
+          <a:stretch>
+            <a:fillRect/>
+          </a:stretch>
+        </p:blipFill>
+        <p:spPr>
+          <a:xfrm>
+            <a:off x="4937760" y="3035808"/>
+            <a:ext cx="274320" cy="274320"/>
+          </a:xfrm>
+          <a:prstGeom prst="rect">
+            <a:avLst/>
+          </a:prstGeom>
+        </p:spPr>
+      </p:pic>
+      <p:sp>
+        <p:nvSpPr>
+          <p:cNvPr id="19" name="Text 13"/>
+          <p:cNvSpPr/>
+          <p:nvPr/>
+        </p:nvSpPr>
+        <p:spPr>
+          <a:xfrm>
+            <a:off x="5303520" y="2788920"/>
+            <a:ext cx="3383280" cy="365760"/>
+          </a:xfrm>
+          <a:prstGeom prst="rect">
+            <a:avLst/>
+          </a:prstGeom>
+          <a:noFill/>
+          <a:ln/>
+        </p:spPr>
+        <p:txBody>
+          <a:bodyPr wrap="square" lIns="0" tIns="0" rIns="0" bIns="0" rtlCol="0" anchor="ctr"/>
+          <a:lstStyle/>
+          <a:p>
+            <a:pPr marL="0" indent="0">
+              <a:buNone/>
+            </a:pPr>
+            <a:r>
+              <a:rPr lang="en-US" sz="1300" b="1" dirty="0">
+                <a:solidFill>
+                  <a:srgbClr val="FFFFFF"/>
+                </a:solidFill>
+                <a:latin typeface="Calibri" pitchFamily="34" charset="0"/>
+                <a:ea typeface="Calibri" pitchFamily="34" charset="-122"/>
+                <a:cs typeface="Calibri" pitchFamily="34" charset="-120"/>
+              </a:rPr>
+              <a:t>GitHub Cheat Sheet (PDF)</a:t>
+            </a:r>
+            <a:endParaRPr lang="en-US" sz="1300" dirty="0"/>
+          </a:p>
+        </p:txBody>
+      </p:sp>
+      <p:sp>
+        <p:nvSpPr>
+          <p:cNvPr id="20" name="Text 14"/>
+          <p:cNvSpPr/>
+          <p:nvPr/>
+        </p:nvSpPr>
+        <p:spPr>
+          <a:xfrm>
+            <a:off x="5303520" y="3200400"/>
+            <a:ext cx="3383280" cy="320040"/>
+          </a:xfrm>
+          <a:prstGeom prst="rect">
+            <a:avLst/>
+          </a:prstGeom>
+          <a:noFill/>
+          <a:ln/>
+        </p:spPr>
+        <p:txBody>
+          <a:bodyPr wrap="square" lIns="0" tIns="0" rIns="0" bIns="0" rtlCol="0" anchor="ctr"/>
+          <a:lstStyle/>
+          <a:p>
+            <a:pPr marL="0" indent="0">
+              <a:buNone/>
+            </a:pPr>
+            <a:r>
+              <a:rPr lang="en-US" sz="1100" dirty="0">
+                <a:solidFill>
+                  <a:srgbClr val="CCFBF1"/>
+                </a:solidFill>
+                <a:latin typeface="Consolas" pitchFamily="34" charset="0"/>
+                <a:ea typeface="Consolas" pitchFamily="34" charset="-122"/>
+                <a:cs typeface="Consolas" pitchFamily="34" charset="-120"/>
+              </a:rPr>
+              <a:t>education.github.com/git-cheat-sheet-education.pdf</a:t>
+            </a:r>
+            <a:endParaRPr lang="en-US" sz="1100" dirty="0"/>
+          </a:p>
+        </p:txBody>
+      </p:sp>
+      <p:sp>
+        <p:nvSpPr>
+          <p:cNvPr id="21" name="Text 15"/>
+          <p:cNvSpPr/>
+          <p:nvPr/>
+        </p:nvSpPr>
+        <p:spPr>
+          <a:xfrm>
+            <a:off x="457200" y="4206240"/>
+            <a:ext cx="8229600" cy="365760"/>
+          </a:xfrm>
+          <a:prstGeom prst="rect">
+            <a:avLst/>
+          </a:prstGeom>
+          <a:noFill/>
+          <a:ln/>
+        </p:spPr>
+        <p:txBody>
+          <a:bodyPr wrap="square" rtlCol="0" anchor="ctr"/>
+          <a:lstStyle/>
+          <a:p>
+            <a:pPr marL="0" indent="0" algn="ctr">
+              <a:buNone/>
+            </a:pPr>
+            <a:r>
+              <a:rPr lang="en-US" sz="1300" b="1" dirty="0">
+                <a:solidFill>
+                  <a:srgbClr val="1B2A4A"/>
+                </a:solidFill>
+                <a:latin typeface="Calibri" pitchFamily="34" charset="0"/>
+                <a:ea typeface="Calibri" pitchFamily="34" charset="-122"/>
+                <a:cs typeface="Calibri" pitchFamily="34" charset="-120"/>
+              </a:rPr>
+              <a:t>The best way to learn Git is to use it — even on a solo project.</a:t>
+            </a:r>
+            <a:endParaRPr lang="en-US" sz="1300" dirty="0"/>
+          </a:p>
+        </p:txBody>
+      </p:sp>
+    </p:spTree>
+  </p:cSld>
+  <p:clrMapOvr>
+    <a:masterClrMapping/>
+  </p:clrMapOvr>
+</p:sld>
+</file>
+
 <file path=ppt/slides/slide2.xml><?xml version="1.0" encoding="utf-8"?>
 <p:sld xmlns:a="http://schemas.openxmlformats.org/drawingml/2006/main" xmlns:r="http://schemas.openxmlformats.org/officeDocument/2006/relationships" xmlns:p="http://schemas.openxmlformats.org/presentationml/2006/main">
   <p:cSld name="Slide 2">
@@ -8994,18 +9849,24 @@
 
 <file path=ppt/slides/slide9.xml><?xml version="1.0" encoding="utf-8"?>
 <p:sld xmlns:a="http://schemas.openxmlformats.org/drawingml/2006/main" xmlns:r="http://schemas.openxmlformats.org/officeDocument/2006/relationships" xmlns:p="http://schemas.openxmlformats.org/presentationml/2006/main">
-  <p:cSld name="Slide 8">
+  <p:cSld>
     <p:bg>
       <p:bgPr>
         <a:solidFill>
-          <a:srgbClr val="1B2A4A"/>
+          <a:srgbClr val="F8FAFC"/>
         </a:solidFill>
         <a:effectLst/>
       </p:bgPr>
     </p:bg>
     <p:spTree>
       <p:nvGrpSpPr>
-        <p:cNvPr id="1" name=""/>
+        <p:cNvPr id="1" name="">
+          <a:extLst>
+            <a:ext uri="{FF2B5EF4-FFF2-40B4-BE49-F238E27FC236}">
+              <a16:creationId xmlns:a16="http://schemas.microsoft.com/office/drawing/2014/main" id="{9F406B75-1449-6A1D-FDAD-179B1E6C43CE}"/>
+            </a:ext>
+          </a:extLst>
+        </p:cNvPr>
         <p:cNvGrpSpPr/>
         <p:nvPr/>
       </p:nvGrpSpPr>
@@ -9019,14 +9880,20 @@
       </p:grpSpPr>
       <p:sp>
         <p:nvSpPr>
-          <p:cNvPr id="2" name="Shape 0"/>
-          <p:cNvSpPr/>
-          <p:nvPr/>
-        </p:nvSpPr>
-        <p:spPr>
-          <a:xfrm>
-            <a:off x="0" y="4114800"/>
-            <a:ext cx="9144000" cy="1028700"/>
+          <p:cNvPr id="2" name="Shape 0">
+            <a:extLst>
+              <a:ext uri="{FF2B5EF4-FFF2-40B4-BE49-F238E27FC236}">
+                <a16:creationId xmlns:a16="http://schemas.microsoft.com/office/drawing/2014/main" id="{453BF832-C707-02ED-995A-4F56C40DA5E7}"/>
+              </a:ext>
+            </a:extLst>
+          </p:cNvPr>
+          <p:cNvSpPr/>
+          <p:nvPr/>
+        </p:nvSpPr>
+        <p:spPr>
+          <a:xfrm>
+            <a:off x="457200" y="256032"/>
+            <a:ext cx="1645920" cy="256032"/>
           </a:xfrm>
           <a:prstGeom prst="rect">
             <a:avLst/>
@@ -9051,14 +9918,62 @@
       </p:sp>
       <p:sp>
         <p:nvSpPr>
-          <p:cNvPr id="3" name="Text 1"/>
-          <p:cNvSpPr/>
-          <p:nvPr/>
-        </p:nvSpPr>
-        <p:spPr>
-          <a:xfrm>
-            <a:off x="457200" y="274320"/>
-            <a:ext cx="8229600" cy="685800"/>
+          <p:cNvPr id="3" name="Text 1">
+            <a:extLst>
+              <a:ext uri="{FF2B5EF4-FFF2-40B4-BE49-F238E27FC236}">
+                <a16:creationId xmlns:a16="http://schemas.microsoft.com/office/drawing/2014/main" id="{0A102B6D-101A-6D16-9C61-4700771DACE8}"/>
+              </a:ext>
+            </a:extLst>
+          </p:cNvPr>
+          <p:cNvSpPr/>
+          <p:nvPr/>
+        </p:nvSpPr>
+        <p:spPr>
+          <a:xfrm>
+            <a:off x="457200" y="256032"/>
+            <a:ext cx="1645920" cy="256032"/>
+          </a:xfrm>
+          <a:prstGeom prst="rect">
+            <a:avLst/>
+          </a:prstGeom>
+          <a:noFill/>
+          <a:ln/>
+        </p:spPr>
+        <p:txBody>
+          <a:bodyPr wrap="square" lIns="0" tIns="0" rIns="0" bIns="0" rtlCol="0" anchor="ctr"/>
+          <a:lstStyle/>
+          <a:p>
+            <a:pPr marL="0" indent="0" algn="ctr">
+              <a:buNone/>
+            </a:pPr>
+            <a:r>
+              <a:rPr lang="en-US" sz="800" b="1" dirty="0">
+                <a:solidFill>
+                  <a:srgbClr val="FFFFFF"/>
+                </a:solidFill>
+              </a:rPr>
+              <a:t>GIT TOOLS</a:t>
+            </a:r>
+            <a:endParaRPr lang="en-US" sz="800" dirty="0"/>
+          </a:p>
+        </p:txBody>
+      </p:sp>
+      <p:sp>
+        <p:nvSpPr>
+          <p:cNvPr id="4" name="Text 2">
+            <a:extLst>
+              <a:ext uri="{FF2B5EF4-FFF2-40B4-BE49-F238E27FC236}">
+                <a16:creationId xmlns:a16="http://schemas.microsoft.com/office/drawing/2014/main" id="{7EABA8D3-0DC9-3DA4-2BF7-AAE9FCA961DB}"/>
+              </a:ext>
+            </a:extLst>
+          </p:cNvPr>
+          <p:cNvSpPr/>
+          <p:nvPr/>
+        </p:nvSpPr>
+        <p:spPr>
+          <a:xfrm>
+            <a:off x="457200" y="594360"/>
+            <a:ext cx="8229600" cy="548640"/>
           </a:xfrm>
           <a:prstGeom prst="rect">
             <a:avLst/>
@@ -9070,93 +9985,136 @@
           <a:bodyPr wrap="square" rtlCol="0" anchor="ctr"/>
           <a:lstStyle/>
           <a:p>
+            <a:pPr marL="0" indent="0">
+              <a:buNone/>
+            </a:pPr>
+            <a:r>
+              <a:rPr lang="en-US" sz="2800" b="1" dirty="0">
+                <a:latin typeface="Trebuchet MS" panose="020B0603020202020204" pitchFamily="34" charset="0"/>
+              </a:rPr>
+              <a:t>CLI or GUI tools are available</a:t>
+            </a:r>
+          </a:p>
+        </p:txBody>
+      </p:sp>
+      <p:sp>
+        <p:nvSpPr>
+          <p:cNvPr id="38" name="Text 36">
+            <a:extLst>
+              <a:ext uri="{FF2B5EF4-FFF2-40B4-BE49-F238E27FC236}">
+                <a16:creationId xmlns:a16="http://schemas.microsoft.com/office/drawing/2014/main" id="{C1976806-E155-505F-42D6-B3E84B6566C4}"/>
+              </a:ext>
+            </a:extLst>
+          </p:cNvPr>
+          <p:cNvSpPr/>
+          <p:nvPr/>
+        </p:nvSpPr>
+        <p:spPr>
+          <a:xfrm>
+            <a:off x="457200" y="3931920"/>
+            <a:ext cx="8229600" cy="274320"/>
+          </a:xfrm>
+          <a:prstGeom prst="rect">
+            <a:avLst/>
+          </a:prstGeom>
+          <a:noFill/>
+          <a:ln/>
+        </p:spPr>
+        <p:txBody>
+          <a:bodyPr wrap="square" rtlCol="0" anchor="ctr"/>
+          <a:lstStyle/>
+          <a:p>
             <a:pPr marL="0" indent="0" algn="ctr">
               <a:buNone/>
             </a:pPr>
             <a:r>
-              <a:rPr lang="en-US" sz="3400" b="1" dirty="0">
-                <a:solidFill>
-                  <a:srgbClr val="FFFFFF"/>
-                </a:solidFill>
-                <a:latin typeface="Trebuchet MS" pitchFamily="34" charset="0"/>
-                <a:ea typeface="Trebuchet MS" pitchFamily="34" charset="-122"/>
-                <a:cs typeface="Trebuchet MS" pitchFamily="34" charset="-120"/>
-              </a:rPr>
-              <a:t>Ready to go further?</a:t>
-            </a:r>
-            <a:endParaRPr lang="en-US" sz="3400" dirty="0"/>
-          </a:p>
-        </p:txBody>
-      </p:sp>
-      <p:sp>
-        <p:nvSpPr>
-          <p:cNvPr id="4" name="Text 2"/>
-          <p:cNvSpPr/>
-          <p:nvPr/>
-        </p:nvSpPr>
-        <p:spPr>
-          <a:xfrm>
-            <a:off x="457200" y="960120"/>
-            <a:ext cx="8229600" cy="411480"/>
-          </a:xfrm>
-          <a:prstGeom prst="rect">
-            <a:avLst/>
-          </a:prstGeom>
-          <a:noFill/>
-          <a:ln/>
-        </p:spPr>
-        <p:txBody>
-          <a:bodyPr wrap="square" rtlCol="0" anchor="ctr"/>
-          <a:lstStyle/>
-          <a:p>
-            <a:pPr marL="0" indent="0" algn="ctr">
-              <a:buNone/>
-            </a:pPr>
-            <a:r>
-              <a:rPr lang="en-US" sz="1600" i="1" dirty="0">
-                <a:solidFill>
-                  <a:srgbClr val="CCFBF1"/>
+              <a:rPr lang="en-US" sz="1100" i="1" dirty="0">
+                <a:solidFill>
+                  <a:schemeClr val="tx1">
+                    <a:lumMod val="75000"/>
+                    <a:lumOff val="25000"/>
+                  </a:schemeClr>
                 </a:solidFill>
                 <a:latin typeface="Calibri" pitchFamily="34" charset="0"/>
                 <a:ea typeface="Calibri" pitchFamily="34" charset="-122"/>
                 <a:cs typeface="Calibri" pitchFamily="34" charset="-120"/>
               </a:rPr>
-              <a:t>Free resources to get started today</a:t>
-            </a:r>
-            <a:endParaRPr lang="en-US" sz="1600" dirty="0"/>
-          </a:p>
-        </p:txBody>
-      </p:sp>
-      <p:sp>
-        <p:nvSpPr>
-          <p:cNvPr id="5" name="Shape 3"/>
-          <p:cNvSpPr/>
-          <p:nvPr/>
-        </p:nvSpPr>
-        <p:spPr>
-          <a:xfrm>
-            <a:off x="457200" y="1508760"/>
-            <a:ext cx="3977640" cy="1005840"/>
-          </a:xfrm>
-          <a:prstGeom prst="rect">
-            <a:avLst/>
-          </a:prstGeom>
-          <a:solidFill>
-            <a:srgbClr val="1E3A5F"/>
-          </a:solidFill>
+              <a:t>Local machine  ←————————————————————————→  GitHub (remote)</a:t>
+            </a:r>
+            <a:endParaRPr lang="en-US" sz="1100" dirty="0">
+              <a:solidFill>
+                <a:schemeClr val="tx1">
+                  <a:lumMod val="75000"/>
+                  <a:lumOff val="25000"/>
+                </a:schemeClr>
+              </a:solidFill>
+            </a:endParaRPr>
+          </a:p>
+        </p:txBody>
+      </p:sp>
+      <p:sp>
+        <p:nvSpPr>
+          <p:cNvPr id="39" name="Shape 37">
+            <a:extLst>
+              <a:ext uri="{FF2B5EF4-FFF2-40B4-BE49-F238E27FC236}">
+                <a16:creationId xmlns:a16="http://schemas.microsoft.com/office/drawing/2014/main" id="{CF145A1C-2BCF-E16D-AB5E-51E032DBA04B}"/>
+              </a:ext>
+            </a:extLst>
+          </p:cNvPr>
+          <p:cNvSpPr/>
+          <p:nvPr/>
+        </p:nvSpPr>
+        <p:spPr>
+          <a:xfrm>
+            <a:off x="594360" y="4224528"/>
+            <a:ext cx="4663440" cy="0"/>
+          </a:xfrm>
+          <a:prstGeom prst="line">
+            <a:avLst/>
+          </a:prstGeom>
+          <a:noFill/>
+          <a:ln w="12700">
+            <a:solidFill>
+              <a:srgbClr val="CBD5E1"/>
+            </a:solidFill>
+            <a:prstDash val="solid"/>
+          </a:ln>
+        </p:spPr>
+        <p:txBody>
+          <a:bodyPr/>
+          <a:lstStyle/>
+          <a:p>
+            <a:endParaRPr lang="en-US"/>
+          </a:p>
+        </p:txBody>
+      </p:sp>
+      <p:sp>
+        <p:nvSpPr>
+          <p:cNvPr id="41" name="Shape 39">
+            <a:extLst>
+              <a:ext uri="{FF2B5EF4-FFF2-40B4-BE49-F238E27FC236}">
+                <a16:creationId xmlns:a16="http://schemas.microsoft.com/office/drawing/2014/main" id="{A7F7FD14-6912-225C-5492-AEAE5884364D}"/>
+              </a:ext>
+            </a:extLst>
+          </p:cNvPr>
+          <p:cNvSpPr/>
+          <p:nvPr/>
+        </p:nvSpPr>
+        <p:spPr>
+          <a:xfrm>
+            <a:off x="5349240" y="4224528"/>
+            <a:ext cx="3246120" cy="0"/>
+          </a:xfrm>
+          <a:prstGeom prst="line">
+            <a:avLst/>
+          </a:prstGeom>
+          <a:noFill/>
           <a:ln w="12700">
             <a:solidFill>
               <a:srgbClr val="0D9488"/>
             </a:solidFill>
             <a:prstDash val="solid"/>
           </a:ln>
-          <a:effectLst>
-            <a:outerShdw blurRad="101600" dist="38100" dir="8100000" algn="bl" rotWithShape="0">
-              <a:srgbClr val="000000">
-                <a:alpha val="10000"/>
-              </a:srgbClr>
-            </a:outerShdw>
-          </a:effectLst>
         </p:spPr>
         <p:txBody>
           <a:bodyPr/>
@@ -9168,7 +10126,13 @@
       </p:sp>
       <p:pic>
         <p:nvPicPr>
-          <p:cNvPr id="6" name="Image 0" descr="preencoded.png"/>
+          <p:cNvPr id="44" name="Picture 43">
+            <a:extLst>
+              <a:ext uri="{FF2B5EF4-FFF2-40B4-BE49-F238E27FC236}">
+                <a16:creationId xmlns:a16="http://schemas.microsoft.com/office/drawing/2014/main" id="{0D7BA612-DDD4-376F-C73C-DED8DCCAC335}"/>
+              </a:ext>
+            </a:extLst>
+          </p:cNvPr>
           <p:cNvPicPr>
             <a:picLocks noChangeAspect="1"/>
           </p:cNvPicPr>
@@ -9182,555 +10146,20 @@
         </p:blipFill>
         <p:spPr>
           <a:xfrm>
-            <a:off x="594360" y="1847088"/>
-            <a:ext cx="274320" cy="274320"/>
+            <a:off x="959426" y="1304501"/>
+            <a:ext cx="2587140" cy="2465918"/>
           </a:xfrm>
           <a:prstGeom prst="rect">
             <a:avLst/>
           </a:prstGeom>
         </p:spPr>
       </p:pic>
-      <p:sp>
-        <p:nvSpPr>
-          <p:cNvPr id="7" name="Text 4"/>
-          <p:cNvSpPr/>
-          <p:nvPr/>
-        </p:nvSpPr>
-        <p:spPr>
-          <a:xfrm>
-            <a:off x="960120" y="1600200"/>
-            <a:ext cx="3383280" cy="365760"/>
-          </a:xfrm>
-          <a:prstGeom prst="rect">
-            <a:avLst/>
-          </a:prstGeom>
-          <a:noFill/>
-          <a:ln/>
-        </p:spPr>
-        <p:txBody>
-          <a:bodyPr wrap="square" lIns="0" tIns="0" rIns="0" bIns="0" rtlCol="0" anchor="ctr"/>
-          <a:lstStyle/>
-          <a:p>
-            <a:pPr marL="0" indent="0">
-              <a:buNone/>
-            </a:pPr>
-            <a:r>
-              <a:rPr lang="en-US" sz="1300" b="1" dirty="0">
-                <a:solidFill>
-                  <a:srgbClr val="FFFFFF"/>
-                </a:solidFill>
-                <a:latin typeface="Calibri" pitchFamily="34" charset="0"/>
-                <a:ea typeface="Calibri" pitchFamily="34" charset="-122"/>
-                <a:cs typeface="Calibri" pitchFamily="34" charset="-120"/>
-              </a:rPr>
-              <a:t>W3Schools Git Tutorial</a:t>
-            </a:r>
-            <a:endParaRPr lang="en-US" sz="1300" dirty="0"/>
-          </a:p>
-        </p:txBody>
-      </p:sp>
-      <p:sp>
-        <p:nvSpPr>
-          <p:cNvPr id="8" name="Text 5"/>
-          <p:cNvSpPr/>
-          <p:nvPr/>
-        </p:nvSpPr>
-        <p:spPr>
-          <a:xfrm>
-            <a:off x="960120" y="2011680"/>
-            <a:ext cx="3383280" cy="320040"/>
-          </a:xfrm>
-          <a:prstGeom prst="rect">
-            <a:avLst/>
-          </a:prstGeom>
-          <a:noFill/>
-          <a:ln/>
-        </p:spPr>
-        <p:txBody>
-          <a:bodyPr wrap="square" lIns="0" tIns="0" rIns="0" bIns="0" rtlCol="0" anchor="ctr"/>
-          <a:lstStyle/>
-          <a:p>
-            <a:pPr marL="0" indent="0">
-              <a:buNone/>
-            </a:pPr>
-            <a:r>
-              <a:rPr lang="en-US" sz="1100" dirty="0">
-                <a:solidFill>
-                  <a:srgbClr val="CCFBF1"/>
-                </a:solidFill>
-                <a:latin typeface="Consolas" pitchFamily="34" charset="0"/>
-                <a:ea typeface="Consolas" pitchFamily="34" charset="-122"/>
-                <a:cs typeface="Consolas" pitchFamily="34" charset="-120"/>
-              </a:rPr>
-              <a:t>w3schools.com/git</a:t>
-            </a:r>
-            <a:endParaRPr lang="en-US" sz="1100" dirty="0"/>
-          </a:p>
-        </p:txBody>
-      </p:sp>
-      <p:sp>
-        <p:nvSpPr>
-          <p:cNvPr id="9" name="Shape 6"/>
-          <p:cNvSpPr/>
-          <p:nvPr/>
-        </p:nvSpPr>
-        <p:spPr>
-          <a:xfrm>
-            <a:off x="4800600" y="1508760"/>
-            <a:ext cx="3977640" cy="1005840"/>
-          </a:xfrm>
-          <a:prstGeom prst="rect">
-            <a:avLst/>
-          </a:prstGeom>
-          <a:solidFill>
-            <a:srgbClr val="1E3A5F"/>
-          </a:solidFill>
-          <a:ln w="12700">
-            <a:solidFill>
-              <a:srgbClr val="0D9488"/>
-            </a:solidFill>
-            <a:prstDash val="solid"/>
-          </a:ln>
-          <a:effectLst>
-            <a:outerShdw blurRad="101600" dist="38100" dir="8100000" algn="bl" rotWithShape="0">
-              <a:srgbClr val="000000">
-                <a:alpha val="10000"/>
-              </a:srgbClr>
-            </a:outerShdw>
-          </a:effectLst>
-        </p:spPr>
-        <p:txBody>
-          <a:bodyPr/>
-          <a:lstStyle/>
-          <a:p>
-            <a:endParaRPr lang="en-US"/>
-          </a:p>
-        </p:txBody>
-      </p:sp>
-      <p:pic>
-        <p:nvPicPr>
-          <p:cNvPr id="10" name="Image 1" descr="preencoded.png"/>
-          <p:cNvPicPr>
-            <a:picLocks noChangeAspect="1"/>
-          </p:cNvPicPr>
-          <p:nvPr/>
-        </p:nvPicPr>
-        <p:blipFill>
-          <a:blip r:embed="rId3"/>
-          <a:stretch>
-            <a:fillRect/>
-          </a:stretch>
-        </p:blipFill>
-        <p:spPr>
-          <a:xfrm>
-            <a:off x="4937760" y="1847088"/>
-            <a:ext cx="274320" cy="274320"/>
-          </a:xfrm>
-          <a:prstGeom prst="rect">
-            <a:avLst/>
-          </a:prstGeom>
-        </p:spPr>
-      </p:pic>
-      <p:sp>
-        <p:nvSpPr>
-          <p:cNvPr id="11" name="Text 7"/>
-          <p:cNvSpPr/>
-          <p:nvPr/>
-        </p:nvSpPr>
-        <p:spPr>
-          <a:xfrm>
-            <a:off x="5303520" y="1600200"/>
-            <a:ext cx="3383280" cy="365760"/>
-          </a:xfrm>
-          <a:prstGeom prst="rect">
-            <a:avLst/>
-          </a:prstGeom>
-          <a:noFill/>
-          <a:ln/>
-        </p:spPr>
-        <p:txBody>
-          <a:bodyPr wrap="square" lIns="0" tIns="0" rIns="0" bIns="0" rtlCol="0" anchor="ctr"/>
-          <a:lstStyle/>
-          <a:p>
-            <a:pPr marL="0" indent="0">
-              <a:buNone/>
-            </a:pPr>
-            <a:r>
-              <a:rPr lang="en-US" sz="1300" b="1" dirty="0">
-                <a:solidFill>
-                  <a:srgbClr val="FFFFFF"/>
-                </a:solidFill>
-                <a:latin typeface="Calibri" pitchFamily="34" charset="0"/>
-                <a:ea typeface="Calibri" pitchFamily="34" charset="-122"/>
-                <a:cs typeface="Calibri" pitchFamily="34" charset="-120"/>
-              </a:rPr>
-              <a:t>GitHub Skills (interactive)</a:t>
-            </a:r>
-            <a:endParaRPr lang="en-US" sz="1300" dirty="0"/>
-          </a:p>
-        </p:txBody>
-      </p:sp>
-      <p:sp>
-        <p:nvSpPr>
-          <p:cNvPr id="12" name="Text 8"/>
-          <p:cNvSpPr/>
-          <p:nvPr/>
-        </p:nvSpPr>
-        <p:spPr>
-          <a:xfrm>
-            <a:off x="5303520" y="2011680"/>
-            <a:ext cx="3383280" cy="320040"/>
-          </a:xfrm>
-          <a:prstGeom prst="rect">
-            <a:avLst/>
-          </a:prstGeom>
-          <a:noFill/>
-          <a:ln/>
-        </p:spPr>
-        <p:txBody>
-          <a:bodyPr wrap="square" lIns="0" tIns="0" rIns="0" bIns="0" rtlCol="0" anchor="ctr"/>
-          <a:lstStyle/>
-          <a:p>
-            <a:pPr marL="0" indent="0">
-              <a:buNone/>
-            </a:pPr>
-            <a:r>
-              <a:rPr lang="en-US" sz="1100" dirty="0">
-                <a:solidFill>
-                  <a:srgbClr val="CCFBF1"/>
-                </a:solidFill>
-                <a:latin typeface="Consolas" pitchFamily="34" charset="0"/>
-                <a:ea typeface="Consolas" pitchFamily="34" charset="-122"/>
-                <a:cs typeface="Consolas" pitchFamily="34" charset="-120"/>
-              </a:rPr>
-              <a:t>skills.github.com</a:t>
-            </a:r>
-            <a:endParaRPr lang="en-US" sz="1100" dirty="0"/>
-          </a:p>
-        </p:txBody>
-      </p:sp>
-      <p:sp>
-        <p:nvSpPr>
-          <p:cNvPr id="13" name="Shape 9"/>
-          <p:cNvSpPr/>
-          <p:nvPr/>
-        </p:nvSpPr>
-        <p:spPr>
-          <a:xfrm>
-            <a:off x="457200" y="2697480"/>
-            <a:ext cx="3977640" cy="1005840"/>
-          </a:xfrm>
-          <a:prstGeom prst="rect">
-            <a:avLst/>
-          </a:prstGeom>
-          <a:solidFill>
-            <a:srgbClr val="1E3A5F"/>
-          </a:solidFill>
-          <a:ln w="12700">
-            <a:solidFill>
-              <a:srgbClr val="0D9488"/>
-            </a:solidFill>
-            <a:prstDash val="solid"/>
-          </a:ln>
-          <a:effectLst>
-            <a:outerShdw blurRad="101600" dist="38100" dir="8100000" algn="bl" rotWithShape="0">
-              <a:srgbClr val="000000">
-                <a:alpha val="10000"/>
-              </a:srgbClr>
-            </a:outerShdw>
-          </a:effectLst>
-        </p:spPr>
-        <p:txBody>
-          <a:bodyPr/>
-          <a:lstStyle/>
-          <a:p>
-            <a:endParaRPr lang="en-US"/>
-          </a:p>
-        </p:txBody>
-      </p:sp>
-      <p:pic>
-        <p:nvPicPr>
-          <p:cNvPr id="14" name="Image 2" descr="preencoded.png"/>
-          <p:cNvPicPr>
-            <a:picLocks noChangeAspect="1"/>
-          </p:cNvPicPr>
-          <p:nvPr/>
-        </p:nvPicPr>
-        <p:blipFill>
-          <a:blip r:embed="rId3"/>
-          <a:stretch>
-            <a:fillRect/>
-          </a:stretch>
-        </p:blipFill>
-        <p:spPr>
-          <a:xfrm>
-            <a:off x="594360" y="3035808"/>
-            <a:ext cx="274320" cy="274320"/>
-          </a:xfrm>
-          <a:prstGeom prst="rect">
-            <a:avLst/>
-          </a:prstGeom>
-        </p:spPr>
-      </p:pic>
-      <p:sp>
-        <p:nvSpPr>
-          <p:cNvPr id="15" name="Text 10"/>
-          <p:cNvSpPr/>
-          <p:nvPr/>
-        </p:nvSpPr>
-        <p:spPr>
-          <a:xfrm>
-            <a:off x="960120" y="2788920"/>
-            <a:ext cx="3383280" cy="365760"/>
-          </a:xfrm>
-          <a:prstGeom prst="rect">
-            <a:avLst/>
-          </a:prstGeom>
-          <a:noFill/>
-          <a:ln/>
-        </p:spPr>
-        <p:txBody>
-          <a:bodyPr wrap="square" lIns="0" tIns="0" rIns="0" bIns="0" rtlCol="0" anchor="ctr"/>
-          <a:lstStyle/>
-          <a:p>
-            <a:pPr marL="0" indent="0">
-              <a:buNone/>
-            </a:pPr>
-            <a:r>
-              <a:rPr lang="en-US" sz="1300" b="1" dirty="0">
-                <a:solidFill>
-                  <a:srgbClr val="FFFFFF"/>
-                </a:solidFill>
-                <a:latin typeface="Calibri" pitchFamily="34" charset="0"/>
-                <a:ea typeface="Calibri" pitchFamily="34" charset="-122"/>
-                <a:cs typeface="Calibri" pitchFamily="34" charset="-120"/>
-              </a:rPr>
-              <a:t>Atlassian Git Tutorials</a:t>
-            </a:r>
-            <a:endParaRPr lang="en-US" sz="1300" dirty="0"/>
-          </a:p>
-        </p:txBody>
-      </p:sp>
-      <p:sp>
-        <p:nvSpPr>
-          <p:cNvPr id="16" name="Text 11"/>
-          <p:cNvSpPr/>
-          <p:nvPr/>
-        </p:nvSpPr>
-        <p:spPr>
-          <a:xfrm>
-            <a:off x="960120" y="3200400"/>
-            <a:ext cx="3383280" cy="320040"/>
-          </a:xfrm>
-          <a:prstGeom prst="rect">
-            <a:avLst/>
-          </a:prstGeom>
-          <a:noFill/>
-          <a:ln/>
-        </p:spPr>
-        <p:txBody>
-          <a:bodyPr wrap="square" lIns="0" tIns="0" rIns="0" bIns="0" rtlCol="0" anchor="ctr"/>
-          <a:lstStyle/>
-          <a:p>
-            <a:pPr marL="0" indent="0">
-              <a:buNone/>
-            </a:pPr>
-            <a:r>
-              <a:rPr lang="en-US" sz="1100" dirty="0">
-                <a:solidFill>
-                  <a:srgbClr val="CCFBF1"/>
-                </a:solidFill>
-                <a:latin typeface="Consolas" pitchFamily="34" charset="0"/>
-                <a:ea typeface="Consolas" pitchFamily="34" charset="-122"/>
-                <a:cs typeface="Consolas" pitchFamily="34" charset="-120"/>
-              </a:rPr>
-              <a:t>atlassian.com/git/tutorials</a:t>
-            </a:r>
-            <a:endParaRPr lang="en-US" sz="1100" dirty="0"/>
-          </a:p>
-        </p:txBody>
-      </p:sp>
-      <p:sp>
-        <p:nvSpPr>
-          <p:cNvPr id="17" name="Shape 12"/>
-          <p:cNvSpPr/>
-          <p:nvPr/>
-        </p:nvSpPr>
-        <p:spPr>
-          <a:xfrm>
-            <a:off x="4800600" y="2697480"/>
-            <a:ext cx="3977640" cy="1005840"/>
-          </a:xfrm>
-          <a:prstGeom prst="rect">
-            <a:avLst/>
-          </a:prstGeom>
-          <a:solidFill>
-            <a:srgbClr val="1E3A5F"/>
-          </a:solidFill>
-          <a:ln w="12700">
-            <a:solidFill>
-              <a:srgbClr val="0D9488"/>
-            </a:solidFill>
-            <a:prstDash val="solid"/>
-          </a:ln>
-          <a:effectLst>
-            <a:outerShdw blurRad="101600" dist="38100" dir="8100000" algn="bl" rotWithShape="0">
-              <a:srgbClr val="000000">
-                <a:alpha val="10000"/>
-              </a:srgbClr>
-            </a:outerShdw>
-          </a:effectLst>
-        </p:spPr>
-        <p:txBody>
-          <a:bodyPr/>
-          <a:lstStyle/>
-          <a:p>
-            <a:endParaRPr lang="en-US"/>
-          </a:p>
-        </p:txBody>
-      </p:sp>
-      <p:pic>
-        <p:nvPicPr>
-          <p:cNvPr id="18" name="Image 3" descr="preencoded.png"/>
-          <p:cNvPicPr>
-            <a:picLocks noChangeAspect="1"/>
-          </p:cNvPicPr>
-          <p:nvPr/>
-        </p:nvPicPr>
-        <p:blipFill>
-          <a:blip r:embed="rId3"/>
-          <a:stretch>
-            <a:fillRect/>
-          </a:stretch>
-        </p:blipFill>
-        <p:spPr>
-          <a:xfrm>
-            <a:off x="4937760" y="3035808"/>
-            <a:ext cx="274320" cy="274320"/>
-          </a:xfrm>
-          <a:prstGeom prst="rect">
-            <a:avLst/>
-          </a:prstGeom>
-        </p:spPr>
-      </p:pic>
-      <p:sp>
-        <p:nvSpPr>
-          <p:cNvPr id="19" name="Text 13"/>
-          <p:cNvSpPr/>
-          <p:nvPr/>
-        </p:nvSpPr>
-        <p:spPr>
-          <a:xfrm>
-            <a:off x="5303520" y="2788920"/>
-            <a:ext cx="3383280" cy="365760"/>
-          </a:xfrm>
-          <a:prstGeom prst="rect">
-            <a:avLst/>
-          </a:prstGeom>
-          <a:noFill/>
-          <a:ln/>
-        </p:spPr>
-        <p:txBody>
-          <a:bodyPr wrap="square" lIns="0" tIns="0" rIns="0" bIns="0" rtlCol="0" anchor="ctr"/>
-          <a:lstStyle/>
-          <a:p>
-            <a:pPr marL="0" indent="0">
-              <a:buNone/>
-            </a:pPr>
-            <a:r>
-              <a:rPr lang="en-US" sz="1300" b="1" dirty="0">
-                <a:solidFill>
-                  <a:srgbClr val="FFFFFF"/>
-                </a:solidFill>
-                <a:latin typeface="Calibri" pitchFamily="34" charset="0"/>
-                <a:ea typeface="Calibri" pitchFamily="34" charset="-122"/>
-                <a:cs typeface="Calibri" pitchFamily="34" charset="-120"/>
-              </a:rPr>
-              <a:t>GitHub Cheat Sheet (PDF)</a:t>
-            </a:r>
-            <a:endParaRPr lang="en-US" sz="1300" dirty="0"/>
-          </a:p>
-        </p:txBody>
-      </p:sp>
-      <p:sp>
-        <p:nvSpPr>
-          <p:cNvPr id="20" name="Text 14"/>
-          <p:cNvSpPr/>
-          <p:nvPr/>
-        </p:nvSpPr>
-        <p:spPr>
-          <a:xfrm>
-            <a:off x="5303520" y="3200400"/>
-            <a:ext cx="3383280" cy="320040"/>
-          </a:xfrm>
-          <a:prstGeom prst="rect">
-            <a:avLst/>
-          </a:prstGeom>
-          <a:noFill/>
-          <a:ln/>
-        </p:spPr>
-        <p:txBody>
-          <a:bodyPr wrap="square" lIns="0" tIns="0" rIns="0" bIns="0" rtlCol="0" anchor="ctr"/>
-          <a:lstStyle/>
-          <a:p>
-            <a:pPr marL="0" indent="0">
-              <a:buNone/>
-            </a:pPr>
-            <a:r>
-              <a:rPr lang="en-US" sz="1100" dirty="0">
-                <a:solidFill>
-                  <a:srgbClr val="CCFBF1"/>
-                </a:solidFill>
-                <a:latin typeface="Consolas" pitchFamily="34" charset="0"/>
-                <a:ea typeface="Consolas" pitchFamily="34" charset="-122"/>
-                <a:cs typeface="Consolas" pitchFamily="34" charset="-120"/>
-              </a:rPr>
-              <a:t>education.github.com/git-cheat-sheet-education.pdf</a:t>
-            </a:r>
-            <a:endParaRPr lang="en-US" sz="1100" dirty="0"/>
-          </a:p>
-        </p:txBody>
-      </p:sp>
-      <p:sp>
-        <p:nvSpPr>
-          <p:cNvPr id="21" name="Text 15"/>
-          <p:cNvSpPr/>
-          <p:nvPr/>
-        </p:nvSpPr>
-        <p:spPr>
-          <a:xfrm>
-            <a:off x="457200" y="4206240"/>
-            <a:ext cx="8229600" cy="365760"/>
-          </a:xfrm>
-          <a:prstGeom prst="rect">
-            <a:avLst/>
-          </a:prstGeom>
-          <a:noFill/>
-          <a:ln/>
-        </p:spPr>
-        <p:txBody>
-          <a:bodyPr wrap="square" rtlCol="0" anchor="ctr"/>
-          <a:lstStyle/>
-          <a:p>
-            <a:pPr marL="0" indent="0" algn="ctr">
-              <a:buNone/>
-            </a:pPr>
-            <a:r>
-              <a:rPr lang="en-US" sz="1300" b="1" dirty="0">
-                <a:solidFill>
-                  <a:srgbClr val="1B2A4A"/>
-                </a:solidFill>
-                <a:latin typeface="Calibri" pitchFamily="34" charset="0"/>
-                <a:ea typeface="Calibri" pitchFamily="34" charset="-122"/>
-                <a:cs typeface="Calibri" pitchFamily="34" charset="-120"/>
-              </a:rPr>
-              <a:t>The best way to learn Git is to use it — even on a solo project.</a:t>
-            </a:r>
-            <a:endParaRPr lang="en-US" sz="1300" dirty="0"/>
-          </a:p>
-        </p:txBody>
-      </p:sp>
     </p:spTree>
+    <p:extLst>
+      <p:ext uri="{BB962C8B-B14F-4D97-AF65-F5344CB8AC3E}">
+        <p14:creationId xmlns:p14="http://schemas.microsoft.com/office/powerpoint/2010/main" val="446247213"/>
+      </p:ext>
+    </p:extLst>
   </p:cSld>
   <p:clrMapOvr>
     <a:masterClrMapping/>

</xml_diff>

<commit_message>
Added a slide showing various Git tools for desktop
</commit_message>
<xml_diff>
--- a/presentations/GitHub_Introduction_I-AIR SEO.pptx
+++ b/presentations/GitHub_Introduction_I-AIR SEO.pptx
@@ -9997,133 +9997,6 @@
           </a:p>
         </p:txBody>
       </p:sp>
-      <p:sp>
-        <p:nvSpPr>
-          <p:cNvPr id="38" name="Text 36">
-            <a:extLst>
-              <a:ext uri="{FF2B5EF4-FFF2-40B4-BE49-F238E27FC236}">
-                <a16:creationId xmlns:a16="http://schemas.microsoft.com/office/drawing/2014/main" id="{C1976806-E155-505F-42D6-B3E84B6566C4}"/>
-              </a:ext>
-            </a:extLst>
-          </p:cNvPr>
-          <p:cNvSpPr/>
-          <p:nvPr/>
-        </p:nvSpPr>
-        <p:spPr>
-          <a:xfrm>
-            <a:off x="457200" y="3931920"/>
-            <a:ext cx="8229600" cy="274320"/>
-          </a:xfrm>
-          <a:prstGeom prst="rect">
-            <a:avLst/>
-          </a:prstGeom>
-          <a:noFill/>
-          <a:ln/>
-        </p:spPr>
-        <p:txBody>
-          <a:bodyPr wrap="square" rtlCol="0" anchor="ctr"/>
-          <a:lstStyle/>
-          <a:p>
-            <a:pPr marL="0" indent="0" algn="ctr">
-              <a:buNone/>
-            </a:pPr>
-            <a:r>
-              <a:rPr lang="en-US" sz="1100" i="1" dirty="0">
-                <a:solidFill>
-                  <a:schemeClr val="tx1">
-                    <a:lumMod val="75000"/>
-                    <a:lumOff val="25000"/>
-                  </a:schemeClr>
-                </a:solidFill>
-                <a:latin typeface="Calibri" pitchFamily="34" charset="0"/>
-                <a:ea typeface="Calibri" pitchFamily="34" charset="-122"/>
-                <a:cs typeface="Calibri" pitchFamily="34" charset="-120"/>
-              </a:rPr>
-              <a:t>Local machine  ←————————————————————————→  GitHub (remote)</a:t>
-            </a:r>
-            <a:endParaRPr lang="en-US" sz="1100" dirty="0">
-              <a:solidFill>
-                <a:schemeClr val="tx1">
-                  <a:lumMod val="75000"/>
-                  <a:lumOff val="25000"/>
-                </a:schemeClr>
-              </a:solidFill>
-            </a:endParaRPr>
-          </a:p>
-        </p:txBody>
-      </p:sp>
-      <p:sp>
-        <p:nvSpPr>
-          <p:cNvPr id="39" name="Shape 37">
-            <a:extLst>
-              <a:ext uri="{FF2B5EF4-FFF2-40B4-BE49-F238E27FC236}">
-                <a16:creationId xmlns:a16="http://schemas.microsoft.com/office/drawing/2014/main" id="{CF145A1C-2BCF-E16D-AB5E-51E032DBA04B}"/>
-              </a:ext>
-            </a:extLst>
-          </p:cNvPr>
-          <p:cNvSpPr/>
-          <p:nvPr/>
-        </p:nvSpPr>
-        <p:spPr>
-          <a:xfrm>
-            <a:off x="594360" y="4224528"/>
-            <a:ext cx="4663440" cy="0"/>
-          </a:xfrm>
-          <a:prstGeom prst="line">
-            <a:avLst/>
-          </a:prstGeom>
-          <a:noFill/>
-          <a:ln w="12700">
-            <a:solidFill>
-              <a:srgbClr val="CBD5E1"/>
-            </a:solidFill>
-            <a:prstDash val="solid"/>
-          </a:ln>
-        </p:spPr>
-        <p:txBody>
-          <a:bodyPr/>
-          <a:lstStyle/>
-          <a:p>
-            <a:endParaRPr lang="en-US"/>
-          </a:p>
-        </p:txBody>
-      </p:sp>
-      <p:sp>
-        <p:nvSpPr>
-          <p:cNvPr id="41" name="Shape 39">
-            <a:extLst>
-              <a:ext uri="{FF2B5EF4-FFF2-40B4-BE49-F238E27FC236}">
-                <a16:creationId xmlns:a16="http://schemas.microsoft.com/office/drawing/2014/main" id="{A7F7FD14-6912-225C-5492-AEAE5884364D}"/>
-              </a:ext>
-            </a:extLst>
-          </p:cNvPr>
-          <p:cNvSpPr/>
-          <p:nvPr/>
-        </p:nvSpPr>
-        <p:spPr>
-          <a:xfrm>
-            <a:off x="5349240" y="4224528"/>
-            <a:ext cx="3246120" cy="0"/>
-          </a:xfrm>
-          <a:prstGeom prst="line">
-            <a:avLst/>
-          </a:prstGeom>
-          <a:noFill/>
-          <a:ln w="12700">
-            <a:solidFill>
-              <a:srgbClr val="0D9488"/>
-            </a:solidFill>
-            <a:prstDash val="solid"/>
-          </a:ln>
-        </p:spPr>
-        <p:txBody>
-          <a:bodyPr/>
-          <a:lstStyle/>
-          <a:p>
-            <a:endParaRPr lang="en-US"/>
-          </a:p>
-        </p:txBody>
-      </p:sp>
       <p:pic>
         <p:nvPicPr>
           <p:cNvPr id="44" name="Picture 43">
@@ -10146,14 +10019,128 @@
         </p:blipFill>
         <p:spPr>
           <a:xfrm>
-            <a:off x="959426" y="1304501"/>
-            <a:ext cx="2587140" cy="2465918"/>
-          </a:xfrm>
-          <a:prstGeom prst="rect">
-            <a:avLst/>
-          </a:prstGeom>
+            <a:off x="940172" y="1338790"/>
+            <a:ext cx="2955461" cy="2816981"/>
+          </a:xfrm>
+          <a:prstGeom prst="rect">
+            <a:avLst/>
+          </a:prstGeom>
+          <a:ln>
+            <a:solidFill>
+              <a:srgbClr val="002060"/>
+            </a:solidFill>
+          </a:ln>
         </p:spPr>
       </p:pic>
+      <p:pic>
+        <p:nvPicPr>
+          <p:cNvPr id="7" name="Picture 6">
+            <a:extLst>
+              <a:ext uri="{FF2B5EF4-FFF2-40B4-BE49-F238E27FC236}">
+                <a16:creationId xmlns:a16="http://schemas.microsoft.com/office/drawing/2014/main" id="{A6D155BB-BF2F-436B-74E5-1AA052AB2D6D}"/>
+              </a:ext>
+            </a:extLst>
+          </p:cNvPr>
+          <p:cNvPicPr>
+            <a:picLocks noChangeAspect="1"/>
+          </p:cNvPicPr>
+          <p:nvPr/>
+        </p:nvPicPr>
+        <p:blipFill>
+          <a:blip r:embed="rId4"/>
+          <a:stretch>
+            <a:fillRect/>
+          </a:stretch>
+        </p:blipFill>
+        <p:spPr>
+          <a:xfrm>
+            <a:off x="5025938" y="1338790"/>
+            <a:ext cx="3102700" cy="2813223"/>
+          </a:xfrm>
+          <a:prstGeom prst="rect">
+            <a:avLst/>
+          </a:prstGeom>
+          <a:ln>
+            <a:solidFill>
+              <a:srgbClr val="002060"/>
+            </a:solidFill>
+          </a:ln>
+        </p:spPr>
+      </p:pic>
+      <p:sp>
+        <p:nvSpPr>
+          <p:cNvPr id="8" name="TextBox 7">
+            <a:extLst>
+              <a:ext uri="{FF2B5EF4-FFF2-40B4-BE49-F238E27FC236}">
+                <a16:creationId xmlns:a16="http://schemas.microsoft.com/office/drawing/2014/main" id="{C6C2F74B-DE91-0A64-C9BB-3E1490EAF592}"/>
+              </a:ext>
+            </a:extLst>
+          </p:cNvPr>
+          <p:cNvSpPr txBox="1"/>
+          <p:nvPr/>
+        </p:nvSpPr>
+        <p:spPr>
+          <a:xfrm>
+            <a:off x="5793024" y="4278079"/>
+            <a:ext cx="1881051" cy="369332"/>
+          </a:xfrm>
+          <a:prstGeom prst="rect">
+            <a:avLst/>
+          </a:prstGeom>
+          <a:noFill/>
+        </p:spPr>
+        <p:txBody>
+          <a:bodyPr wrap="square" rtlCol="0">
+            <a:spAutoFit/>
+          </a:bodyPr>
+          <a:lstStyle/>
+          <a:p>
+            <a:r>
+              <a:rPr lang="en-US" dirty="0">
+                <a:latin typeface="Trebuchet MS" panose="020B0603020202020204" pitchFamily="34" charset="0"/>
+              </a:rPr>
+              <a:t>GitHub Desktop</a:t>
+            </a:r>
+          </a:p>
+        </p:txBody>
+      </p:sp>
+      <p:sp>
+        <p:nvSpPr>
+          <p:cNvPr id="9" name="TextBox 8">
+            <a:extLst>
+              <a:ext uri="{FF2B5EF4-FFF2-40B4-BE49-F238E27FC236}">
+                <a16:creationId xmlns:a16="http://schemas.microsoft.com/office/drawing/2014/main" id="{777BA7B7-84AE-54CC-15A0-B63869BD0720}"/>
+              </a:ext>
+            </a:extLst>
+          </p:cNvPr>
+          <p:cNvSpPr txBox="1"/>
+          <p:nvPr/>
+        </p:nvSpPr>
+        <p:spPr>
+          <a:xfrm>
+            <a:off x="1325873" y="4278079"/>
+            <a:ext cx="2234096" cy="369332"/>
+          </a:xfrm>
+          <a:prstGeom prst="rect">
+            <a:avLst/>
+          </a:prstGeom>
+          <a:noFill/>
+        </p:spPr>
+        <p:txBody>
+          <a:bodyPr wrap="square" rtlCol="0">
+            <a:spAutoFit/>
+          </a:bodyPr>
+          <a:lstStyle/>
+          <a:p>
+            <a:r>
+              <a:rPr lang="en-US" dirty="0">
+                <a:latin typeface="Trebuchet MS" panose="020B0603020202020204" pitchFamily="34" charset="0"/>
+              </a:rPr>
+              <a:t>PowerShell, Bash</a:t>
+            </a:r>
+          </a:p>
+        </p:txBody>
+      </p:sp>
     </p:spTree>
     <p:extLst>
       <p:ext uri="{BB962C8B-B14F-4D97-AF65-F5344CB8AC3E}">

</xml_diff>

<commit_message>
Added an intro slide at the beginning
</commit_message>
<xml_diff>
--- a/presentations/GitHub_Introduction_I-AIR SEO.pptx
+++ b/presentations/GitHub_Introduction_I-AIR SEO.pptx
@@ -5,19 +5,20 @@
     <p:sldMasterId id="2147483648" r:id="rId1"/>
   </p:sldMasterIdLst>
   <p:notesMasterIdLst>
-    <p:notesMasterId r:id="rId12"/>
+    <p:notesMasterId r:id="rId13"/>
   </p:notesMasterIdLst>
   <p:sldIdLst>
     <p:sldId id="256" r:id="rId2"/>
-    <p:sldId id="257" r:id="rId3"/>
-    <p:sldId id="258" r:id="rId4"/>
-    <p:sldId id="264" r:id="rId5"/>
-    <p:sldId id="259" r:id="rId6"/>
-    <p:sldId id="260" r:id="rId7"/>
-    <p:sldId id="261" r:id="rId8"/>
-    <p:sldId id="262" r:id="rId9"/>
-    <p:sldId id="265" r:id="rId10"/>
-    <p:sldId id="263" r:id="rId11"/>
+    <p:sldId id="266" r:id="rId3"/>
+    <p:sldId id="257" r:id="rId4"/>
+    <p:sldId id="258" r:id="rId5"/>
+    <p:sldId id="264" r:id="rId6"/>
+    <p:sldId id="259" r:id="rId7"/>
+    <p:sldId id="260" r:id="rId8"/>
+    <p:sldId id="261" r:id="rId9"/>
+    <p:sldId id="262" r:id="rId10"/>
+    <p:sldId id="265" r:id="rId11"/>
+    <p:sldId id="263" r:id="rId12"/>
   </p:sldIdLst>
   <p:sldSz cx="9144000" cy="5143500" type="screen16x9"/>
   <p:notesSz cx="5143500" cy="9144000"/>
@@ -335,6 +336,114 @@
   <p:cSld>
     <p:spTree>
       <p:nvGrpSpPr>
+        <p:cNvPr id="1" name="">
+          <a:extLst>
+            <a:ext uri="{FF2B5EF4-FFF2-40B4-BE49-F238E27FC236}">
+              <a16:creationId xmlns:a16="http://schemas.microsoft.com/office/drawing/2014/main" id="{37DA7EE9-EE33-2D58-74A6-73BE590AA139}"/>
+            </a:ext>
+          </a:extLst>
+        </p:cNvPr>
+        <p:cNvGrpSpPr/>
+        <p:nvPr/>
+      </p:nvGrpSpPr>
+      <p:grpSpPr>
+        <a:xfrm>
+          <a:off x="0" y="0"/>
+          <a:ext cx="0" cy="0"/>
+          <a:chOff x="0" y="0"/>
+          <a:chExt cx="0" cy="0"/>
+        </a:xfrm>
+      </p:grpSpPr>
+      <p:sp>
+        <p:nvSpPr>
+          <p:cNvPr id="2" name="Slide Image Placeholder 1">
+            <a:extLst>
+              <a:ext uri="{FF2B5EF4-FFF2-40B4-BE49-F238E27FC236}">
+                <a16:creationId xmlns:a16="http://schemas.microsoft.com/office/drawing/2014/main" id="{F08E9422-6E15-9ECF-BE9A-3F39B55945DA}"/>
+              </a:ext>
+            </a:extLst>
+          </p:cNvPr>
+          <p:cNvSpPr>
+            <a:spLocks noGrp="1" noRot="1" noChangeAspect="1"/>
+          </p:cNvSpPr>
+          <p:nvPr>
+            <p:ph type="sldImg"/>
+          </p:nvPr>
+        </p:nvSpPr>
+        <p:spPr/>
+      </p:sp>
+      <p:sp>
+        <p:nvSpPr>
+          <p:cNvPr id="3" name="Notes Placeholder 2">
+            <a:extLst>
+              <a:ext uri="{FF2B5EF4-FFF2-40B4-BE49-F238E27FC236}">
+                <a16:creationId xmlns:a16="http://schemas.microsoft.com/office/drawing/2014/main" id="{53147C36-9807-763B-E599-BD54799120F8}"/>
+              </a:ext>
+            </a:extLst>
+          </p:cNvPr>
+          <p:cNvSpPr>
+            <a:spLocks noGrp="1"/>
+          </p:cNvSpPr>
+          <p:nvPr>
+            <p:ph type="body" idx="1"/>
+          </p:nvPr>
+        </p:nvSpPr>
+        <p:spPr/>
+        <p:txBody>
+          <a:bodyPr/>
+          <a:lstStyle/>
+          <a:p>
+            <a:endParaRPr lang="en-US" dirty="0"/>
+          </a:p>
+        </p:txBody>
+      </p:sp>
+      <p:sp>
+        <p:nvSpPr>
+          <p:cNvPr id="4" name="Slide Number Placeholder 3">
+            <a:extLst>
+              <a:ext uri="{FF2B5EF4-FFF2-40B4-BE49-F238E27FC236}">
+                <a16:creationId xmlns:a16="http://schemas.microsoft.com/office/drawing/2014/main" id="{9EFD2847-C24B-C23A-5FA4-CF06C7499A76}"/>
+              </a:ext>
+            </a:extLst>
+          </p:cNvPr>
+          <p:cNvSpPr>
+            <a:spLocks noGrp="1"/>
+          </p:cNvSpPr>
+          <p:nvPr>
+            <p:ph type="sldNum" sz="quarter" idx="10"/>
+          </p:nvPr>
+        </p:nvSpPr>
+        <p:spPr/>
+        <p:txBody>
+          <a:bodyPr/>
+          <a:lstStyle/>
+          <a:p>
+            <a:fld id="{F7021451-1387-4CA6-816F-3879F97B5CBC}" type="slidenum">
+              <a:rPr lang="en-US"/>
+              <a:t>10</a:t>
+            </a:fld>
+            <a:endParaRPr lang="en-US"/>
+          </a:p>
+        </p:txBody>
+      </p:sp>
+    </p:spTree>
+    <p:extLst>
+      <p:ext uri="{BB962C8B-B14F-4D97-AF65-F5344CB8AC3E}">
+        <p14:creationId xmlns:p14="http://schemas.microsoft.com/office/powerpoint/2010/main" val="3858462183"/>
+      </p:ext>
+    </p:extLst>
+  </p:cSld>
+  <p:clrMapOvr>
+    <a:masterClrMapping/>
+  </p:clrMapOvr>
+</p:notes>
+</file>
+
+<file path=ppt/notesSlides/notesSlide11.xml><?xml version="1.0" encoding="utf-8"?>
+<p:notes xmlns:a="http://schemas.openxmlformats.org/drawingml/2006/main" xmlns:r="http://schemas.openxmlformats.org/officeDocument/2006/relationships" xmlns:p="http://schemas.openxmlformats.org/presentationml/2006/main">
+  <p:cSld>
+    <p:spTree>
+      <p:nvGrpSpPr>
         <p:cNvPr id="1" name=""/>
         <p:cNvGrpSpPr/>
         <p:nvPr/>
@@ -395,7 +504,7 @@
           <a:p>
             <a:fld id="{F7021451-1387-4CA6-816F-3879F97B5CBC}" type="slidenum">
               <a:rPr lang="en-US"/>
-              <a:t>10</a:t>
+              <a:t>11</a:t>
             </a:fld>
             <a:endParaRPr lang="en-US"/>
           </a:p>
@@ -419,7 +528,13 @@
   <p:cSld>
     <p:spTree>
       <p:nvGrpSpPr>
-        <p:cNvPr id="1" name=""/>
+        <p:cNvPr id="1" name="">
+          <a:extLst>
+            <a:ext uri="{FF2B5EF4-FFF2-40B4-BE49-F238E27FC236}">
+              <a16:creationId xmlns:a16="http://schemas.microsoft.com/office/drawing/2014/main" id="{C28171BC-AA59-4042-0D58-B1BB0870CFC8}"/>
+            </a:ext>
+          </a:extLst>
+        </p:cNvPr>
         <p:cNvGrpSpPr/>
         <p:nvPr/>
       </p:nvGrpSpPr>
@@ -433,7 +548,13 @@
       </p:grpSpPr>
       <p:sp>
         <p:nvSpPr>
-          <p:cNvPr id="2" name="Slide Image Placeholder 1"/>
+          <p:cNvPr id="2" name="Slide Image Placeholder 1">
+            <a:extLst>
+              <a:ext uri="{FF2B5EF4-FFF2-40B4-BE49-F238E27FC236}">
+                <a16:creationId xmlns:a16="http://schemas.microsoft.com/office/drawing/2014/main" id="{146BD232-AE7C-8CFC-E87D-044DBFD73806}"/>
+              </a:ext>
+            </a:extLst>
+          </p:cNvPr>
           <p:cNvSpPr>
             <a:spLocks noGrp="1" noRot="1" noChangeAspect="1"/>
           </p:cNvSpPr>
@@ -445,7 +566,13 @@
       </p:sp>
       <p:sp>
         <p:nvSpPr>
-          <p:cNvPr id="3" name="Notes Placeholder 2"/>
+          <p:cNvPr id="3" name="Notes Placeholder 2">
+            <a:extLst>
+              <a:ext uri="{FF2B5EF4-FFF2-40B4-BE49-F238E27FC236}">
+                <a16:creationId xmlns:a16="http://schemas.microsoft.com/office/drawing/2014/main" id="{85F56DD5-6A98-B030-59A8-63A3E43CBABE}"/>
+              </a:ext>
+            </a:extLst>
+          </p:cNvPr>
           <p:cNvSpPr>
             <a:spLocks noGrp="1"/>
           </p:cNvSpPr>
@@ -464,7 +591,13 @@
       </p:sp>
       <p:sp>
         <p:nvSpPr>
-          <p:cNvPr id="4" name="Slide Number Placeholder 3"/>
+          <p:cNvPr id="4" name="Slide Number Placeholder 3">
+            <a:extLst>
+              <a:ext uri="{FF2B5EF4-FFF2-40B4-BE49-F238E27FC236}">
+                <a16:creationId xmlns:a16="http://schemas.microsoft.com/office/drawing/2014/main" id="{5160046B-B2D5-D499-BB05-0DAD1059401F}"/>
+              </a:ext>
+            </a:extLst>
+          </p:cNvPr>
           <p:cNvSpPr>
             <a:spLocks noGrp="1"/>
           </p:cNvSpPr>
@@ -488,7 +621,7 @@
     </p:spTree>
     <p:extLst>
       <p:ext uri="{BB962C8B-B14F-4D97-AF65-F5344CB8AC3E}">
-        <p14:creationId xmlns:p14="http://schemas.microsoft.com/office/powerpoint/2010/main" val="1024086991"/>
+        <p14:creationId xmlns:p14="http://schemas.microsoft.com/office/powerpoint/2010/main" val="470584970"/>
       </p:ext>
     </p:extLst>
   </p:cSld>
@@ -587,6 +720,90 @@
   <p:cSld>
     <p:spTree>
       <p:nvGrpSpPr>
+        <p:cNvPr id="1" name=""/>
+        <p:cNvGrpSpPr/>
+        <p:nvPr/>
+      </p:nvGrpSpPr>
+      <p:grpSpPr>
+        <a:xfrm>
+          <a:off x="0" y="0"/>
+          <a:ext cx="0" cy="0"/>
+          <a:chOff x="0" y="0"/>
+          <a:chExt cx="0" cy="0"/>
+        </a:xfrm>
+      </p:grpSpPr>
+      <p:sp>
+        <p:nvSpPr>
+          <p:cNvPr id="2" name="Slide Image Placeholder 1"/>
+          <p:cNvSpPr>
+            <a:spLocks noGrp="1" noRot="1" noChangeAspect="1"/>
+          </p:cNvSpPr>
+          <p:nvPr>
+            <p:ph type="sldImg"/>
+          </p:nvPr>
+        </p:nvSpPr>
+        <p:spPr/>
+      </p:sp>
+      <p:sp>
+        <p:nvSpPr>
+          <p:cNvPr id="3" name="Notes Placeholder 2"/>
+          <p:cNvSpPr>
+            <a:spLocks noGrp="1"/>
+          </p:cNvSpPr>
+          <p:nvPr>
+            <p:ph type="body" idx="1"/>
+          </p:nvPr>
+        </p:nvSpPr>
+        <p:spPr/>
+        <p:txBody>
+          <a:bodyPr/>
+          <a:lstStyle/>
+          <a:p>
+            <a:endParaRPr lang="en-US" dirty="0"/>
+          </a:p>
+        </p:txBody>
+      </p:sp>
+      <p:sp>
+        <p:nvSpPr>
+          <p:cNvPr id="4" name="Slide Number Placeholder 3"/>
+          <p:cNvSpPr>
+            <a:spLocks noGrp="1"/>
+          </p:cNvSpPr>
+          <p:nvPr>
+            <p:ph type="sldNum" sz="quarter" idx="10"/>
+          </p:nvPr>
+        </p:nvSpPr>
+        <p:spPr/>
+        <p:txBody>
+          <a:bodyPr/>
+          <a:lstStyle/>
+          <a:p>
+            <a:fld id="{F7021451-1387-4CA6-816F-3879F97B5CBC}" type="slidenum">
+              <a:rPr lang="en-US"/>
+              <a:t>4</a:t>
+            </a:fld>
+            <a:endParaRPr lang="en-US"/>
+          </a:p>
+        </p:txBody>
+      </p:sp>
+    </p:spTree>
+    <p:extLst>
+      <p:ext uri="{BB962C8B-B14F-4D97-AF65-F5344CB8AC3E}">
+        <p14:creationId xmlns:p14="http://schemas.microsoft.com/office/powerpoint/2010/main" val="1024086991"/>
+      </p:ext>
+    </p:extLst>
+  </p:cSld>
+  <p:clrMapOvr>
+    <a:masterClrMapping/>
+  </p:clrMapOvr>
+</p:notes>
+</file>
+
+<file path=ppt/notesSlides/notesSlide5.xml><?xml version="1.0" encoding="utf-8"?>
+<p:notes xmlns:a="http://schemas.openxmlformats.org/drawingml/2006/main" xmlns:r="http://schemas.openxmlformats.org/officeDocument/2006/relationships" xmlns:p="http://schemas.openxmlformats.org/presentationml/2006/main">
+  <p:cSld>
+    <p:spTree>
+      <p:nvGrpSpPr>
         <p:cNvPr id="1" name="">
           <a:extLst>
             <a:ext uri="{FF2B5EF4-FFF2-40B4-BE49-F238E27FC236}">
@@ -671,7 +888,7 @@
           <a:p>
             <a:fld id="{F7021451-1387-4CA6-816F-3879F97B5CBC}" type="slidenum">
               <a:rPr lang="en-US"/>
-              <a:t>4</a:t>
+              <a:t>5</a:t>
             </a:fld>
             <a:endParaRPr lang="en-US"/>
           </a:p>
@@ -681,90 +898,6 @@
     <p:extLst>
       <p:ext uri="{BB962C8B-B14F-4D97-AF65-F5344CB8AC3E}">
         <p14:creationId xmlns:p14="http://schemas.microsoft.com/office/powerpoint/2010/main" val="3969942519"/>
-      </p:ext>
-    </p:extLst>
-  </p:cSld>
-  <p:clrMapOvr>
-    <a:masterClrMapping/>
-  </p:clrMapOvr>
-</p:notes>
-</file>
-
-<file path=ppt/notesSlides/notesSlide5.xml><?xml version="1.0" encoding="utf-8"?>
-<p:notes xmlns:a="http://schemas.openxmlformats.org/drawingml/2006/main" xmlns:r="http://schemas.openxmlformats.org/officeDocument/2006/relationships" xmlns:p="http://schemas.openxmlformats.org/presentationml/2006/main">
-  <p:cSld>
-    <p:spTree>
-      <p:nvGrpSpPr>
-        <p:cNvPr id="1" name=""/>
-        <p:cNvGrpSpPr/>
-        <p:nvPr/>
-      </p:nvGrpSpPr>
-      <p:grpSpPr>
-        <a:xfrm>
-          <a:off x="0" y="0"/>
-          <a:ext cx="0" cy="0"/>
-          <a:chOff x="0" y="0"/>
-          <a:chExt cx="0" cy="0"/>
-        </a:xfrm>
-      </p:grpSpPr>
-      <p:sp>
-        <p:nvSpPr>
-          <p:cNvPr id="2" name="Slide Image Placeholder 1"/>
-          <p:cNvSpPr>
-            <a:spLocks noGrp="1" noRot="1" noChangeAspect="1"/>
-          </p:cNvSpPr>
-          <p:nvPr>
-            <p:ph type="sldImg"/>
-          </p:nvPr>
-        </p:nvSpPr>
-        <p:spPr/>
-      </p:sp>
-      <p:sp>
-        <p:nvSpPr>
-          <p:cNvPr id="3" name="Notes Placeholder 2"/>
-          <p:cNvSpPr>
-            <a:spLocks noGrp="1"/>
-          </p:cNvSpPr>
-          <p:nvPr>
-            <p:ph type="body" idx="1"/>
-          </p:nvPr>
-        </p:nvSpPr>
-        <p:spPr/>
-        <p:txBody>
-          <a:bodyPr/>
-          <a:lstStyle/>
-          <a:p>
-            <a:endParaRPr lang="en-US" dirty="0"/>
-          </a:p>
-        </p:txBody>
-      </p:sp>
-      <p:sp>
-        <p:nvSpPr>
-          <p:cNvPr id="4" name="Slide Number Placeholder 3"/>
-          <p:cNvSpPr>
-            <a:spLocks noGrp="1"/>
-          </p:cNvSpPr>
-          <p:nvPr>
-            <p:ph type="sldNum" sz="quarter" idx="10"/>
-          </p:nvPr>
-        </p:nvSpPr>
-        <p:spPr/>
-        <p:txBody>
-          <a:bodyPr/>
-          <a:lstStyle/>
-          <a:p>
-            <a:fld id="{F7021451-1387-4CA6-816F-3879F97B5CBC}" type="slidenum">
-              <a:rPr lang="en-US"/>
-              <a:t>5</a:t>
-            </a:fld>
-            <a:endParaRPr lang="en-US"/>
-          </a:p>
-        </p:txBody>
-      </p:sp>
-    </p:spTree>
-    <p:extLst>
-      <p:ext uri="{BB962C8B-B14F-4D97-AF65-F5344CB8AC3E}">
-        <p14:creationId xmlns:p14="http://schemas.microsoft.com/office/powerpoint/2010/main" val="1024086991"/>
       </p:ext>
     </p:extLst>
   </p:cSld>
@@ -1031,13 +1164,7 @@
   <p:cSld>
     <p:spTree>
       <p:nvGrpSpPr>
-        <p:cNvPr id="1" name="">
-          <a:extLst>
-            <a:ext uri="{FF2B5EF4-FFF2-40B4-BE49-F238E27FC236}">
-              <a16:creationId xmlns:a16="http://schemas.microsoft.com/office/drawing/2014/main" id="{37DA7EE9-EE33-2D58-74A6-73BE590AA139}"/>
-            </a:ext>
-          </a:extLst>
-        </p:cNvPr>
+        <p:cNvPr id="1" name=""/>
         <p:cNvGrpSpPr/>
         <p:nvPr/>
       </p:nvGrpSpPr>
@@ -1051,13 +1178,7 @@
       </p:grpSpPr>
       <p:sp>
         <p:nvSpPr>
-          <p:cNvPr id="2" name="Slide Image Placeholder 1">
-            <a:extLst>
-              <a:ext uri="{FF2B5EF4-FFF2-40B4-BE49-F238E27FC236}">
-                <a16:creationId xmlns:a16="http://schemas.microsoft.com/office/drawing/2014/main" id="{F08E9422-6E15-9ECF-BE9A-3F39B55945DA}"/>
-              </a:ext>
-            </a:extLst>
-          </p:cNvPr>
+          <p:cNvPr id="2" name="Slide Image Placeholder 1"/>
           <p:cNvSpPr>
             <a:spLocks noGrp="1" noRot="1" noChangeAspect="1"/>
           </p:cNvSpPr>
@@ -1069,13 +1190,7 @@
       </p:sp>
       <p:sp>
         <p:nvSpPr>
-          <p:cNvPr id="3" name="Notes Placeholder 2">
-            <a:extLst>
-              <a:ext uri="{FF2B5EF4-FFF2-40B4-BE49-F238E27FC236}">
-                <a16:creationId xmlns:a16="http://schemas.microsoft.com/office/drawing/2014/main" id="{53147C36-9807-763B-E599-BD54799120F8}"/>
-              </a:ext>
-            </a:extLst>
-          </p:cNvPr>
+          <p:cNvPr id="3" name="Notes Placeholder 2"/>
           <p:cNvSpPr>
             <a:spLocks noGrp="1"/>
           </p:cNvSpPr>
@@ -1094,13 +1209,7 @@
       </p:sp>
       <p:sp>
         <p:nvSpPr>
-          <p:cNvPr id="4" name="Slide Number Placeholder 3">
-            <a:extLst>
-              <a:ext uri="{FF2B5EF4-FFF2-40B4-BE49-F238E27FC236}">
-                <a16:creationId xmlns:a16="http://schemas.microsoft.com/office/drawing/2014/main" id="{9EFD2847-C24B-C23A-5FA4-CF06C7499A76}"/>
-              </a:ext>
-            </a:extLst>
-          </p:cNvPr>
+          <p:cNvPr id="4" name="Slide Number Placeholder 3"/>
           <p:cNvSpPr>
             <a:spLocks noGrp="1"/>
           </p:cNvSpPr>
@@ -1124,7 +1233,7 @@
     </p:spTree>
     <p:extLst>
       <p:ext uri="{BB962C8B-B14F-4D97-AF65-F5344CB8AC3E}">
-        <p14:creationId xmlns:p14="http://schemas.microsoft.com/office/powerpoint/2010/main" val="3858462183"/>
+        <p14:creationId xmlns:p14="http://schemas.microsoft.com/office/powerpoint/2010/main" val="1024086991"/>
       </p:ext>
     </p:extLst>
   </p:cSld>
@@ -1774,6 +1883,313 @@
 
 <file path=ppt/slides/slide10.xml><?xml version="1.0" encoding="utf-8"?>
 <p:sld xmlns:a="http://schemas.openxmlformats.org/drawingml/2006/main" xmlns:r="http://schemas.openxmlformats.org/officeDocument/2006/relationships" xmlns:p="http://schemas.openxmlformats.org/presentationml/2006/main">
+  <p:cSld>
+    <p:bg>
+      <p:bgPr>
+        <a:solidFill>
+          <a:srgbClr val="F8FAFC"/>
+        </a:solidFill>
+        <a:effectLst/>
+      </p:bgPr>
+    </p:bg>
+    <p:spTree>
+      <p:nvGrpSpPr>
+        <p:cNvPr id="1" name="">
+          <a:extLst>
+            <a:ext uri="{FF2B5EF4-FFF2-40B4-BE49-F238E27FC236}">
+              <a16:creationId xmlns:a16="http://schemas.microsoft.com/office/drawing/2014/main" id="{9F406B75-1449-6A1D-FDAD-179B1E6C43CE}"/>
+            </a:ext>
+          </a:extLst>
+        </p:cNvPr>
+        <p:cNvGrpSpPr/>
+        <p:nvPr/>
+      </p:nvGrpSpPr>
+      <p:grpSpPr>
+        <a:xfrm>
+          <a:off x="0" y="0"/>
+          <a:ext cx="0" cy="0"/>
+          <a:chOff x="0" y="0"/>
+          <a:chExt cx="0" cy="0"/>
+        </a:xfrm>
+      </p:grpSpPr>
+      <p:sp>
+        <p:nvSpPr>
+          <p:cNvPr id="2" name="Shape 0">
+            <a:extLst>
+              <a:ext uri="{FF2B5EF4-FFF2-40B4-BE49-F238E27FC236}">
+                <a16:creationId xmlns:a16="http://schemas.microsoft.com/office/drawing/2014/main" id="{453BF832-C707-02ED-995A-4F56C40DA5E7}"/>
+              </a:ext>
+            </a:extLst>
+          </p:cNvPr>
+          <p:cNvSpPr/>
+          <p:nvPr/>
+        </p:nvSpPr>
+        <p:spPr>
+          <a:xfrm>
+            <a:off x="457200" y="256032"/>
+            <a:ext cx="1645920" cy="256032"/>
+          </a:xfrm>
+          <a:prstGeom prst="rect">
+            <a:avLst/>
+          </a:prstGeom>
+          <a:solidFill>
+            <a:srgbClr val="0D9488"/>
+          </a:solidFill>
+          <a:ln w="12700">
+            <a:solidFill>
+              <a:srgbClr val="0D9488"/>
+            </a:solidFill>
+            <a:prstDash val="solid"/>
+          </a:ln>
+        </p:spPr>
+        <p:txBody>
+          <a:bodyPr/>
+          <a:lstStyle/>
+          <a:p>
+            <a:endParaRPr lang="en-US"/>
+          </a:p>
+        </p:txBody>
+      </p:sp>
+      <p:sp>
+        <p:nvSpPr>
+          <p:cNvPr id="3" name="Text 1">
+            <a:extLst>
+              <a:ext uri="{FF2B5EF4-FFF2-40B4-BE49-F238E27FC236}">
+                <a16:creationId xmlns:a16="http://schemas.microsoft.com/office/drawing/2014/main" id="{0A102B6D-101A-6D16-9C61-4700771DACE8}"/>
+              </a:ext>
+            </a:extLst>
+          </p:cNvPr>
+          <p:cNvSpPr/>
+          <p:nvPr/>
+        </p:nvSpPr>
+        <p:spPr>
+          <a:xfrm>
+            <a:off x="457200" y="256032"/>
+            <a:ext cx="1645920" cy="256032"/>
+          </a:xfrm>
+          <a:prstGeom prst="rect">
+            <a:avLst/>
+          </a:prstGeom>
+          <a:noFill/>
+          <a:ln/>
+        </p:spPr>
+        <p:txBody>
+          <a:bodyPr wrap="square" lIns="0" tIns="0" rIns="0" bIns="0" rtlCol="0" anchor="ctr"/>
+          <a:lstStyle/>
+          <a:p>
+            <a:pPr marL="0" indent="0" algn="ctr">
+              <a:buNone/>
+            </a:pPr>
+            <a:r>
+              <a:rPr lang="en-US" sz="800" b="1" dirty="0">
+                <a:solidFill>
+                  <a:srgbClr val="FFFFFF"/>
+                </a:solidFill>
+              </a:rPr>
+              <a:t>GIT TOOLS</a:t>
+            </a:r>
+            <a:endParaRPr lang="en-US" sz="800" dirty="0"/>
+          </a:p>
+        </p:txBody>
+      </p:sp>
+      <p:sp>
+        <p:nvSpPr>
+          <p:cNvPr id="4" name="Text 2">
+            <a:extLst>
+              <a:ext uri="{FF2B5EF4-FFF2-40B4-BE49-F238E27FC236}">
+                <a16:creationId xmlns:a16="http://schemas.microsoft.com/office/drawing/2014/main" id="{7EABA8D3-0DC9-3DA4-2BF7-AAE9FCA961DB}"/>
+              </a:ext>
+            </a:extLst>
+          </p:cNvPr>
+          <p:cNvSpPr/>
+          <p:nvPr/>
+        </p:nvSpPr>
+        <p:spPr>
+          <a:xfrm>
+            <a:off x="457200" y="594360"/>
+            <a:ext cx="8229600" cy="548640"/>
+          </a:xfrm>
+          <a:prstGeom prst="rect">
+            <a:avLst/>
+          </a:prstGeom>
+          <a:noFill/>
+          <a:ln/>
+        </p:spPr>
+        <p:txBody>
+          <a:bodyPr wrap="square" rtlCol="0" anchor="ctr"/>
+          <a:lstStyle/>
+          <a:p>
+            <a:pPr marL="0" indent="0">
+              <a:buNone/>
+            </a:pPr>
+            <a:r>
+              <a:rPr lang="en-US" sz="2800" b="1" dirty="0">
+                <a:latin typeface="Trebuchet MS" panose="020B0603020202020204" pitchFamily="34" charset="0"/>
+              </a:rPr>
+              <a:t>CLI or GUI tools are available</a:t>
+            </a:r>
+          </a:p>
+        </p:txBody>
+      </p:sp>
+      <p:pic>
+        <p:nvPicPr>
+          <p:cNvPr id="44" name="Picture 43">
+            <a:extLst>
+              <a:ext uri="{FF2B5EF4-FFF2-40B4-BE49-F238E27FC236}">
+                <a16:creationId xmlns:a16="http://schemas.microsoft.com/office/drawing/2014/main" id="{0D7BA612-DDD4-376F-C73C-DED8DCCAC335}"/>
+              </a:ext>
+            </a:extLst>
+          </p:cNvPr>
+          <p:cNvPicPr>
+            <a:picLocks noChangeAspect="1"/>
+          </p:cNvPicPr>
+          <p:nvPr/>
+        </p:nvPicPr>
+        <p:blipFill>
+          <a:blip r:embed="rId3"/>
+          <a:stretch>
+            <a:fillRect/>
+          </a:stretch>
+        </p:blipFill>
+        <p:spPr>
+          <a:xfrm>
+            <a:off x="940172" y="1338790"/>
+            <a:ext cx="2955461" cy="2816981"/>
+          </a:xfrm>
+          <a:prstGeom prst="rect">
+            <a:avLst/>
+          </a:prstGeom>
+          <a:ln>
+            <a:solidFill>
+              <a:srgbClr val="002060"/>
+            </a:solidFill>
+          </a:ln>
+        </p:spPr>
+      </p:pic>
+      <p:pic>
+        <p:nvPicPr>
+          <p:cNvPr id="7" name="Picture 6">
+            <a:extLst>
+              <a:ext uri="{FF2B5EF4-FFF2-40B4-BE49-F238E27FC236}">
+                <a16:creationId xmlns:a16="http://schemas.microsoft.com/office/drawing/2014/main" id="{A6D155BB-BF2F-436B-74E5-1AA052AB2D6D}"/>
+              </a:ext>
+            </a:extLst>
+          </p:cNvPr>
+          <p:cNvPicPr>
+            <a:picLocks noChangeAspect="1"/>
+          </p:cNvPicPr>
+          <p:nvPr/>
+        </p:nvPicPr>
+        <p:blipFill>
+          <a:blip r:embed="rId4"/>
+          <a:stretch>
+            <a:fillRect/>
+          </a:stretch>
+        </p:blipFill>
+        <p:spPr>
+          <a:xfrm>
+            <a:off x="5025938" y="1338790"/>
+            <a:ext cx="3102700" cy="2813223"/>
+          </a:xfrm>
+          <a:prstGeom prst="rect">
+            <a:avLst/>
+          </a:prstGeom>
+          <a:ln>
+            <a:solidFill>
+              <a:srgbClr val="002060"/>
+            </a:solidFill>
+          </a:ln>
+        </p:spPr>
+      </p:pic>
+      <p:sp>
+        <p:nvSpPr>
+          <p:cNvPr id="8" name="TextBox 7">
+            <a:extLst>
+              <a:ext uri="{FF2B5EF4-FFF2-40B4-BE49-F238E27FC236}">
+                <a16:creationId xmlns:a16="http://schemas.microsoft.com/office/drawing/2014/main" id="{C6C2F74B-DE91-0A64-C9BB-3E1490EAF592}"/>
+              </a:ext>
+            </a:extLst>
+          </p:cNvPr>
+          <p:cNvSpPr txBox="1"/>
+          <p:nvPr/>
+        </p:nvSpPr>
+        <p:spPr>
+          <a:xfrm>
+            <a:off x="5793024" y="4278079"/>
+            <a:ext cx="1881051" cy="369332"/>
+          </a:xfrm>
+          <a:prstGeom prst="rect">
+            <a:avLst/>
+          </a:prstGeom>
+          <a:noFill/>
+        </p:spPr>
+        <p:txBody>
+          <a:bodyPr wrap="square" rtlCol="0">
+            <a:spAutoFit/>
+          </a:bodyPr>
+          <a:lstStyle/>
+          <a:p>
+            <a:r>
+              <a:rPr lang="en-US" dirty="0">
+                <a:latin typeface="Trebuchet MS" panose="020B0603020202020204" pitchFamily="34" charset="0"/>
+              </a:rPr>
+              <a:t>GitHub Desktop</a:t>
+            </a:r>
+          </a:p>
+        </p:txBody>
+      </p:sp>
+      <p:sp>
+        <p:nvSpPr>
+          <p:cNvPr id="9" name="TextBox 8">
+            <a:extLst>
+              <a:ext uri="{FF2B5EF4-FFF2-40B4-BE49-F238E27FC236}">
+                <a16:creationId xmlns:a16="http://schemas.microsoft.com/office/drawing/2014/main" id="{777BA7B7-84AE-54CC-15A0-B63869BD0720}"/>
+              </a:ext>
+            </a:extLst>
+          </p:cNvPr>
+          <p:cNvSpPr txBox="1"/>
+          <p:nvPr/>
+        </p:nvSpPr>
+        <p:spPr>
+          <a:xfrm>
+            <a:off x="1325873" y="4278079"/>
+            <a:ext cx="2234096" cy="369332"/>
+          </a:xfrm>
+          <a:prstGeom prst="rect">
+            <a:avLst/>
+          </a:prstGeom>
+          <a:noFill/>
+        </p:spPr>
+        <p:txBody>
+          <a:bodyPr wrap="square" rtlCol="0">
+            <a:spAutoFit/>
+          </a:bodyPr>
+          <a:lstStyle/>
+          <a:p>
+            <a:r>
+              <a:rPr lang="en-US" dirty="0">
+                <a:latin typeface="Trebuchet MS" panose="020B0603020202020204" pitchFamily="34" charset="0"/>
+              </a:rPr>
+              <a:t>PowerShell, Bash</a:t>
+            </a:r>
+          </a:p>
+        </p:txBody>
+      </p:sp>
+    </p:spTree>
+    <p:extLst>
+      <p:ext uri="{BB962C8B-B14F-4D97-AF65-F5344CB8AC3E}">
+        <p14:creationId xmlns:p14="http://schemas.microsoft.com/office/powerpoint/2010/main" val="446247213"/>
+      </p:ext>
+    </p:extLst>
+  </p:cSld>
+  <p:clrMapOvr>
+    <a:masterClrMapping/>
+  </p:clrMapOvr>
+</p:sld>
+</file>
+
+<file path=ppt/slides/slide11.xml><?xml version="1.0" encoding="utf-8"?>
+<p:sld xmlns:a="http://schemas.openxmlformats.org/drawingml/2006/main" xmlns:r="http://schemas.openxmlformats.org/officeDocument/2006/relationships" xmlns:p="http://schemas.openxmlformats.org/presentationml/2006/main">
   <p:cSld name="Slide 8">
     <p:bg>
       <p:bgPr>
@@ -2519,6 +2935,214 @@
 </file>
 
 <file path=ppt/slides/slide2.xml><?xml version="1.0" encoding="utf-8"?>
+<p:sld xmlns:a="http://schemas.openxmlformats.org/drawingml/2006/main" xmlns:r="http://schemas.openxmlformats.org/officeDocument/2006/relationships" xmlns:p="http://schemas.openxmlformats.org/presentationml/2006/main">
+  <p:cSld>
+    <p:spTree>
+      <p:nvGrpSpPr>
+        <p:cNvPr id="1" name="">
+          <a:extLst>
+            <a:ext uri="{FF2B5EF4-FFF2-40B4-BE49-F238E27FC236}">
+              <a16:creationId xmlns:a16="http://schemas.microsoft.com/office/drawing/2014/main" id="{B3224C96-02FE-2DFE-D24B-AAC3DE0E2BA0}"/>
+            </a:ext>
+          </a:extLst>
+        </p:cNvPr>
+        <p:cNvGrpSpPr/>
+        <p:nvPr/>
+      </p:nvGrpSpPr>
+      <p:grpSpPr>
+        <a:xfrm>
+          <a:off x="0" y="0"/>
+          <a:ext cx="0" cy="0"/>
+          <a:chOff x="0" y="0"/>
+          <a:chExt cx="0" cy="0"/>
+        </a:xfrm>
+      </p:grpSpPr>
+      <p:sp>
+        <p:nvSpPr>
+          <p:cNvPr id="2" name="Shape 0">
+            <a:extLst>
+              <a:ext uri="{FF2B5EF4-FFF2-40B4-BE49-F238E27FC236}">
+                <a16:creationId xmlns:a16="http://schemas.microsoft.com/office/drawing/2014/main" id="{B06649D5-372A-27DD-AE6B-1737927F70FE}"/>
+              </a:ext>
+            </a:extLst>
+          </p:cNvPr>
+          <p:cNvSpPr/>
+          <p:nvPr/>
+        </p:nvSpPr>
+        <p:spPr>
+          <a:xfrm>
+            <a:off x="457200" y="256032"/>
+            <a:ext cx="1645920" cy="256032"/>
+          </a:xfrm>
+          <a:prstGeom prst="rect">
+            <a:avLst/>
+          </a:prstGeom>
+          <a:solidFill>
+            <a:srgbClr val="0D9488"/>
+          </a:solidFill>
+          <a:ln w="12700">
+            <a:solidFill>
+              <a:srgbClr val="0D9488"/>
+            </a:solidFill>
+            <a:prstDash val="solid"/>
+          </a:ln>
+        </p:spPr>
+        <p:txBody>
+          <a:bodyPr/>
+          <a:lstStyle/>
+          <a:p>
+            <a:endParaRPr lang="en-US"/>
+          </a:p>
+        </p:txBody>
+      </p:sp>
+      <p:sp>
+        <p:nvSpPr>
+          <p:cNvPr id="3" name="Text 1">
+            <a:extLst>
+              <a:ext uri="{FF2B5EF4-FFF2-40B4-BE49-F238E27FC236}">
+                <a16:creationId xmlns:a16="http://schemas.microsoft.com/office/drawing/2014/main" id="{70C018EB-C44A-77E4-35F2-BE82AD35816C}"/>
+              </a:ext>
+            </a:extLst>
+          </p:cNvPr>
+          <p:cNvSpPr/>
+          <p:nvPr/>
+        </p:nvSpPr>
+        <p:spPr>
+          <a:xfrm>
+            <a:off x="457200" y="256032"/>
+            <a:ext cx="1645920" cy="256032"/>
+          </a:xfrm>
+          <a:prstGeom prst="rect">
+            <a:avLst/>
+          </a:prstGeom>
+          <a:noFill/>
+          <a:ln/>
+        </p:spPr>
+        <p:txBody>
+          <a:bodyPr wrap="square" lIns="0" tIns="0" rIns="0" bIns="0" rtlCol="0" anchor="ctr"/>
+          <a:lstStyle/>
+          <a:p>
+            <a:pPr marL="0" indent="0" algn="ctr">
+              <a:buNone/>
+            </a:pPr>
+            <a:r>
+              <a:rPr lang="en-US" sz="800" b="1" dirty="0">
+                <a:solidFill>
+                  <a:srgbClr val="FFFFFF"/>
+                </a:solidFill>
+              </a:rPr>
+              <a:t>TODAY</a:t>
+            </a:r>
+            <a:endParaRPr lang="en-US" sz="800" dirty="0"/>
+          </a:p>
+        </p:txBody>
+      </p:sp>
+      <p:sp>
+        <p:nvSpPr>
+          <p:cNvPr id="4" name="Text 2">
+            <a:extLst>
+              <a:ext uri="{FF2B5EF4-FFF2-40B4-BE49-F238E27FC236}">
+                <a16:creationId xmlns:a16="http://schemas.microsoft.com/office/drawing/2014/main" id="{CB243527-3759-9BD1-EBCE-D8553AFD72B5}"/>
+              </a:ext>
+            </a:extLst>
+          </p:cNvPr>
+          <p:cNvSpPr/>
+          <p:nvPr/>
+        </p:nvSpPr>
+        <p:spPr>
+          <a:xfrm>
+            <a:off x="457200" y="594360"/>
+            <a:ext cx="8229600" cy="1005840"/>
+          </a:xfrm>
+          <a:prstGeom prst="rect">
+            <a:avLst/>
+          </a:prstGeom>
+          <a:noFill/>
+          <a:ln/>
+        </p:spPr>
+        <p:txBody>
+          <a:bodyPr wrap="square" rtlCol="0" anchor="ctr"/>
+          <a:lstStyle/>
+          <a:p>
+            <a:pPr marL="0" indent="0">
+              <a:buNone/>
+            </a:pPr>
+            <a:r>
+              <a:rPr lang="en-US" sz="3000" b="1" dirty="0">
+                <a:solidFill>
+                  <a:srgbClr val="1E293B"/>
+                </a:solidFill>
+                <a:latin typeface="Trebuchet MS" pitchFamily="34" charset="0"/>
+              </a:rPr>
+              <a:t>Exploring uses for Git/GitHub</a:t>
+            </a:r>
+            <a:endParaRPr lang="en-US" sz="3000" dirty="0"/>
+          </a:p>
+        </p:txBody>
+      </p:sp>
+      <p:sp>
+        <p:nvSpPr>
+          <p:cNvPr id="12" name="TextBox 11">
+            <a:extLst>
+              <a:ext uri="{FF2B5EF4-FFF2-40B4-BE49-F238E27FC236}">
+                <a16:creationId xmlns:a16="http://schemas.microsoft.com/office/drawing/2014/main" id="{3504B851-4A06-45EA-3196-DACA9CA0FB53}"/>
+              </a:ext>
+            </a:extLst>
+          </p:cNvPr>
+          <p:cNvSpPr txBox="1"/>
+          <p:nvPr/>
+        </p:nvSpPr>
+        <p:spPr>
+          <a:xfrm>
+            <a:off x="489857" y="1682496"/>
+            <a:ext cx="7994469" cy="646331"/>
+          </a:xfrm>
+          <a:prstGeom prst="rect">
+            <a:avLst/>
+          </a:prstGeom>
+          <a:noFill/>
+        </p:spPr>
+        <p:txBody>
+          <a:bodyPr wrap="square" rtlCol="0">
+            <a:spAutoFit/>
+          </a:bodyPr>
+          <a:lstStyle/>
+          <a:p>
+            <a:pPr marL="285750" indent="-285750">
+              <a:buFontTx/>
+              <a:buChar char="-"/>
+            </a:pPr>
+            <a:r>
+              <a:rPr lang="en-US" dirty="0"/>
+              <a:t>Teams using Git/GitHub for developing data products - Joel</a:t>
+            </a:r>
+          </a:p>
+          <a:p>
+            <a:pPr marL="285750" indent="-285750">
+              <a:buFontTx/>
+              <a:buChar char="-"/>
+            </a:pPr>
+            <a:r>
+              <a:rPr lang="en-US" dirty="0"/>
+              <a:t>Using GitHub to share common code (accessing, contributing, licenses) - James</a:t>
+            </a:r>
+          </a:p>
+        </p:txBody>
+      </p:sp>
+    </p:spTree>
+    <p:extLst>
+      <p:ext uri="{BB962C8B-B14F-4D97-AF65-F5344CB8AC3E}">
+        <p14:creationId xmlns:p14="http://schemas.microsoft.com/office/powerpoint/2010/main" val="208259732"/>
+      </p:ext>
+    </p:extLst>
+  </p:cSld>
+  <p:clrMapOvr>
+    <a:masterClrMapping/>
+  </p:clrMapOvr>
+</p:sld>
+</file>
+
+<file path=ppt/slides/slide3.xml><?xml version="1.0" encoding="utf-8"?>
 <p:sld xmlns:a="http://schemas.openxmlformats.org/drawingml/2006/main" xmlns:r="http://schemas.openxmlformats.org/officeDocument/2006/relationships" xmlns:p="http://schemas.openxmlformats.org/presentationml/2006/main">
   <p:cSld name="Slide 2">
     <p:bg>
@@ -3327,7 +3951,7 @@
 </p:sld>
 </file>
 
-<file path=ppt/slides/slide3.xml><?xml version="1.0" encoding="utf-8"?>
+<file path=ppt/slides/slide4.xml><?xml version="1.0" encoding="utf-8"?>
 <p:sld xmlns:a="http://schemas.openxmlformats.org/drawingml/2006/main" xmlns:r="http://schemas.openxmlformats.org/officeDocument/2006/relationships" xmlns:p="http://schemas.openxmlformats.org/presentationml/2006/main">
   <p:cSld name="Slide 3">
     <p:bg>
@@ -3783,7 +4407,7 @@
 </p:sld>
 </file>
 
-<file path=ppt/slides/slide4.xml><?xml version="1.0" encoding="utf-8"?>
+<file path=ppt/slides/slide5.xml><?xml version="1.0" encoding="utf-8"?>
 <p:sld xmlns:a="http://schemas.openxmlformats.org/drawingml/2006/main" xmlns:r="http://schemas.openxmlformats.org/officeDocument/2006/relationships" xmlns:p="http://schemas.openxmlformats.org/presentationml/2006/main">
   <p:cSld>
     <p:bg>
@@ -4781,7 +5405,7 @@
 </p:sld>
 </file>
 
-<file path=ppt/slides/slide5.xml><?xml version="1.0" encoding="utf-8"?>
+<file path=ppt/slides/slide6.xml><?xml version="1.0" encoding="utf-8"?>
 <p:sld xmlns:a="http://schemas.openxmlformats.org/drawingml/2006/main" xmlns:r="http://schemas.openxmlformats.org/officeDocument/2006/relationships" xmlns:p="http://schemas.openxmlformats.org/presentationml/2006/main">
   <p:cSld name="Slide 4">
     <p:bg>
@@ -5888,7 +6512,7 @@
 </p:sld>
 </file>
 
-<file path=ppt/slides/slide6.xml><?xml version="1.0" encoding="utf-8"?>
+<file path=ppt/slides/slide7.xml><?xml version="1.0" encoding="utf-8"?>
 <p:sld xmlns:a="http://schemas.openxmlformats.org/drawingml/2006/main" xmlns:r="http://schemas.openxmlformats.org/officeDocument/2006/relationships" xmlns:p="http://schemas.openxmlformats.org/presentationml/2006/main">
   <p:cSld name="Slide 5">
     <p:bg>
@@ -6720,7 +7344,7 @@
 </p:sld>
 </file>
 
-<file path=ppt/slides/slide7.xml><?xml version="1.0" encoding="utf-8"?>
+<file path=ppt/slides/slide8.xml><?xml version="1.0" encoding="utf-8"?>
 <p:sld xmlns:a="http://schemas.openxmlformats.org/drawingml/2006/main" xmlns:r="http://schemas.openxmlformats.org/officeDocument/2006/relationships" xmlns:p="http://schemas.openxmlformats.org/presentationml/2006/main">
   <p:cSld name="Slide 6">
     <p:bg>
@@ -8214,7 +8838,7 @@
 </p:sld>
 </file>
 
-<file path=ppt/slides/slide8.xml><?xml version="1.0" encoding="utf-8"?>
+<file path=ppt/slides/slide9.xml><?xml version="1.0" encoding="utf-8"?>
 <p:sld xmlns:a="http://schemas.openxmlformats.org/drawingml/2006/main" xmlns:r="http://schemas.openxmlformats.org/officeDocument/2006/relationships" xmlns:p="http://schemas.openxmlformats.org/presentationml/2006/main">
   <p:cSld name="Slide 7">
     <p:bg>
@@ -9840,313 +10464,6 @@
         </p:txBody>
       </p:sp>
     </p:spTree>
-  </p:cSld>
-  <p:clrMapOvr>
-    <a:masterClrMapping/>
-  </p:clrMapOvr>
-</p:sld>
-</file>
-
-<file path=ppt/slides/slide9.xml><?xml version="1.0" encoding="utf-8"?>
-<p:sld xmlns:a="http://schemas.openxmlformats.org/drawingml/2006/main" xmlns:r="http://schemas.openxmlformats.org/officeDocument/2006/relationships" xmlns:p="http://schemas.openxmlformats.org/presentationml/2006/main">
-  <p:cSld>
-    <p:bg>
-      <p:bgPr>
-        <a:solidFill>
-          <a:srgbClr val="F8FAFC"/>
-        </a:solidFill>
-        <a:effectLst/>
-      </p:bgPr>
-    </p:bg>
-    <p:spTree>
-      <p:nvGrpSpPr>
-        <p:cNvPr id="1" name="">
-          <a:extLst>
-            <a:ext uri="{FF2B5EF4-FFF2-40B4-BE49-F238E27FC236}">
-              <a16:creationId xmlns:a16="http://schemas.microsoft.com/office/drawing/2014/main" id="{9F406B75-1449-6A1D-FDAD-179B1E6C43CE}"/>
-            </a:ext>
-          </a:extLst>
-        </p:cNvPr>
-        <p:cNvGrpSpPr/>
-        <p:nvPr/>
-      </p:nvGrpSpPr>
-      <p:grpSpPr>
-        <a:xfrm>
-          <a:off x="0" y="0"/>
-          <a:ext cx="0" cy="0"/>
-          <a:chOff x="0" y="0"/>
-          <a:chExt cx="0" cy="0"/>
-        </a:xfrm>
-      </p:grpSpPr>
-      <p:sp>
-        <p:nvSpPr>
-          <p:cNvPr id="2" name="Shape 0">
-            <a:extLst>
-              <a:ext uri="{FF2B5EF4-FFF2-40B4-BE49-F238E27FC236}">
-                <a16:creationId xmlns:a16="http://schemas.microsoft.com/office/drawing/2014/main" id="{453BF832-C707-02ED-995A-4F56C40DA5E7}"/>
-              </a:ext>
-            </a:extLst>
-          </p:cNvPr>
-          <p:cNvSpPr/>
-          <p:nvPr/>
-        </p:nvSpPr>
-        <p:spPr>
-          <a:xfrm>
-            <a:off x="457200" y="256032"/>
-            <a:ext cx="1645920" cy="256032"/>
-          </a:xfrm>
-          <a:prstGeom prst="rect">
-            <a:avLst/>
-          </a:prstGeom>
-          <a:solidFill>
-            <a:srgbClr val="0D9488"/>
-          </a:solidFill>
-          <a:ln w="12700">
-            <a:solidFill>
-              <a:srgbClr val="0D9488"/>
-            </a:solidFill>
-            <a:prstDash val="solid"/>
-          </a:ln>
-        </p:spPr>
-        <p:txBody>
-          <a:bodyPr/>
-          <a:lstStyle/>
-          <a:p>
-            <a:endParaRPr lang="en-US"/>
-          </a:p>
-        </p:txBody>
-      </p:sp>
-      <p:sp>
-        <p:nvSpPr>
-          <p:cNvPr id="3" name="Text 1">
-            <a:extLst>
-              <a:ext uri="{FF2B5EF4-FFF2-40B4-BE49-F238E27FC236}">
-                <a16:creationId xmlns:a16="http://schemas.microsoft.com/office/drawing/2014/main" id="{0A102B6D-101A-6D16-9C61-4700771DACE8}"/>
-              </a:ext>
-            </a:extLst>
-          </p:cNvPr>
-          <p:cNvSpPr/>
-          <p:nvPr/>
-        </p:nvSpPr>
-        <p:spPr>
-          <a:xfrm>
-            <a:off x="457200" y="256032"/>
-            <a:ext cx="1645920" cy="256032"/>
-          </a:xfrm>
-          <a:prstGeom prst="rect">
-            <a:avLst/>
-          </a:prstGeom>
-          <a:noFill/>
-          <a:ln/>
-        </p:spPr>
-        <p:txBody>
-          <a:bodyPr wrap="square" lIns="0" tIns="0" rIns="0" bIns="0" rtlCol="0" anchor="ctr"/>
-          <a:lstStyle/>
-          <a:p>
-            <a:pPr marL="0" indent="0" algn="ctr">
-              <a:buNone/>
-            </a:pPr>
-            <a:r>
-              <a:rPr lang="en-US" sz="800" b="1" dirty="0">
-                <a:solidFill>
-                  <a:srgbClr val="FFFFFF"/>
-                </a:solidFill>
-              </a:rPr>
-              <a:t>GIT TOOLS</a:t>
-            </a:r>
-            <a:endParaRPr lang="en-US" sz="800" dirty="0"/>
-          </a:p>
-        </p:txBody>
-      </p:sp>
-      <p:sp>
-        <p:nvSpPr>
-          <p:cNvPr id="4" name="Text 2">
-            <a:extLst>
-              <a:ext uri="{FF2B5EF4-FFF2-40B4-BE49-F238E27FC236}">
-                <a16:creationId xmlns:a16="http://schemas.microsoft.com/office/drawing/2014/main" id="{7EABA8D3-0DC9-3DA4-2BF7-AAE9FCA961DB}"/>
-              </a:ext>
-            </a:extLst>
-          </p:cNvPr>
-          <p:cNvSpPr/>
-          <p:nvPr/>
-        </p:nvSpPr>
-        <p:spPr>
-          <a:xfrm>
-            <a:off x="457200" y="594360"/>
-            <a:ext cx="8229600" cy="548640"/>
-          </a:xfrm>
-          <a:prstGeom prst="rect">
-            <a:avLst/>
-          </a:prstGeom>
-          <a:noFill/>
-          <a:ln/>
-        </p:spPr>
-        <p:txBody>
-          <a:bodyPr wrap="square" rtlCol="0" anchor="ctr"/>
-          <a:lstStyle/>
-          <a:p>
-            <a:pPr marL="0" indent="0">
-              <a:buNone/>
-            </a:pPr>
-            <a:r>
-              <a:rPr lang="en-US" sz="2800" b="1" dirty="0">
-                <a:latin typeface="Trebuchet MS" panose="020B0603020202020204" pitchFamily="34" charset="0"/>
-              </a:rPr>
-              <a:t>CLI or GUI tools are available</a:t>
-            </a:r>
-          </a:p>
-        </p:txBody>
-      </p:sp>
-      <p:pic>
-        <p:nvPicPr>
-          <p:cNvPr id="44" name="Picture 43">
-            <a:extLst>
-              <a:ext uri="{FF2B5EF4-FFF2-40B4-BE49-F238E27FC236}">
-                <a16:creationId xmlns:a16="http://schemas.microsoft.com/office/drawing/2014/main" id="{0D7BA612-DDD4-376F-C73C-DED8DCCAC335}"/>
-              </a:ext>
-            </a:extLst>
-          </p:cNvPr>
-          <p:cNvPicPr>
-            <a:picLocks noChangeAspect="1"/>
-          </p:cNvPicPr>
-          <p:nvPr/>
-        </p:nvPicPr>
-        <p:blipFill>
-          <a:blip r:embed="rId3"/>
-          <a:stretch>
-            <a:fillRect/>
-          </a:stretch>
-        </p:blipFill>
-        <p:spPr>
-          <a:xfrm>
-            <a:off x="940172" y="1338790"/>
-            <a:ext cx="2955461" cy="2816981"/>
-          </a:xfrm>
-          <a:prstGeom prst="rect">
-            <a:avLst/>
-          </a:prstGeom>
-          <a:ln>
-            <a:solidFill>
-              <a:srgbClr val="002060"/>
-            </a:solidFill>
-          </a:ln>
-        </p:spPr>
-      </p:pic>
-      <p:pic>
-        <p:nvPicPr>
-          <p:cNvPr id="7" name="Picture 6">
-            <a:extLst>
-              <a:ext uri="{FF2B5EF4-FFF2-40B4-BE49-F238E27FC236}">
-                <a16:creationId xmlns:a16="http://schemas.microsoft.com/office/drawing/2014/main" id="{A6D155BB-BF2F-436B-74E5-1AA052AB2D6D}"/>
-              </a:ext>
-            </a:extLst>
-          </p:cNvPr>
-          <p:cNvPicPr>
-            <a:picLocks noChangeAspect="1"/>
-          </p:cNvPicPr>
-          <p:nvPr/>
-        </p:nvPicPr>
-        <p:blipFill>
-          <a:blip r:embed="rId4"/>
-          <a:stretch>
-            <a:fillRect/>
-          </a:stretch>
-        </p:blipFill>
-        <p:spPr>
-          <a:xfrm>
-            <a:off x="5025938" y="1338790"/>
-            <a:ext cx="3102700" cy="2813223"/>
-          </a:xfrm>
-          <a:prstGeom prst="rect">
-            <a:avLst/>
-          </a:prstGeom>
-          <a:ln>
-            <a:solidFill>
-              <a:srgbClr val="002060"/>
-            </a:solidFill>
-          </a:ln>
-        </p:spPr>
-      </p:pic>
-      <p:sp>
-        <p:nvSpPr>
-          <p:cNvPr id="8" name="TextBox 7">
-            <a:extLst>
-              <a:ext uri="{FF2B5EF4-FFF2-40B4-BE49-F238E27FC236}">
-                <a16:creationId xmlns:a16="http://schemas.microsoft.com/office/drawing/2014/main" id="{C6C2F74B-DE91-0A64-C9BB-3E1490EAF592}"/>
-              </a:ext>
-            </a:extLst>
-          </p:cNvPr>
-          <p:cNvSpPr txBox="1"/>
-          <p:nvPr/>
-        </p:nvSpPr>
-        <p:spPr>
-          <a:xfrm>
-            <a:off x="5793024" y="4278079"/>
-            <a:ext cx="1881051" cy="369332"/>
-          </a:xfrm>
-          <a:prstGeom prst="rect">
-            <a:avLst/>
-          </a:prstGeom>
-          <a:noFill/>
-        </p:spPr>
-        <p:txBody>
-          <a:bodyPr wrap="square" rtlCol="0">
-            <a:spAutoFit/>
-          </a:bodyPr>
-          <a:lstStyle/>
-          <a:p>
-            <a:r>
-              <a:rPr lang="en-US" dirty="0">
-                <a:latin typeface="Trebuchet MS" panose="020B0603020202020204" pitchFamily="34" charset="0"/>
-              </a:rPr>
-              <a:t>GitHub Desktop</a:t>
-            </a:r>
-          </a:p>
-        </p:txBody>
-      </p:sp>
-      <p:sp>
-        <p:nvSpPr>
-          <p:cNvPr id="9" name="TextBox 8">
-            <a:extLst>
-              <a:ext uri="{FF2B5EF4-FFF2-40B4-BE49-F238E27FC236}">
-                <a16:creationId xmlns:a16="http://schemas.microsoft.com/office/drawing/2014/main" id="{777BA7B7-84AE-54CC-15A0-B63869BD0720}"/>
-              </a:ext>
-            </a:extLst>
-          </p:cNvPr>
-          <p:cNvSpPr txBox="1"/>
-          <p:nvPr/>
-        </p:nvSpPr>
-        <p:spPr>
-          <a:xfrm>
-            <a:off x="1325873" y="4278079"/>
-            <a:ext cx="2234096" cy="369332"/>
-          </a:xfrm>
-          <a:prstGeom prst="rect">
-            <a:avLst/>
-          </a:prstGeom>
-          <a:noFill/>
-        </p:spPr>
-        <p:txBody>
-          <a:bodyPr wrap="square" rtlCol="0">
-            <a:spAutoFit/>
-          </a:bodyPr>
-          <a:lstStyle/>
-          <a:p>
-            <a:r>
-              <a:rPr lang="en-US" dirty="0">
-                <a:latin typeface="Trebuchet MS" panose="020B0603020202020204" pitchFamily="34" charset="0"/>
-              </a:rPr>
-              <a:t>PowerShell, Bash</a:t>
-            </a:r>
-          </a:p>
-        </p:txBody>
-      </p:sp>
-    </p:spTree>
-    <p:extLst>
-      <p:ext uri="{BB962C8B-B14F-4D97-AF65-F5344CB8AC3E}">
-        <p14:creationId xmlns:p14="http://schemas.microsoft.com/office/powerpoint/2010/main" val="446247213"/>
-      </p:ext>
-    </p:extLst>
   </p:cSld>
   <p:clrMapOvr>
     <a:masterClrMapping/>

</xml_diff>